<commit_message>
Refine editable deck for figure-led presentation
</commit_message>
<xml_diff>
--- a/docs/presentation_2026/urban_heat_transfer_presentation.pptx
+++ b/docs/presentation_2026/urban_heat_transfer_presentation.pptx
@@ -11,6 +11,7 @@
     <p:sldId id="259" r:id="rId10"/>
     <p:sldId id="260" r:id="rId11"/>
     <p:sldId id="261" r:id="rId12"/>
+    <p:sldId id="262" r:id="rId13"/>
   </p:sldIdLst>
   <p:sldSz cx="12191695" cy="6858000" type="screen4x3"/>
   <p:notesSz cx="6858000" cy="9144000"/>
@@ -3109,8 +3110,8 @@
         </p:nvSpPr>
         <p:spPr>
           <a:xfrm>
-            <a:off x="5867253" y="-914400"/>
-            <a:ext cx="4724281" cy="5943600"/>
+            <a:off x="9067573" y="-609600"/>
+            <a:ext cx="2438339" cy="2438400"/>
           </a:xfrm>
           <a:prstGeom prst="ellipse">
             <a:avLst/>
@@ -3152,8 +3153,8 @@
         </p:nvSpPr>
         <p:spPr>
           <a:xfrm>
-            <a:off x="8838979" y="-304800"/>
-            <a:ext cx="3200319" cy="3810000"/>
+            <a:off x="9677158" y="4267200"/>
+            <a:ext cx="1752556" cy="1752599"/>
           </a:xfrm>
           <a:prstGeom prst="ellipse">
             <a:avLst/>
@@ -3189,57 +3190,14 @@
       </p:sp>
       <p:sp>
         <p:nvSpPr>
-          <p:cNvPr id="4" name="Oval 3"/>
+          <p:cNvPr id="4" name="Rounded Rectangle 3"/>
           <p:cNvSpPr/>
           <p:nvPr/>
         </p:nvSpPr>
         <p:spPr>
           <a:xfrm>
-            <a:off x="-152396" y="4876800"/>
-            <a:ext cx="3962300" cy="2895600"/>
-          </a:xfrm>
-          <a:prstGeom prst="ellipse">
-            <a:avLst/>
-          </a:prstGeom>
-          <a:solidFill>
-            <a:srgbClr val="EBE0CF"/>
-          </a:solidFill>
-          <a:ln>
-            <a:noFill/>
-          </a:ln>
-        </p:spPr>
-        <p:style>
-          <a:lnRef idx="1">
-            <a:schemeClr val="accent1"/>
-          </a:lnRef>
-          <a:fillRef idx="3">
-            <a:schemeClr val="accent1"/>
-          </a:fillRef>
-          <a:effectRef idx="2">
-            <a:schemeClr val="accent1"/>
-          </a:effectRef>
-          <a:fontRef idx="minor">
-            <a:schemeClr val="lt1"/>
-          </a:fontRef>
-        </p:style>
-        <p:txBody>
-          <a:bodyPr rtlCol="0" anchor="ctr"/>
-          <a:lstStyle/>
-          <a:p>
-            <a:pPr algn="ctr"/>
-          </a:p>
-        </p:txBody>
-      </p:sp>
-      <p:sp>
-        <p:nvSpPr>
-          <p:cNvPr id="5" name="Rounded Rectangle 4"/>
-          <p:cNvSpPr/>
-          <p:nvPr/>
-        </p:nvSpPr>
-        <p:spPr>
-          <a:xfrm>
-            <a:off x="472428" y="441960"/>
-            <a:ext cx="2956486" cy="487680"/>
+            <a:off x="548626" y="655320"/>
+            <a:ext cx="2224984" cy="411479"/>
           </a:xfrm>
           <a:prstGeom prst="roundRect">
             <a:avLst/>
@@ -3275,14 +3233,14 @@
       </p:sp>
       <p:sp>
         <p:nvSpPr>
-          <p:cNvPr id="6" name="TextBox 5"/>
+          <p:cNvPr id="5" name="TextBox 4"/>
           <p:cNvSpPr txBox="1"/>
           <p:nvPr/>
         </p:nvSpPr>
         <p:spPr>
           <a:xfrm>
-            <a:off x="701022" y="502920"/>
-            <a:ext cx="2514537" cy="365760"/>
+            <a:off x="731501" y="723900"/>
+            <a:ext cx="1828754" cy="259080"/>
           </a:xfrm>
           <a:prstGeom prst="rect">
             <a:avLst/>
@@ -3290,14 +3248,14 @@
           <a:noFill/>
         </p:spPr>
         <p:txBody>
-          <a:bodyPr wrap="square" lIns="25400" rIns="25400" tIns="25400" bIns="25400" anchor="t">
+          <a:bodyPr wrap="square" lIns="63500" rIns="63500" tIns="63500" bIns="63500" anchor="t">
             <a:spAutoFit/>
           </a:bodyPr>
           <a:lstStyle/>
           <a:p>
             <a:pPr algn="l"/>
             <a:r>
-              <a:rPr sz="2200" b="1">
+              <a:rPr sz="1800" b="1">
                 <a:solidFill>
                   <a:srgbClr val="FFFDFA"/>
                 </a:solidFill>
@@ -3310,14 +3268,61 @@
       </p:sp>
       <p:sp>
         <p:nvSpPr>
+          <p:cNvPr id="6" name="TextBox 5"/>
+          <p:cNvSpPr txBox="1"/>
+          <p:nvPr/>
+        </p:nvSpPr>
+        <p:spPr>
+          <a:xfrm>
+            <a:off x="563865" y="1432560"/>
+            <a:ext cx="5943451" cy="1295399"/>
+          </a:xfrm>
+          <a:prstGeom prst="rect">
+            <a:avLst/>
+          </a:prstGeom>
+          <a:noFill/>
+        </p:spPr>
+        <p:txBody>
+          <a:bodyPr wrap="square" lIns="63500" rIns="63500" tIns="63500" bIns="63500" anchor="t">
+            <a:normAutofit/>
+          </a:bodyPr>
+          <a:lstStyle/>
+          <a:p>
+            <a:pPr algn="l"/>
+            <a:r>
+              <a:rPr sz="2900" b="1">
+                <a:solidFill>
+                  <a:srgbClr val="1E2A2F"/>
+                </a:solidFill>
+                <a:latin typeface="Arial"/>
+              </a:rPr>
+              <a:t>Cross-City Urban Heat</a:t>
+            </a:r>
+          </a:p>
+          <a:p>
+            <a:pPr algn="l"/>
+            <a:r>
+              <a:rPr sz="2900" b="1">
+                <a:solidFill>
+                  <a:srgbClr val="1E2A2F"/>
+                </a:solidFill>
+                <a:latin typeface="Arial"/>
+              </a:rPr>
+              <a:t>Hotspot Prediction</a:t>
+            </a:r>
+          </a:p>
+        </p:txBody>
+      </p:sp>
+      <p:sp>
+        <p:nvSpPr>
           <p:cNvPr id="7" name="TextBox 6"/>
           <p:cNvSpPr txBox="1"/>
           <p:nvPr/>
         </p:nvSpPr>
         <p:spPr>
           <a:xfrm>
-            <a:off x="441948" y="1051560"/>
-            <a:ext cx="6857828" cy="1905000"/>
+            <a:off x="594345" y="2910840"/>
+            <a:ext cx="4267093" cy="426720"/>
           </a:xfrm>
           <a:prstGeom prst="rect">
             <a:avLst/>
@@ -3325,105 +3330,104 @@
           <a:noFill/>
         </p:spPr>
         <p:txBody>
-          <a:bodyPr wrap="square" lIns="25400" rIns="25400" tIns="25400" bIns="25400" anchor="t">
-            <a:spAutoFit/>
+          <a:bodyPr wrap="square" lIns="63500" rIns="63500" tIns="63500" bIns="63500" anchor="t">
+            <a:normAutofit/>
           </a:bodyPr>
           <a:lstStyle/>
           <a:p>
             <a:pPr algn="l"/>
             <a:r>
-              <a:rPr sz="4000" b="1">
-                <a:solidFill>
-                  <a:srgbClr val="1E2A2F"/>
+              <a:rPr sz="1800" b="0">
+                <a:solidFill>
+                  <a:srgbClr val="5C696D"/>
                 </a:solidFill>
                 <a:latin typeface="Arial"/>
               </a:rPr>
-              <a:t>30 cities | 71.4M cells</a:t>
-            </a:r>
-          </a:p>
+              <a:t>30 cities | 71.4M cells | unseen-city hotspot screening</a:t>
+            </a:r>
+          </a:p>
+        </p:txBody>
+      </p:sp>
+      <p:sp>
+        <p:nvSpPr>
+          <p:cNvPr id="8" name="TextBox 7"/>
+          <p:cNvSpPr txBox="1"/>
+          <p:nvPr/>
+        </p:nvSpPr>
+        <p:spPr>
+          <a:xfrm>
+            <a:off x="594345" y="4267200"/>
+            <a:ext cx="4267093" cy="472439"/>
+          </a:xfrm>
+          <a:prstGeom prst="rect">
+            <a:avLst/>
+          </a:prstGeom>
+          <a:noFill/>
+        </p:spPr>
+        <p:txBody>
+          <a:bodyPr wrap="square" lIns="63500" rIns="63500" tIns="63500" bIns="63500" anchor="t">
+            <a:normAutofit/>
+          </a:bodyPr>
+          <a:lstStyle/>
           <a:p>
             <a:pPr algn="l"/>
             <a:r>
-              <a:rPr sz="4000" b="1">
-                <a:solidFill>
-                  <a:srgbClr val="1E2A2F"/>
+              <a:rPr sz="2300" b="1">
+                <a:solidFill>
+                  <a:srgbClr val="254D5A"/>
                 </a:solidFill>
                 <a:latin typeface="Arial"/>
               </a:rPr>
-              <a:t>| hotspot screening on</a:t>
-            </a:r>
-          </a:p>
+              <a:t>Max Clements | Nicholas Machado</a:t>
+            </a:r>
+          </a:p>
+        </p:txBody>
+      </p:sp>
+      <p:sp>
+        <p:nvSpPr>
+          <p:cNvPr id="9" name="TextBox 8"/>
+          <p:cNvSpPr txBox="1"/>
+          <p:nvPr/>
+        </p:nvSpPr>
+        <p:spPr>
+          <a:xfrm>
+            <a:off x="594345" y="4876800"/>
+            <a:ext cx="4724281" cy="350520"/>
+          </a:xfrm>
+          <a:prstGeom prst="rect">
+            <a:avLst/>
+          </a:prstGeom>
+          <a:noFill/>
+        </p:spPr>
+        <p:txBody>
+          <a:bodyPr wrap="square" lIns="63500" rIns="63500" tIns="63500" bIns="63500" anchor="t">
+            <a:normAutofit/>
+          </a:bodyPr>
+          <a:lstStyle/>
           <a:p>
             <a:pPr algn="l"/>
             <a:r>
-              <a:rPr sz="4000" b="1">
-                <a:solidFill>
-                  <a:srgbClr val="1E2A2F"/>
+              <a:rPr sz="1600" b="0">
+                <a:solidFill>
+                  <a:srgbClr val="5C696D"/>
                 </a:solidFill>
                 <a:latin typeface="Arial"/>
               </a:rPr>
-              <a:t>unseen cities</a:t>
-            </a:r>
-          </a:p>
-        </p:txBody>
-      </p:sp>
-      <p:sp>
-        <p:nvSpPr>
-          <p:cNvPr id="8" name="TextBox 7"/>
-          <p:cNvSpPr txBox="1"/>
-          <p:nvPr/>
-        </p:nvSpPr>
-        <p:spPr>
-          <a:xfrm>
-            <a:off x="502907" y="3810000"/>
-            <a:ext cx="6553036" cy="655320"/>
-          </a:xfrm>
-          <a:prstGeom prst="rect">
-            <a:avLst/>
-          </a:prstGeom>
-          <a:noFill/>
-        </p:spPr>
-        <p:txBody>
-          <a:bodyPr wrap="square" lIns="25400" rIns="25400" tIns="25400" bIns="25400" anchor="t">
-            <a:spAutoFit/>
-          </a:bodyPr>
-          <a:lstStyle/>
-          <a:p>
-            <a:pPr algn="l"/>
-            <a:r>
-              <a:rPr sz="2500" b="0">
-                <a:solidFill>
-                  <a:srgbClr val="5C696D"/>
-                </a:solidFill>
-                <a:latin typeface="Arial"/>
-              </a:rPr>
-              <a:t>A presentation-first view of the urban heat</a:t>
-            </a:r>
-          </a:p>
-          <a:p>
-            <a:pPr algn="l"/>
-            <a:r>
-              <a:rPr sz="2500" b="0">
-                <a:solidFill>
-                  <a:srgbClr val="5C696D"/>
-                </a:solidFill>
-                <a:latin typeface="Arial"/>
-              </a:rPr>
-              <a:t>transfer benchmark.</a:t>
-            </a:r>
-          </a:p>
-        </p:txBody>
-      </p:sp>
-      <p:sp>
-        <p:nvSpPr>
-          <p:cNvPr id="9" name="Rounded Rectangle 8"/>
+              <a:t>STAT 5630 Final Project | April 2026</a:t>
+            </a:r>
+          </a:p>
+        </p:txBody>
+      </p:sp>
+      <p:sp>
+        <p:nvSpPr>
+          <p:cNvPr id="10" name="Rounded Rectangle 9"/>
           <p:cNvSpPr/>
           <p:nvPr/>
         </p:nvSpPr>
         <p:spPr>
           <a:xfrm>
-            <a:off x="7696007" y="838200"/>
-            <a:ext cx="3962300" cy="4572000"/>
+            <a:off x="7939841" y="1508760"/>
+            <a:ext cx="2499297" cy="2712720"/>
           </a:xfrm>
           <a:prstGeom prst="roundRect">
             <a:avLst/>
@@ -3431,8 +3435,10 @@
           <a:solidFill>
             <a:srgbClr val="FFF8EF"/>
           </a:solidFill>
-          <a:ln>
-            <a:noFill/>
+          <a:ln w="12700">
+            <a:solidFill>
+              <a:srgbClr val="DBC7AA"/>
+            </a:solidFill>
           </a:ln>
         </p:spPr>
         <p:style>
@@ -3459,16 +3465,16 @@
       </p:sp>
       <p:sp>
         <p:nvSpPr>
-          <p:cNvPr id="10" name="Rounded Rectangle 9"/>
+          <p:cNvPr id="11" name="Oval 10"/>
           <p:cNvSpPr/>
           <p:nvPr/>
         </p:nvSpPr>
         <p:spPr>
           <a:xfrm>
-            <a:off x="7985560" y="1188720"/>
-            <a:ext cx="3383195" cy="594360"/>
-          </a:xfrm>
-          <a:prstGeom prst="roundRect">
+            <a:off x="8457988" y="2057400"/>
+            <a:ext cx="655303" cy="655320"/>
+          </a:xfrm>
+          <a:prstGeom prst="ellipse">
             <a:avLst/>
           </a:prstGeom>
           <a:solidFill>
@@ -3502,49 +3508,57 @@
       </p:sp>
       <p:sp>
         <p:nvSpPr>
-          <p:cNvPr id="11" name="TextBox 10"/>
-          <p:cNvSpPr txBox="1"/>
-          <p:nvPr/>
-        </p:nvSpPr>
-        <p:spPr>
-          <a:xfrm>
-            <a:off x="8137956" y="1310640"/>
-            <a:ext cx="3139361" cy="320040"/>
-          </a:xfrm>
-          <a:prstGeom prst="rect">
-            <a:avLst/>
-          </a:prstGeom>
-          <a:noFill/>
-        </p:spPr>
-        <p:txBody>
-          <a:bodyPr wrap="square" lIns="25400" rIns="25400" tIns="25400" bIns="25400" anchor="t">
-            <a:spAutoFit/>
-          </a:bodyPr>
-          <a:lstStyle/>
-          <a:p>
-            <a:pPr algn="ctr"/>
-            <a:r>
-              <a:rPr sz="2300" b="1">
-                <a:solidFill>
-                  <a:srgbClr val="FFFDFA"/>
-                </a:solidFill>
-                <a:latin typeface="Arial"/>
-              </a:rPr>
-              <a:t>What the talk shows</a:t>
-            </a:r>
-          </a:p>
-        </p:txBody>
-      </p:sp>
-      <p:sp>
-        <p:nvSpPr>
           <p:cNvPr id="12" name="Oval 11"/>
           <p:cNvSpPr/>
           <p:nvPr/>
         </p:nvSpPr>
         <p:spPr>
           <a:xfrm>
-            <a:off x="8153196" y="2240280"/>
-            <a:ext cx="137156" cy="137160"/>
+            <a:off x="9433324" y="1676400"/>
+            <a:ext cx="655303" cy="655320"/>
+          </a:xfrm>
+          <a:prstGeom prst="ellipse">
+            <a:avLst/>
+          </a:prstGeom>
+          <a:solidFill>
+            <a:srgbClr val="8AA07A"/>
+          </a:solidFill>
+          <a:ln>
+            <a:noFill/>
+          </a:ln>
+        </p:spPr>
+        <p:style>
+          <a:lnRef idx="1">
+            <a:schemeClr val="accent1"/>
+          </a:lnRef>
+          <a:fillRef idx="3">
+            <a:schemeClr val="accent1"/>
+          </a:fillRef>
+          <a:effectRef idx="2">
+            <a:schemeClr val="accent1"/>
+          </a:effectRef>
+          <a:fontRef idx="minor">
+            <a:schemeClr val="lt1"/>
+          </a:fontRef>
+        </p:style>
+        <p:txBody>
+          <a:bodyPr rtlCol="0" anchor="ctr"/>
+          <a:lstStyle/>
+          <a:p>
+            <a:pPr algn="ctr"/>
+          </a:p>
+        </p:txBody>
+      </p:sp>
+      <p:sp>
+        <p:nvSpPr>
+          <p:cNvPr id="13" name="Oval 12"/>
+          <p:cNvSpPr/>
+          <p:nvPr/>
+        </p:nvSpPr>
+        <p:spPr>
+          <a:xfrm>
+            <a:off x="9433324" y="2910840"/>
+            <a:ext cx="655303" cy="655320"/>
           </a:xfrm>
           <a:prstGeom prst="ellipse">
             <a:avLst/>
@@ -3580,79 +3594,20 @@
       </p:sp>
       <p:sp>
         <p:nvSpPr>
-          <p:cNvPr id="13" name="TextBox 12"/>
-          <p:cNvSpPr txBox="1"/>
-          <p:nvPr/>
-        </p:nvSpPr>
-        <p:spPr>
-          <a:xfrm>
-            <a:off x="8534186" y="2133600"/>
-            <a:ext cx="2362140" cy="838200"/>
-          </a:xfrm>
-          <a:prstGeom prst="rect">
-            <a:avLst/>
-          </a:prstGeom>
-          <a:noFill/>
-        </p:spPr>
-        <p:txBody>
-          <a:bodyPr wrap="square" lIns="25400" rIns="25400" tIns="25400" bIns="25400" anchor="t">
-            <a:spAutoFit/>
-          </a:bodyPr>
-          <a:lstStyle/>
-          <a:p>
-            <a:pPr algn="l"/>
-            <a:r>
-              <a:rPr sz="2400" b="1">
-                <a:solidFill>
-                  <a:srgbClr val="1E2A2F"/>
-                </a:solidFill>
-                <a:latin typeface="Arial"/>
-              </a:rPr>
-              <a:t>why cross-city</a:t>
-            </a:r>
-          </a:p>
-          <a:p>
-            <a:pPr algn="l"/>
-            <a:r>
-              <a:rPr sz="2400" b="1">
-                <a:solidFill>
-                  <a:srgbClr val="1E2A2F"/>
-                </a:solidFill>
-                <a:latin typeface="Arial"/>
-              </a:rPr>
-              <a:t>transfer is the real</a:t>
-            </a:r>
-          </a:p>
-          <a:p>
-            <a:pPr algn="l"/>
-            <a:r>
-              <a:rPr sz="2400" b="1">
-                <a:solidFill>
-                  <a:srgbClr val="1E2A2F"/>
-                </a:solidFill>
-                <a:latin typeface="Arial"/>
-              </a:rPr>
-              <a:t>test</a:t>
-            </a:r>
-          </a:p>
-        </p:txBody>
-      </p:sp>
-      <p:sp>
-        <p:nvSpPr>
-          <p:cNvPr id="14" name="Oval 13"/>
+          <p:cNvPr id="14" name="Chevron 13"/>
           <p:cNvSpPr/>
           <p:nvPr/>
         </p:nvSpPr>
         <p:spPr>
           <a:xfrm>
-            <a:off x="8153196" y="3108960"/>
-            <a:ext cx="137156" cy="137160"/>
-          </a:xfrm>
-          <a:prstGeom prst="ellipse">
+            <a:off x="9052333" y="2286000"/>
+            <a:ext cx="335271" cy="350520"/>
+          </a:xfrm>
+          <a:prstGeom prst="chevron">
             <a:avLst/>
           </a:prstGeom>
           <a:solidFill>
-            <a:srgbClr val="D26B34"/>
+            <a:srgbClr val="254D5A"/>
           </a:solidFill>
           <a:ln>
             <a:noFill/>
@@ -3682,79 +3637,20 @@
       </p:sp>
       <p:sp>
         <p:nvSpPr>
-          <p:cNvPr id="15" name="TextBox 14"/>
-          <p:cNvSpPr txBox="1"/>
-          <p:nvPr/>
-        </p:nvSpPr>
-        <p:spPr>
-          <a:xfrm>
-            <a:off x="8534186" y="3002280"/>
-            <a:ext cx="2362140" cy="838200"/>
-          </a:xfrm>
-          <a:prstGeom prst="rect">
-            <a:avLst/>
-          </a:prstGeom>
-          <a:noFill/>
-        </p:spPr>
-        <p:txBody>
-          <a:bodyPr wrap="square" lIns="25400" rIns="25400" tIns="25400" bIns="25400" anchor="t">
-            <a:spAutoFit/>
-          </a:bodyPr>
-          <a:lstStyle/>
-          <a:p>
-            <a:pPr algn="l"/>
-            <a:r>
-              <a:rPr sz="2400" b="1">
-                <a:solidFill>
-                  <a:srgbClr val="1E2A2F"/>
-                </a:solidFill>
-                <a:latin typeface="Arial"/>
-              </a:rPr>
-              <a:t>how 30-city</a:t>
-            </a:r>
-          </a:p>
-          <a:p>
-            <a:pPr algn="l"/>
-            <a:r>
-              <a:rPr sz="2400" b="1">
-                <a:solidFill>
-                  <a:srgbClr val="1E2A2F"/>
-                </a:solidFill>
-                <a:latin typeface="Arial"/>
-              </a:rPr>
-              <a:t>evaluation stays</a:t>
-            </a:r>
-          </a:p>
-          <a:p>
-            <a:pPr algn="l"/>
-            <a:r>
-              <a:rPr sz="2400" b="1">
-                <a:solidFill>
-                  <a:srgbClr val="1E2A2F"/>
-                </a:solidFill>
-                <a:latin typeface="Arial"/>
-              </a:rPr>
-              <a:t>leakage-safe</a:t>
-            </a:r>
-          </a:p>
-        </p:txBody>
-      </p:sp>
-      <p:sp>
-        <p:nvSpPr>
-          <p:cNvPr id="16" name="Oval 15"/>
+          <p:cNvPr id="15" name="Chevron 14"/>
           <p:cNvSpPr/>
           <p:nvPr/>
         </p:nvSpPr>
         <p:spPr>
           <a:xfrm>
-            <a:off x="8153196" y="3977639"/>
-            <a:ext cx="137156" cy="137160"/>
-          </a:xfrm>
-          <a:prstGeom prst="ellipse">
+            <a:off x="9753356" y="2606040"/>
+            <a:ext cx="335271" cy="350520"/>
+          </a:xfrm>
+          <a:prstGeom prst="chevron">
             <a:avLst/>
           </a:prstGeom>
           <a:solidFill>
-            <a:srgbClr val="D26B34"/>
+            <a:srgbClr val="9A402D"/>
           </a:solidFill>
           <a:ln>
             <a:noFill/>
@@ -3784,14 +3680,14 @@
       </p:sp>
       <p:sp>
         <p:nvSpPr>
-          <p:cNvPr id="17" name="TextBox 16"/>
+          <p:cNvPr id="16" name="TextBox 15"/>
           <p:cNvSpPr txBox="1"/>
           <p:nvPr/>
         </p:nvSpPr>
         <p:spPr>
           <a:xfrm>
-            <a:off x="8534186" y="3870960"/>
-            <a:ext cx="2362140" cy="838200"/>
+            <a:off x="8305592" y="3581400"/>
+            <a:ext cx="1798275" cy="335280"/>
           </a:xfrm>
           <a:prstGeom prst="rect">
             <a:avLst/>
@@ -3799,134 +3695,20 @@
           <a:noFill/>
         </p:spPr>
         <p:txBody>
-          <a:bodyPr wrap="square" lIns="25400" rIns="25400" tIns="25400" bIns="25400" anchor="t">
-            <a:spAutoFit/>
+          <a:bodyPr wrap="square" lIns="63500" rIns="63500" tIns="63500" bIns="63500" anchor="t">
+            <a:normAutofit/>
           </a:bodyPr>
           <a:lstStyle/>
           <a:p>
-            <a:pPr algn="l"/>
-            <a:r>
-              <a:rPr sz="2400" b="1">
-                <a:solidFill>
-                  <a:srgbClr val="1E2A2F"/>
+            <a:pPr algn="ctr"/>
+            <a:r>
+              <a:rPr sz="1500" b="1">
+                <a:solidFill>
+                  <a:srgbClr val="5C696D"/>
                 </a:solidFill>
                 <a:latin typeface="Arial"/>
               </a:rPr>
-              <a:t>where RF helps</a:t>
-            </a:r>
-          </a:p>
-          <a:p>
-            <a:pPr algn="l"/>
-            <a:r>
-              <a:rPr sz="2400" b="1">
-                <a:solidFill>
-                  <a:srgbClr val="1E2A2F"/>
-                </a:solidFill>
-                <a:latin typeface="Arial"/>
-              </a:rPr>
-              <a:t>and where</a:t>
-            </a:r>
-          </a:p>
-          <a:p>
-            <a:pPr algn="l"/>
-            <a:r>
-              <a:rPr sz="2400" b="1">
-                <a:solidFill>
-                  <a:srgbClr val="1E2A2F"/>
-                </a:solidFill>
-                <a:latin typeface="Arial"/>
-              </a:rPr>
-              <a:t>uncertainty</a:t>
-            </a:r>
-          </a:p>
-          <a:p>
-            <a:pPr algn="l"/>
-            <a:r>
-              <a:rPr sz="2400" b="1">
-                <a:solidFill>
-                  <a:srgbClr val="1E2A2F"/>
-                </a:solidFill>
-                <a:latin typeface="Arial"/>
-              </a:rPr>
-              <a:t>remains</a:t>
-            </a:r>
-          </a:p>
-        </p:txBody>
-      </p:sp>
-      <p:sp>
-        <p:nvSpPr>
-          <p:cNvPr id="18" name="Rounded Rectangle 17"/>
-          <p:cNvSpPr/>
-          <p:nvPr/>
-        </p:nvSpPr>
-        <p:spPr>
-          <a:xfrm>
-            <a:off x="472428" y="6050280"/>
-            <a:ext cx="11185880" cy="533400"/>
-          </a:xfrm>
-          <a:prstGeom prst="roundRect">
-            <a:avLst/>
-          </a:prstGeom>
-          <a:solidFill>
-            <a:srgbClr val="EBE0CF"/>
-          </a:solidFill>
-          <a:ln>
-            <a:noFill/>
-          </a:ln>
-        </p:spPr>
-        <p:style>
-          <a:lnRef idx="1">
-            <a:schemeClr val="accent1"/>
-          </a:lnRef>
-          <a:fillRef idx="3">
-            <a:schemeClr val="accent1"/>
-          </a:fillRef>
-          <a:effectRef idx="2">
-            <a:schemeClr val="accent1"/>
-          </a:effectRef>
-          <a:fontRef idx="minor">
-            <a:schemeClr val="lt1"/>
-          </a:fontRef>
-        </p:style>
-        <p:txBody>
-          <a:bodyPr rtlCol="0" anchor="ctr"/>
-          <a:lstStyle/>
-          <a:p>
-            <a:pPr algn="ctr"/>
-          </a:p>
-        </p:txBody>
-      </p:sp>
-      <p:sp>
-        <p:nvSpPr>
-          <p:cNvPr id="19" name="TextBox 18"/>
-          <p:cNvSpPr txBox="1"/>
-          <p:nvPr/>
-        </p:nvSpPr>
-        <p:spPr>
-          <a:xfrm>
-            <a:off x="701022" y="6187440"/>
-            <a:ext cx="9753356" cy="243840"/>
-          </a:xfrm>
-          <a:prstGeom prst="rect">
-            <a:avLst/>
-          </a:prstGeom>
-          <a:noFill/>
-        </p:spPr>
-        <p:txBody>
-          <a:bodyPr wrap="square" lIns="25400" rIns="25400" tIns="25400" bIns="25400" anchor="t">
-            <a:spAutoFit/>
-          </a:bodyPr>
-          <a:lstStyle/>
-          <a:p>
-            <a:pPr algn="l"/>
-            <a:r>
-              <a:rPr sz="2000" b="0">
-                <a:solidFill>
-                  <a:srgbClr val="254D5A"/>
-                </a:solidFill>
-                <a:latin typeface="Arial"/>
-              </a:rPr>
-              <a:t>Max Clements   |   STAT 5630 Final Project   |   April 2026</a:t>
+              <a:t>seen cities -&gt; unseen city</a:t>
             </a:r>
           </a:p>
         </p:txBody>
@@ -3965,8 +3747,8 @@
         </p:nvSpPr>
         <p:spPr>
           <a:xfrm>
-            <a:off x="7924601" y="-304800"/>
-            <a:ext cx="3809904" cy="2438400"/>
+            <a:off x="9600959" y="-457200"/>
+            <a:ext cx="1981150" cy="1828800"/>
           </a:xfrm>
           <a:prstGeom prst="ellipse">
             <a:avLst/>
@@ -4002,23 +3784,60 @@
       </p:sp>
       <p:sp>
         <p:nvSpPr>
-          <p:cNvPr id="3" name="Oval 2"/>
+          <p:cNvPr id="3" name="TextBox 2"/>
+          <p:cNvSpPr txBox="1"/>
+          <p:nvPr/>
+        </p:nvSpPr>
+        <p:spPr>
+          <a:xfrm>
+            <a:off x="457188" y="289560"/>
+            <a:ext cx="2514537" cy="259080"/>
+          </a:xfrm>
+          <a:prstGeom prst="rect">
+            <a:avLst/>
+          </a:prstGeom>
+          <a:noFill/>
+        </p:spPr>
+        <p:txBody>
+          <a:bodyPr wrap="square" lIns="63500" rIns="63500" tIns="63500" bIns="63500" anchor="t">
+            <a:spAutoFit/>
+          </a:bodyPr>
+          <a:lstStyle/>
+          <a:p>
+            <a:pPr algn="l"/>
+            <a:r>
+              <a:rPr sz="1800" b="1">
+                <a:solidFill>
+                  <a:srgbClr val="254D5A"/>
+                </a:solidFill>
+                <a:latin typeface="Arial"/>
+              </a:rPr>
+              <a:t>Why transfer matters</a:t>
+            </a:r>
+          </a:p>
+        </p:txBody>
+      </p:sp>
+      <p:sp>
+        <p:nvSpPr>
+          <p:cNvPr id="4" name="Rounded Rectangle 3"/>
           <p:cNvSpPr/>
           <p:nvPr/>
         </p:nvSpPr>
         <p:spPr>
           <a:xfrm>
-            <a:off x="-304792" y="5029200"/>
-            <a:ext cx="3200319" cy="2286000"/>
-          </a:xfrm>
-          <a:prstGeom prst="ellipse">
+            <a:off x="396230" y="670560"/>
+            <a:ext cx="11399235" cy="3749039"/>
+          </a:xfrm>
+          <a:prstGeom prst="roundRect">
             <a:avLst/>
           </a:prstGeom>
           <a:solidFill>
-            <a:srgbClr val="3A7182"/>
+            <a:srgbClr val="FFFDFA"/>
           </a:solidFill>
-          <a:ln>
-            <a:noFill/>
+          <a:ln w="17780">
+            <a:solidFill>
+              <a:srgbClr val="DBC7AA"/>
+            </a:solidFill>
           </a:ln>
         </p:spPr>
         <p:style>
@@ -4043,430 +3862,40 @@
           </a:p>
         </p:txBody>
       </p:sp>
-      <p:sp>
-        <p:nvSpPr>
-          <p:cNvPr id="4" name="Rounded Rectangle 3"/>
+      <p:pic>
+        <p:nvPicPr>
+          <p:cNvPr id="5" name="Picture 4" descr="transfer_problem_schematic.png"/>
+          <p:cNvPicPr>
+            <a:picLocks noChangeAspect="1"/>
+          </p:cNvPicPr>
+          <p:nvPr/>
+        </p:nvPicPr>
+        <p:blipFill>
+          <a:blip r:embed="rId2"/>
+          <a:stretch>
+            <a:fillRect/>
+          </a:stretch>
+        </p:blipFill>
+        <p:spPr>
+          <a:xfrm>
+            <a:off x="640063" y="883920"/>
+            <a:ext cx="10896327" cy="3337560"/>
+          </a:xfrm>
+          <a:prstGeom prst="rect">
+            <a:avLst/>
+          </a:prstGeom>
+        </p:spPr>
+      </p:pic>
+      <p:sp>
+        <p:nvSpPr>
+          <p:cNvPr id="6" name="Rounded Rectangle 5"/>
           <p:cNvSpPr/>
           <p:nvPr/>
         </p:nvSpPr>
         <p:spPr>
           <a:xfrm>
-            <a:off x="411469" y="411479"/>
-            <a:ext cx="3398435" cy="1158240"/>
-          </a:xfrm>
-          <a:prstGeom prst="roundRect">
-            <a:avLst/>
-          </a:prstGeom>
-          <a:solidFill>
-            <a:srgbClr val="FFFAF2"/>
-          </a:solidFill>
-          <a:ln w="12700">
-            <a:solidFill>
-              <a:srgbClr val="DBC7AA"/>
-            </a:solidFill>
-          </a:ln>
-        </p:spPr>
-        <p:style>
-          <a:lnRef idx="1">
-            <a:schemeClr val="accent1"/>
-          </a:lnRef>
-          <a:fillRef idx="3">
-            <a:schemeClr val="accent1"/>
-          </a:fillRef>
-          <a:effectRef idx="2">
-            <a:schemeClr val="accent1"/>
-          </a:effectRef>
-          <a:fontRef idx="minor">
-            <a:schemeClr val="lt1"/>
-          </a:fontRef>
-        </p:style>
-        <p:txBody>
-          <a:bodyPr rtlCol="0" anchor="ctr"/>
-          <a:lstStyle/>
-          <a:p>
-            <a:pPr algn="ctr"/>
-          </a:p>
-        </p:txBody>
-      </p:sp>
-      <p:sp>
-        <p:nvSpPr>
-          <p:cNvPr id="5" name="TextBox 4"/>
-          <p:cNvSpPr txBox="1"/>
-          <p:nvPr/>
-        </p:nvSpPr>
-        <p:spPr>
-          <a:xfrm>
-            <a:off x="624824" y="609600"/>
-            <a:ext cx="2986965" cy="259080"/>
-          </a:xfrm>
-          <a:prstGeom prst="rect">
-            <a:avLst/>
-          </a:prstGeom>
-          <a:noFill/>
-        </p:spPr>
-        <p:txBody>
-          <a:bodyPr wrap="square" lIns="25400" rIns="25400" tIns="25400" bIns="25400" anchor="t">
-            <a:spAutoFit/>
-          </a:bodyPr>
-          <a:lstStyle/>
-          <a:p>
-            <a:pPr algn="l"/>
-            <a:r>
-              <a:rPr sz="2400" b="1">
-                <a:solidFill>
-                  <a:srgbClr val="1E2A2F"/>
-                </a:solidFill>
-                <a:latin typeface="Arial"/>
-              </a:rPr>
-              <a:t>Heat risk matters</a:t>
-            </a:r>
-          </a:p>
-        </p:txBody>
-      </p:sp>
-      <p:sp>
-        <p:nvSpPr>
-          <p:cNvPr id="6" name="TextBox 5"/>
-          <p:cNvSpPr txBox="1"/>
-          <p:nvPr/>
-        </p:nvSpPr>
-        <p:spPr>
-          <a:xfrm>
-            <a:off x="624824" y="960120"/>
-            <a:ext cx="2956486" cy="457200"/>
-          </a:xfrm>
-          <a:prstGeom prst="rect">
-            <a:avLst/>
-          </a:prstGeom>
-          <a:noFill/>
-        </p:spPr>
-        <p:txBody>
-          <a:bodyPr wrap="square" lIns="25400" rIns="25400" tIns="25400" bIns="25400" anchor="t">
-            <a:spAutoFit/>
-          </a:bodyPr>
-          <a:lstStyle/>
-          <a:p>
-            <a:pPr algn="l"/>
-            <a:r>
-              <a:rPr sz="1900" b="0">
-                <a:solidFill>
-                  <a:srgbClr val="5C696D"/>
-                </a:solidFill>
-                <a:latin typeface="Arial"/>
-              </a:rPr>
-              <a:t>public health + planning</a:t>
-            </a:r>
-          </a:p>
-        </p:txBody>
-      </p:sp>
-      <p:sp>
-        <p:nvSpPr>
-          <p:cNvPr id="7" name="Rounded Rectangle 6"/>
-          <p:cNvSpPr/>
-          <p:nvPr/>
-        </p:nvSpPr>
-        <p:spPr>
-          <a:xfrm>
-            <a:off x="4175655" y="411479"/>
-            <a:ext cx="3398435" cy="1158240"/>
-          </a:xfrm>
-          <a:prstGeom prst="roundRect">
-            <a:avLst/>
-          </a:prstGeom>
-          <a:solidFill>
-            <a:srgbClr val="FFFAF2"/>
-          </a:solidFill>
-          <a:ln w="12700">
-            <a:solidFill>
-              <a:srgbClr val="DBC7AA"/>
-            </a:solidFill>
-          </a:ln>
-        </p:spPr>
-        <p:style>
-          <a:lnRef idx="1">
-            <a:schemeClr val="accent1"/>
-          </a:lnRef>
-          <a:fillRef idx="3">
-            <a:schemeClr val="accent1"/>
-          </a:fillRef>
-          <a:effectRef idx="2">
-            <a:schemeClr val="accent1"/>
-          </a:effectRef>
-          <a:fontRef idx="minor">
-            <a:schemeClr val="lt1"/>
-          </a:fontRef>
-        </p:style>
-        <p:txBody>
-          <a:bodyPr rtlCol="0" anchor="ctr"/>
-          <a:lstStyle/>
-          <a:p>
-            <a:pPr algn="ctr"/>
-          </a:p>
-        </p:txBody>
-      </p:sp>
-      <p:sp>
-        <p:nvSpPr>
-          <p:cNvPr id="8" name="TextBox 7"/>
-          <p:cNvSpPr txBox="1"/>
-          <p:nvPr/>
-        </p:nvSpPr>
-        <p:spPr>
-          <a:xfrm>
-            <a:off x="4389010" y="609600"/>
-            <a:ext cx="2986965" cy="259080"/>
-          </a:xfrm>
-          <a:prstGeom prst="rect">
-            <a:avLst/>
-          </a:prstGeom>
-          <a:noFill/>
-        </p:spPr>
-        <p:txBody>
-          <a:bodyPr wrap="square" lIns="25400" rIns="25400" tIns="25400" bIns="25400" anchor="t">
-            <a:spAutoFit/>
-          </a:bodyPr>
-          <a:lstStyle/>
-          <a:p>
-            <a:pPr algn="l"/>
-            <a:r>
-              <a:rPr sz="2400" b="1">
-                <a:solidFill>
-                  <a:srgbClr val="1E2A2F"/>
-                </a:solidFill>
-                <a:latin typeface="Arial"/>
-              </a:rPr>
-              <a:t>Cities differ</a:t>
-            </a:r>
-          </a:p>
-        </p:txBody>
-      </p:sp>
-      <p:sp>
-        <p:nvSpPr>
-          <p:cNvPr id="9" name="TextBox 8"/>
-          <p:cNvSpPr txBox="1"/>
-          <p:nvPr/>
-        </p:nvSpPr>
-        <p:spPr>
-          <a:xfrm>
-            <a:off x="4389010" y="960120"/>
-            <a:ext cx="2956486" cy="457200"/>
-          </a:xfrm>
-          <a:prstGeom prst="rect">
-            <a:avLst/>
-          </a:prstGeom>
-          <a:noFill/>
-        </p:spPr>
-        <p:txBody>
-          <a:bodyPr wrap="square" lIns="25400" rIns="25400" tIns="25400" bIns="25400" anchor="t">
-            <a:spAutoFit/>
-          </a:bodyPr>
-          <a:lstStyle/>
-          <a:p>
-            <a:pPr algn="l"/>
-            <a:r>
-              <a:rPr sz="1900" b="0">
-                <a:solidFill>
-                  <a:srgbClr val="5C696D"/>
-                </a:solidFill>
-                <a:latin typeface="Arial"/>
-              </a:rPr>
-              <a:t>climate, land cover, water,</a:t>
-            </a:r>
-          </a:p>
-          <a:p>
-            <a:pPr algn="l"/>
-            <a:r>
-              <a:rPr sz="1900" b="0">
-                <a:solidFill>
-                  <a:srgbClr val="5C696D"/>
-                </a:solidFill>
-                <a:latin typeface="Arial"/>
-              </a:rPr>
-              <a:t>vegetation</a:t>
-            </a:r>
-          </a:p>
-        </p:txBody>
-      </p:sp>
-      <p:sp>
-        <p:nvSpPr>
-          <p:cNvPr id="10" name="Rounded Rectangle 9"/>
-          <p:cNvSpPr/>
-          <p:nvPr/>
-        </p:nvSpPr>
-        <p:spPr>
-          <a:xfrm>
-            <a:off x="7939841" y="411479"/>
-            <a:ext cx="3398435" cy="1158240"/>
-          </a:xfrm>
-          <a:prstGeom prst="roundRect">
-            <a:avLst/>
-          </a:prstGeom>
-          <a:solidFill>
-            <a:srgbClr val="FFFAF2"/>
-          </a:solidFill>
-          <a:ln w="12700">
-            <a:solidFill>
-              <a:srgbClr val="DBC7AA"/>
-            </a:solidFill>
-          </a:ln>
-        </p:spPr>
-        <p:style>
-          <a:lnRef idx="1">
-            <a:schemeClr val="accent1"/>
-          </a:lnRef>
-          <a:fillRef idx="3">
-            <a:schemeClr val="accent1"/>
-          </a:fillRef>
-          <a:effectRef idx="2">
-            <a:schemeClr val="accent1"/>
-          </a:effectRef>
-          <a:fontRef idx="minor">
-            <a:schemeClr val="lt1"/>
-          </a:fontRef>
-        </p:style>
-        <p:txBody>
-          <a:bodyPr rtlCol="0" anchor="ctr"/>
-          <a:lstStyle/>
-          <a:p>
-            <a:pPr algn="ctr"/>
-          </a:p>
-        </p:txBody>
-      </p:sp>
-      <p:sp>
-        <p:nvSpPr>
-          <p:cNvPr id="11" name="TextBox 10"/>
-          <p:cNvSpPr txBox="1"/>
-          <p:nvPr/>
-        </p:nvSpPr>
-        <p:spPr>
-          <a:xfrm>
-            <a:off x="8153196" y="609600"/>
-            <a:ext cx="2986965" cy="259080"/>
-          </a:xfrm>
-          <a:prstGeom prst="rect">
-            <a:avLst/>
-          </a:prstGeom>
-          <a:noFill/>
-        </p:spPr>
-        <p:txBody>
-          <a:bodyPr wrap="square" lIns="25400" rIns="25400" tIns="25400" bIns="25400" anchor="t">
-            <a:spAutoFit/>
-          </a:bodyPr>
-          <a:lstStyle/>
-          <a:p>
-            <a:pPr algn="l"/>
-            <a:r>
-              <a:rPr sz="2400" b="1">
-                <a:solidFill>
-                  <a:srgbClr val="1E2A2F"/>
-                </a:solidFill>
-                <a:latin typeface="Arial"/>
-              </a:rPr>
-              <a:t>Random row splits mislead</a:t>
-            </a:r>
-          </a:p>
-        </p:txBody>
-      </p:sp>
-      <p:sp>
-        <p:nvSpPr>
-          <p:cNvPr id="12" name="TextBox 11"/>
-          <p:cNvSpPr txBox="1"/>
-          <p:nvPr/>
-        </p:nvSpPr>
-        <p:spPr>
-          <a:xfrm>
-            <a:off x="8153196" y="960120"/>
-            <a:ext cx="2956486" cy="457200"/>
-          </a:xfrm>
-          <a:prstGeom prst="rect">
-            <a:avLst/>
-          </a:prstGeom>
-          <a:noFill/>
-        </p:spPr>
-        <p:txBody>
-          <a:bodyPr wrap="square" lIns="25400" rIns="25400" tIns="25400" bIns="25400" anchor="t">
-            <a:spAutoFit/>
-          </a:bodyPr>
-          <a:lstStyle/>
-          <a:p>
-            <a:pPr algn="l"/>
-            <a:r>
-              <a:rPr sz="1900" b="0">
-                <a:solidFill>
-                  <a:srgbClr val="5C696D"/>
-                </a:solidFill>
-                <a:latin typeface="Arial"/>
-              </a:rPr>
-              <a:t>same-city leakage looks</a:t>
-            </a:r>
-          </a:p>
-          <a:p>
-            <a:pPr algn="l"/>
-            <a:r>
-              <a:rPr sz="1900" b="0">
-                <a:solidFill>
-                  <a:srgbClr val="5C696D"/>
-                </a:solidFill>
-                <a:latin typeface="Arial"/>
-              </a:rPr>
-              <a:t>easier than transfer</a:t>
-            </a:r>
-          </a:p>
-        </p:txBody>
-      </p:sp>
-      <p:sp>
-        <p:nvSpPr>
-          <p:cNvPr id="13" name="Rounded Rectangle 12"/>
-          <p:cNvSpPr/>
-          <p:nvPr/>
-        </p:nvSpPr>
-        <p:spPr>
-          <a:xfrm>
-            <a:off x="457188" y="1889759"/>
-            <a:ext cx="11277318" cy="2819399"/>
-          </a:xfrm>
-          <a:prstGeom prst="roundRect">
-            <a:avLst/>
-          </a:prstGeom>
-          <a:solidFill>
-            <a:srgbClr val="FFFDFA"/>
-          </a:solidFill>
-          <a:ln w="19050">
-            <a:solidFill>
-              <a:srgbClr val="DBC7AA"/>
-            </a:solidFill>
-          </a:ln>
-        </p:spPr>
-        <p:style>
-          <a:lnRef idx="1">
-            <a:schemeClr val="accent1"/>
-          </a:lnRef>
-          <a:fillRef idx="3">
-            <a:schemeClr val="accent1"/>
-          </a:fillRef>
-          <a:effectRef idx="2">
-            <a:schemeClr val="accent1"/>
-          </a:effectRef>
-          <a:fontRef idx="minor">
-            <a:schemeClr val="lt1"/>
-          </a:fontRef>
-        </p:style>
-        <p:txBody>
-          <a:bodyPr rtlCol="0" anchor="ctr"/>
-          <a:lstStyle/>
-          <a:p>
-            <a:pPr algn="ctr"/>
-          </a:p>
-        </p:txBody>
-      </p:sp>
-      <p:sp>
-        <p:nvSpPr>
-          <p:cNvPr id="14" name="Rounded Rectangle 13"/>
-          <p:cNvSpPr/>
-          <p:nvPr/>
-        </p:nvSpPr>
-        <p:spPr>
-          <a:xfrm>
-            <a:off x="822939" y="2225040"/>
-            <a:ext cx="2392620" cy="487680"/>
+            <a:off x="746741" y="4846320"/>
+            <a:ext cx="2179265" cy="426720"/>
           </a:xfrm>
           <a:prstGeom prst="roundRect">
             <a:avLst/>
@@ -4502,14 +3931,14 @@
       </p:sp>
       <p:sp>
         <p:nvSpPr>
-          <p:cNvPr id="15" name="TextBox 14"/>
+          <p:cNvPr id="7" name="TextBox 6"/>
           <p:cNvSpPr txBox="1"/>
           <p:nvPr/>
         </p:nvSpPr>
         <p:spPr>
           <a:xfrm>
-            <a:off x="1036294" y="2346960"/>
-            <a:ext cx="1965910" cy="228600"/>
+            <a:off x="929616" y="4922520"/>
+            <a:ext cx="1783035" cy="259080"/>
           </a:xfrm>
           <a:prstGeom prst="rect">
             <a:avLst/>
@@ -4517,93 +3946,34 @@
           <a:noFill/>
         </p:spPr>
         <p:txBody>
-          <a:bodyPr wrap="square" lIns="25400" rIns="25400" tIns="25400" bIns="25400" anchor="t">
-            <a:spAutoFit/>
+          <a:bodyPr wrap="square" lIns="63500" rIns="63500" tIns="63500" bIns="63500" anchor="t">
+            <a:normAutofit/>
           </a:bodyPr>
           <a:lstStyle/>
           <a:p>
             <a:pPr algn="l"/>
             <a:r>
-              <a:rPr sz="2300" b="1">
+              <a:rPr sz="1900" b="1">
                 <a:solidFill>
                   <a:srgbClr val="FFFDFA"/>
                 </a:solidFill>
                 <a:latin typeface="Arial"/>
               </a:rPr>
-              <a:t>Core question</a:t>
-            </a:r>
-          </a:p>
-        </p:txBody>
-      </p:sp>
-      <p:sp>
-        <p:nvSpPr>
-          <p:cNvPr id="16" name="TextBox 15"/>
-          <p:cNvSpPr txBox="1"/>
-          <p:nvPr/>
-        </p:nvSpPr>
-        <p:spPr>
-          <a:xfrm>
-            <a:off x="868658" y="3017520"/>
-            <a:ext cx="9905752" cy="1295399"/>
-          </a:xfrm>
-          <a:prstGeom prst="rect">
-            <a:avLst/>
-          </a:prstGeom>
-          <a:noFill/>
-        </p:spPr>
-        <p:txBody>
-          <a:bodyPr wrap="square" lIns="25400" rIns="25400" tIns="25400" bIns="25400" anchor="t">
-            <a:spAutoFit/>
-          </a:bodyPr>
-          <a:lstStyle/>
-          <a:p>
-            <a:pPr algn="l"/>
-            <a:r>
-              <a:rPr sz="3300" b="1">
-                <a:solidFill>
-                  <a:srgbClr val="1E2A2F"/>
-                </a:solidFill>
-                <a:latin typeface="Arial"/>
-              </a:rPr>
-              <a:t>Can a model trained on some cities find</a:t>
-            </a:r>
-          </a:p>
-          <a:p>
-            <a:pPr algn="l"/>
-            <a:r>
-              <a:rPr sz="3300" b="1">
-                <a:solidFill>
-                  <a:srgbClr val="1E2A2F"/>
-                </a:solidFill>
-                <a:latin typeface="Arial"/>
-              </a:rPr>
-              <a:t>heat hotspots in a city it has never</a:t>
-            </a:r>
-          </a:p>
-          <a:p>
-            <a:pPr algn="l"/>
-            <a:r>
-              <a:rPr sz="3300" b="1">
-                <a:solidFill>
-                  <a:srgbClr val="1E2A2F"/>
-                </a:solidFill>
-                <a:latin typeface="Arial"/>
-              </a:rPr>
-              <a:t>seen?</a:t>
-            </a:r>
-          </a:p>
-        </p:txBody>
-      </p:sp>
-      <p:sp>
-        <p:nvSpPr>
-          <p:cNvPr id="17" name="Rounded Rectangle 16"/>
+              <a:t>Research question</a:t>
+            </a:r>
+          </a:p>
+        </p:txBody>
+      </p:sp>
+      <p:sp>
+        <p:nvSpPr>
+          <p:cNvPr id="8" name="Rounded Rectangle 7"/>
           <p:cNvSpPr/>
           <p:nvPr/>
         </p:nvSpPr>
         <p:spPr>
           <a:xfrm>
-            <a:off x="1417284" y="5455920"/>
-            <a:ext cx="9357126" cy="670560"/>
+            <a:off x="396230" y="5318760"/>
+            <a:ext cx="11399235" cy="990599"/>
           </a:xfrm>
           <a:prstGeom prst="roundRect">
             <a:avLst/>
@@ -4639,14 +4009,14 @@
       </p:sp>
       <p:sp>
         <p:nvSpPr>
-          <p:cNvPr id="18" name="TextBox 17"/>
+          <p:cNvPr id="9" name="TextBox 8"/>
           <p:cNvSpPr txBox="1"/>
           <p:nvPr/>
         </p:nvSpPr>
         <p:spPr>
           <a:xfrm>
-            <a:off x="1630639" y="5623559"/>
-            <a:ext cx="8991375" cy="289560"/>
+            <a:off x="761980" y="5532120"/>
+            <a:ext cx="10515337" cy="533400"/>
           </a:xfrm>
           <a:prstGeom prst="rect">
             <a:avLst/>
@@ -4654,20 +4024,20 @@
           <a:noFill/>
         </p:spPr>
         <p:txBody>
-          <a:bodyPr wrap="square" lIns="25400" rIns="25400" tIns="25400" bIns="25400" anchor="t">
-            <a:spAutoFit/>
+          <a:bodyPr wrap="square" lIns="63500" rIns="63500" tIns="63500" bIns="63500" anchor="t">
+            <a:normAutofit/>
           </a:bodyPr>
           <a:lstStyle/>
           <a:p>
             <a:pPr algn="ctr"/>
             <a:r>
-              <a:rPr sz="2300" b="1">
-                <a:solidFill>
-                  <a:srgbClr val="254D5A"/>
+              <a:rPr sz="2600" b="1">
+                <a:solidFill>
+                  <a:srgbClr val="1E2A2F"/>
                 </a:solidFill>
                 <a:latin typeface="Arial"/>
               </a:rPr>
-              <a:t>This is a transfer benchmark, not same-city interpolation.</a:t>
+              <a:t>Can a model trained on some cities find heat hotspots in a city it has never seen?</a:t>
             </a:r>
           </a:p>
         </p:txBody>
@@ -4700,44 +4070,36 @@
       <p:grpSpPr/>
       <p:sp>
         <p:nvSpPr>
-          <p:cNvPr id="2" name="Oval 1"/>
-          <p:cNvSpPr/>
-          <p:nvPr/>
-        </p:nvSpPr>
-        <p:spPr>
-          <a:xfrm>
-            <a:off x="9448563" y="5334000"/>
-            <a:ext cx="2895527" cy="1981199"/>
-          </a:xfrm>
-          <a:prstGeom prst="ellipse">
-            <a:avLst/>
-          </a:prstGeom>
-          <a:solidFill>
-            <a:srgbClr val="3A7182"/>
-          </a:solidFill>
-          <a:ln>
-            <a:noFill/>
-          </a:ln>
-        </p:spPr>
-        <p:style>
-          <a:lnRef idx="1">
-            <a:schemeClr val="accent1"/>
-          </a:lnRef>
-          <a:fillRef idx="3">
-            <a:schemeClr val="accent1"/>
-          </a:fillRef>
-          <a:effectRef idx="2">
-            <a:schemeClr val="accent1"/>
-          </a:effectRef>
-          <a:fontRef idx="minor">
-            <a:schemeClr val="lt1"/>
-          </a:fontRef>
-        </p:style>
-        <p:txBody>
-          <a:bodyPr rtlCol="0" anchor="ctr"/>
-          <a:lstStyle/>
-          <a:p>
-            <a:pPr algn="ctr"/>
+          <p:cNvPr id="2" name="TextBox 1"/>
+          <p:cNvSpPr txBox="1"/>
+          <p:nvPr/>
+        </p:nvSpPr>
+        <p:spPr>
+          <a:xfrm>
+            <a:off x="441948" y="274320"/>
+            <a:ext cx="3200319" cy="259080"/>
+          </a:xfrm>
+          <a:prstGeom prst="rect">
+            <a:avLst/>
+          </a:prstGeom>
+          <a:noFill/>
+        </p:spPr>
+        <p:txBody>
+          <a:bodyPr wrap="square" lIns="63500" rIns="63500" tIns="63500" bIns="63500" anchor="t">
+            <a:spAutoFit/>
+          </a:bodyPr>
+          <a:lstStyle/>
+          <a:p>
+            <a:pPr algn="l"/>
+            <a:r>
+              <a:rPr sz="1800" b="1">
+                <a:solidFill>
+                  <a:srgbClr val="254D5A"/>
+                </a:solidFill>
+                <a:latin typeface="Arial"/>
+              </a:rPr>
+              <a:t>Data + evaluation design</a:t>
+            </a:r>
           </a:p>
         </p:txBody>
       </p:sp>
@@ -4749,8 +4111,8 @@
         </p:nvSpPr>
         <p:spPr>
           <a:xfrm>
-            <a:off x="380990" y="320040"/>
-            <a:ext cx="2285942" cy="1371600"/>
+            <a:off x="396230" y="655320"/>
+            <a:ext cx="2179265" cy="899160"/>
           </a:xfrm>
           <a:prstGeom prst="roundRect">
             <a:avLst/>
@@ -4794,8 +4156,8 @@
         </p:nvSpPr>
         <p:spPr>
           <a:xfrm>
-            <a:off x="579105" y="563880"/>
-            <a:ext cx="1889712" cy="411479"/>
+            <a:off x="563865" y="807720"/>
+            <a:ext cx="1843993" cy="320040"/>
           </a:xfrm>
           <a:prstGeom prst="rect">
             <a:avLst/>
@@ -4803,14 +4165,14 @@
           <a:noFill/>
         </p:spPr>
         <p:txBody>
-          <a:bodyPr wrap="square" lIns="25400" rIns="25400" tIns="25400" bIns="25400" anchor="t">
-            <a:spAutoFit/>
+          <a:bodyPr wrap="square" lIns="63500" rIns="63500" tIns="63500" bIns="63500" anchor="t">
+            <a:normAutofit/>
           </a:bodyPr>
           <a:lstStyle/>
           <a:p>
             <a:pPr algn="l"/>
             <a:r>
-              <a:rPr sz="5000" b="1">
+              <a:rPr sz="3600" b="1">
                 <a:solidFill>
                   <a:srgbClr val="1E2A2F"/>
                 </a:solidFill>
@@ -4829,8 +4191,8 @@
         </p:nvSpPr>
         <p:spPr>
           <a:xfrm>
-            <a:off x="579105" y="1143000"/>
-            <a:ext cx="1523961" cy="228600"/>
+            <a:off x="563865" y="1158240"/>
+            <a:ext cx="1371565" cy="213360"/>
           </a:xfrm>
           <a:prstGeom prst="rect">
             <a:avLst/>
@@ -4838,14 +4200,14 @@
           <a:noFill/>
         </p:spPr>
         <p:txBody>
-          <a:bodyPr wrap="square" lIns="25400" rIns="25400" tIns="25400" bIns="25400" anchor="t">
-            <a:spAutoFit/>
+          <a:bodyPr wrap="square" lIns="63500" rIns="63500" tIns="63500" bIns="63500" anchor="t">
+            <a:normAutofit/>
           </a:bodyPr>
           <a:lstStyle/>
           <a:p>
             <a:pPr algn="l"/>
             <a:r>
-              <a:rPr sz="2000" b="0">
+              <a:rPr sz="1600" b="0">
                 <a:solidFill>
                   <a:srgbClr val="5C696D"/>
                 </a:solidFill>
@@ -4864,8 +4226,8 @@
         </p:nvSpPr>
         <p:spPr>
           <a:xfrm>
-            <a:off x="2773610" y="320040"/>
-            <a:ext cx="2285942" cy="1371600"/>
+            <a:off x="2819329" y="655320"/>
+            <a:ext cx="2179265" cy="899160"/>
           </a:xfrm>
           <a:prstGeom prst="roundRect">
             <a:avLst/>
@@ -4909,8 +4271,8 @@
         </p:nvSpPr>
         <p:spPr>
           <a:xfrm>
-            <a:off x="2971725" y="563880"/>
-            <a:ext cx="1889712" cy="411479"/>
+            <a:off x="2986965" y="807720"/>
+            <a:ext cx="1843993" cy="320040"/>
           </a:xfrm>
           <a:prstGeom prst="rect">
             <a:avLst/>
@@ -4918,14 +4280,14 @@
           <a:noFill/>
         </p:spPr>
         <p:txBody>
-          <a:bodyPr wrap="square" lIns="25400" rIns="25400" tIns="25400" bIns="25400" anchor="t">
-            <a:spAutoFit/>
+          <a:bodyPr wrap="square" lIns="63500" rIns="63500" tIns="63500" bIns="63500" anchor="t">
+            <a:normAutofit/>
           </a:bodyPr>
           <a:lstStyle/>
           <a:p>
             <a:pPr algn="l"/>
             <a:r>
-              <a:rPr sz="4400" b="1">
+              <a:rPr sz="3000" b="1">
                 <a:solidFill>
                   <a:srgbClr val="1E2A2F"/>
                 </a:solidFill>
@@ -4944,8 +4306,8 @@
         </p:nvSpPr>
         <p:spPr>
           <a:xfrm>
-            <a:off x="2971725" y="1143000"/>
-            <a:ext cx="1523961" cy="228600"/>
+            <a:off x="2986965" y="1158240"/>
+            <a:ext cx="1371565" cy="213360"/>
           </a:xfrm>
           <a:prstGeom prst="rect">
             <a:avLst/>
@@ -4953,14 +4315,14 @@
           <a:noFill/>
         </p:spPr>
         <p:txBody>
-          <a:bodyPr wrap="square" lIns="25400" rIns="25400" tIns="25400" bIns="25400" anchor="t">
-            <a:spAutoFit/>
+          <a:bodyPr wrap="square" lIns="63500" rIns="63500" tIns="63500" bIns="63500" anchor="t">
+            <a:normAutofit/>
           </a:bodyPr>
           <a:lstStyle/>
           <a:p>
             <a:pPr algn="l"/>
             <a:r>
-              <a:rPr sz="2000" b="0">
+              <a:rPr sz="1600" b="0">
                 <a:solidFill>
                   <a:srgbClr val="5C696D"/>
                 </a:solidFill>
@@ -4979,8 +4341,8 @@
         </p:nvSpPr>
         <p:spPr>
           <a:xfrm>
-            <a:off x="5166230" y="320040"/>
-            <a:ext cx="2285942" cy="1371600"/>
+            <a:off x="5242428" y="655320"/>
+            <a:ext cx="2179265" cy="899160"/>
           </a:xfrm>
           <a:prstGeom prst="roundRect">
             <a:avLst/>
@@ -5024,8 +4386,8 @@
         </p:nvSpPr>
         <p:spPr>
           <a:xfrm>
-            <a:off x="5364345" y="563880"/>
-            <a:ext cx="1889712" cy="411479"/>
+            <a:off x="5410064" y="807720"/>
+            <a:ext cx="1843993" cy="320040"/>
           </a:xfrm>
           <a:prstGeom prst="rect">
             <a:avLst/>
@@ -5033,14 +4395,14 @@
           <a:noFill/>
         </p:spPr>
         <p:txBody>
-          <a:bodyPr wrap="square" lIns="25400" rIns="25400" tIns="25400" bIns="25400" anchor="t">
-            <a:spAutoFit/>
+          <a:bodyPr wrap="square" lIns="63500" rIns="63500" tIns="63500" bIns="63500" anchor="t">
+            <a:normAutofit/>
           </a:bodyPr>
           <a:lstStyle/>
           <a:p>
             <a:pPr algn="l"/>
             <a:r>
-              <a:rPr sz="5000" b="1">
+              <a:rPr sz="3600" b="1">
                 <a:solidFill>
                   <a:srgbClr val="1E2A2F"/>
                 </a:solidFill>
@@ -5059,8 +4421,8 @@
         </p:nvSpPr>
         <p:spPr>
           <a:xfrm>
-            <a:off x="5364345" y="1143000"/>
-            <a:ext cx="1523961" cy="228600"/>
+            <a:off x="5410064" y="1158240"/>
+            <a:ext cx="1371565" cy="213360"/>
           </a:xfrm>
           <a:prstGeom prst="rect">
             <a:avLst/>
@@ -5068,14 +4430,14 @@
           <a:noFill/>
         </p:spPr>
         <p:txBody>
-          <a:bodyPr wrap="square" lIns="25400" rIns="25400" tIns="25400" bIns="25400" anchor="t">
-            <a:spAutoFit/>
+          <a:bodyPr wrap="square" lIns="63500" rIns="63500" tIns="63500" bIns="63500" anchor="t">
+            <a:normAutofit/>
           </a:bodyPr>
           <a:lstStyle/>
           <a:p>
             <a:pPr algn="l"/>
             <a:r>
-              <a:rPr sz="2000" b="0">
+              <a:rPr sz="1600" b="0">
                 <a:solidFill>
                   <a:srgbClr val="5C696D"/>
                 </a:solidFill>
@@ -5094,8 +4456,8 @@
         </p:nvSpPr>
         <p:spPr>
           <a:xfrm>
-            <a:off x="7558851" y="320040"/>
-            <a:ext cx="2285942" cy="1371600"/>
+            <a:off x="7665528" y="655320"/>
+            <a:ext cx="2179265" cy="899160"/>
           </a:xfrm>
           <a:prstGeom prst="roundRect">
             <a:avLst/>
@@ -5139,8 +4501,8 @@
         </p:nvSpPr>
         <p:spPr>
           <a:xfrm>
-            <a:off x="7756966" y="563880"/>
-            <a:ext cx="1889712" cy="411479"/>
+            <a:off x="7833164" y="807720"/>
+            <a:ext cx="1843993" cy="320040"/>
           </a:xfrm>
           <a:prstGeom prst="rect">
             <a:avLst/>
@@ -5148,14 +4510,14 @@
           <a:noFill/>
         </p:spPr>
         <p:txBody>
-          <a:bodyPr wrap="square" lIns="25400" rIns="25400" tIns="25400" bIns="25400" anchor="t">
-            <a:spAutoFit/>
+          <a:bodyPr wrap="square" lIns="63500" rIns="63500" tIns="63500" bIns="63500" anchor="t">
+            <a:normAutofit/>
           </a:bodyPr>
           <a:lstStyle/>
           <a:p>
             <a:pPr algn="l"/>
             <a:r>
-              <a:rPr sz="3600" b="1">
+              <a:rPr sz="2600" b="1">
                 <a:solidFill>
                   <a:srgbClr val="1E2A2F"/>
                 </a:solidFill>
@@ -5174,8 +4536,8 @@
         </p:nvSpPr>
         <p:spPr>
           <a:xfrm>
-            <a:off x="7756966" y="1143000"/>
-            <a:ext cx="1523961" cy="228600"/>
+            <a:off x="7833164" y="1158240"/>
+            <a:ext cx="1371565" cy="213360"/>
           </a:xfrm>
           <a:prstGeom prst="rect">
             <a:avLst/>
@@ -5183,14 +4545,14 @@
           <a:noFill/>
         </p:spPr>
         <p:txBody>
-          <a:bodyPr wrap="square" lIns="25400" rIns="25400" tIns="25400" bIns="25400" anchor="t">
-            <a:spAutoFit/>
+          <a:bodyPr wrap="square" lIns="63500" rIns="63500" tIns="63500" bIns="63500" anchor="t">
+            <a:normAutofit/>
           </a:bodyPr>
           <a:lstStyle/>
           <a:p>
             <a:pPr algn="l"/>
             <a:r>
-              <a:rPr sz="2000" b="0">
+              <a:rPr sz="1600" b="0">
                 <a:solidFill>
                   <a:srgbClr val="5C696D"/>
                 </a:solidFill>
@@ -5209,8 +4571,8 @@
         </p:nvSpPr>
         <p:spPr>
           <a:xfrm>
-            <a:off x="9966710" y="320040"/>
-            <a:ext cx="1828754" cy="1371600"/>
+            <a:off x="10088627" y="655320"/>
+            <a:ext cx="1706837" cy="899160"/>
           </a:xfrm>
           <a:prstGeom prst="roundRect">
             <a:avLst/>
@@ -5252,8 +4614,8 @@
         </p:nvSpPr>
         <p:spPr>
           <a:xfrm>
-            <a:off x="10530576" y="579120"/>
-            <a:ext cx="685782" cy="396239"/>
+            <a:off x="10439139" y="792479"/>
+            <a:ext cx="975335" cy="274320"/>
           </a:xfrm>
           <a:prstGeom prst="rect">
             <a:avLst/>
@@ -5261,14 +4623,14 @@
           <a:noFill/>
         </p:spPr>
         <p:txBody>
-          <a:bodyPr wrap="square" lIns="25400" rIns="25400" tIns="25400" bIns="25400" anchor="t">
-            <a:spAutoFit/>
+          <a:bodyPr wrap="square" lIns="63500" rIns="63500" tIns="63500" bIns="63500" anchor="t">
+            <a:normAutofit/>
           </a:bodyPr>
           <a:lstStyle/>
           <a:p>
             <a:pPr algn="ctr"/>
             <a:r>
-              <a:rPr sz="5000" b="1">
+              <a:rPr sz="3400" b="1">
                 <a:solidFill>
                   <a:srgbClr val="FFFDFA"/>
                 </a:solidFill>
@@ -5287,8 +4649,8 @@
         </p:nvSpPr>
         <p:spPr>
           <a:xfrm>
-            <a:off x="10210544" y="1143000"/>
-            <a:ext cx="1371565" cy="243840"/>
+            <a:off x="10286742" y="1158240"/>
+            <a:ext cx="1310607" cy="198119"/>
           </a:xfrm>
           <a:prstGeom prst="rect">
             <a:avLst/>
@@ -5296,14 +4658,14 @@
           <a:noFill/>
         </p:spPr>
         <p:txBody>
-          <a:bodyPr wrap="square" lIns="25400" rIns="25400" tIns="25400" bIns="25400" anchor="t">
-            <a:spAutoFit/>
+          <a:bodyPr wrap="square" lIns="63500" rIns="63500" tIns="63500" bIns="63500" anchor="t">
+            <a:normAutofit/>
           </a:bodyPr>
           <a:lstStyle/>
           <a:p>
             <a:pPr algn="ctr"/>
             <a:r>
-              <a:rPr sz="2200" b="0">
+              <a:rPr sz="1500" b="0">
                 <a:solidFill>
                   <a:srgbClr val="FFFDFA"/>
                 </a:solidFill>
@@ -5322,8 +4684,8 @@
         </p:nvSpPr>
         <p:spPr>
           <a:xfrm>
-            <a:off x="380990" y="2087880"/>
-            <a:ext cx="7177860" cy="4099560"/>
+            <a:off x="396230" y="1813559"/>
+            <a:ext cx="11399235" cy="3810000"/>
           </a:xfrm>
           <a:prstGeom prst="roundRect">
             <a:avLst/>
@@ -5331,7 +4693,7 @@
           <a:solidFill>
             <a:srgbClr val="FFFDFA"/>
           </a:solidFill>
-          <a:ln w="12700">
+          <a:ln w="17780">
             <a:solidFill>
               <a:srgbClr val="DBC7AA"/>
             </a:solidFill>
@@ -5359,22 +4721,46 @@
           </a:p>
         </p:txBody>
       </p:sp>
-      <p:sp>
-        <p:nvSpPr>
-          <p:cNvPr id="19" name="Rounded Rectangle 18"/>
+      <p:pic>
+        <p:nvPicPr>
+          <p:cNvPr id="19" name="Picture 18" descr="heldout_city_cv_schematic.png"/>
+          <p:cNvPicPr>
+            <a:picLocks noChangeAspect="1"/>
+          </p:cNvPicPr>
+          <p:nvPr/>
+        </p:nvPicPr>
+        <p:blipFill>
+          <a:blip r:embed="rId2"/>
+          <a:stretch>
+            <a:fillRect/>
+          </a:stretch>
+        </p:blipFill>
+        <p:spPr>
+          <a:xfrm>
+            <a:off x="640063" y="2072640"/>
+            <a:ext cx="10896327" cy="3124200"/>
+          </a:xfrm>
+          <a:prstGeom prst="rect">
+            <a:avLst/>
+          </a:prstGeom>
+        </p:spPr>
+      </p:pic>
+      <p:sp>
+        <p:nvSpPr>
+          <p:cNvPr id="20" name="Rounded Rectangle 19"/>
           <p:cNvSpPr/>
           <p:nvPr/>
         </p:nvSpPr>
         <p:spPr>
           <a:xfrm>
-            <a:off x="640063" y="2346960"/>
-            <a:ext cx="2301182" cy="518160"/>
+            <a:off x="1432524" y="5852160"/>
+            <a:ext cx="9311407" cy="487680"/>
           </a:xfrm>
           <a:prstGeom prst="roundRect">
             <a:avLst/>
           </a:prstGeom>
           <a:solidFill>
-            <a:srgbClr val="3A7182"/>
+            <a:srgbClr val="EBE0CF"/>
           </a:solidFill>
           <a:ln>
             <a:noFill/>
@@ -5404,14 +4790,14 @@
       </p:sp>
       <p:sp>
         <p:nvSpPr>
-          <p:cNvPr id="20" name="TextBox 19"/>
+          <p:cNvPr id="21" name="TextBox 20"/>
           <p:cNvSpPr txBox="1"/>
           <p:nvPr/>
         </p:nvSpPr>
         <p:spPr>
           <a:xfrm>
-            <a:off x="883897" y="2468879"/>
-            <a:ext cx="1752556" cy="243840"/>
+            <a:off x="1676358" y="5974080"/>
+            <a:ext cx="8838979" cy="213360"/>
           </a:xfrm>
           <a:prstGeom prst="rect">
             <a:avLst/>
@@ -5419,762 +4805,20 @@
           <a:noFill/>
         </p:spPr>
         <p:txBody>
-          <a:bodyPr wrap="square" lIns="25400" rIns="25400" tIns="25400" bIns="25400" anchor="t">
-            <a:spAutoFit/>
+          <a:bodyPr wrap="square" lIns="63500" rIns="63500" tIns="63500" bIns="63500" anchor="t">
+            <a:normAutofit/>
           </a:bodyPr>
           <a:lstStyle/>
           <a:p>
             <a:pPr algn="ctr"/>
             <a:r>
-              <a:rPr sz="2400" b="1">
-                <a:solidFill>
-                  <a:srgbClr val="FFFDFA"/>
+              <a:rPr sz="1700" b="1">
+                <a:solidFill>
+                  <a:srgbClr val="254D5A"/>
                 </a:solidFill>
                 <a:latin typeface="Arial"/>
               </a:rPr>
-              <a:t>Analytic unit</a:t>
-            </a:r>
-          </a:p>
-        </p:txBody>
-      </p:sp>
-      <p:sp>
-        <p:nvSpPr>
-          <p:cNvPr id="21" name="TextBox 20"/>
-          <p:cNvSpPr txBox="1"/>
-          <p:nvPr/>
-        </p:nvSpPr>
-        <p:spPr>
-          <a:xfrm>
-            <a:off x="670543" y="3185160"/>
-            <a:ext cx="6400639" cy="853440"/>
-          </a:xfrm>
-          <a:prstGeom prst="rect">
-            <a:avLst/>
-          </a:prstGeom>
-          <a:noFill/>
-        </p:spPr>
-        <p:txBody>
-          <a:bodyPr wrap="square" lIns="25400" rIns="25400" tIns="25400" bIns="25400" anchor="t">
-            <a:spAutoFit/>
-          </a:bodyPr>
-          <a:lstStyle/>
-          <a:p>
-            <a:pPr algn="l"/>
-            <a:r>
-              <a:rPr sz="2200" b="0">
-                <a:solidFill>
-                  <a:srgbClr val="1E2A2F"/>
-                </a:solidFill>
-                <a:latin typeface="Arial"/>
-              </a:rPr>
-              <a:t>One row = one 30 m cell in one city. Predictors</a:t>
-            </a:r>
-          </a:p>
-          <a:p>
-            <a:pPr algn="l"/>
-            <a:r>
-              <a:rPr sz="2200" b="0">
-                <a:solidFill>
-                  <a:srgbClr val="1E2A2F"/>
-                </a:solidFill>
-                <a:latin typeface="Arial"/>
-              </a:rPr>
-              <a:t>summarize built form, terrain, water, vegetation,</a:t>
-            </a:r>
-          </a:p>
-          <a:p>
-            <a:pPr algn="l"/>
-            <a:r>
-              <a:rPr sz="2200" b="0">
-                <a:solidFill>
-                  <a:srgbClr val="1E2A2F"/>
-                </a:solidFill>
-                <a:latin typeface="Arial"/>
-              </a:rPr>
-              <a:t>and climate context.</a:t>
-            </a:r>
-          </a:p>
-        </p:txBody>
-      </p:sp>
-      <p:sp>
-        <p:nvSpPr>
-          <p:cNvPr id="22" name="Rounded Rectangle 21"/>
-          <p:cNvSpPr/>
-          <p:nvPr/>
-        </p:nvSpPr>
-        <p:spPr>
-          <a:xfrm>
-            <a:off x="7772205" y="2087880"/>
-            <a:ext cx="4023259" cy="4099560"/>
-          </a:xfrm>
-          <a:prstGeom prst="roundRect">
-            <a:avLst/>
-          </a:prstGeom>
-          <a:solidFill>
-            <a:srgbClr val="FFFAF2"/>
-          </a:solidFill>
-          <a:ln w="12700">
-            <a:solidFill>
-              <a:srgbClr val="DBC7AA"/>
-            </a:solidFill>
-          </a:ln>
-        </p:spPr>
-        <p:style>
-          <a:lnRef idx="1">
-            <a:schemeClr val="accent1"/>
-          </a:lnRef>
-          <a:fillRef idx="3">
-            <a:schemeClr val="accent1"/>
-          </a:fillRef>
-          <a:effectRef idx="2">
-            <a:schemeClr val="accent1"/>
-          </a:effectRef>
-          <a:fontRef idx="minor">
-            <a:schemeClr val="lt1"/>
-          </a:fontRef>
-        </p:style>
-        <p:txBody>
-          <a:bodyPr rtlCol="0" anchor="ctr"/>
-          <a:lstStyle/>
-          <a:p>
-            <a:pPr algn="ctr"/>
-          </a:p>
-        </p:txBody>
-      </p:sp>
-      <p:sp>
-        <p:nvSpPr>
-          <p:cNvPr id="23" name="Rounded Rectangle 22"/>
-          <p:cNvSpPr/>
-          <p:nvPr/>
-        </p:nvSpPr>
-        <p:spPr>
-          <a:xfrm>
-            <a:off x="7955081" y="2346960"/>
-            <a:ext cx="3657508" cy="518160"/>
-          </a:xfrm>
-          <a:prstGeom prst="roundRect">
-            <a:avLst/>
-          </a:prstGeom>
-          <a:solidFill>
-            <a:srgbClr val="9A402D"/>
-          </a:solidFill>
-          <a:ln>
-            <a:noFill/>
-          </a:ln>
-        </p:spPr>
-        <p:style>
-          <a:lnRef idx="1">
-            <a:schemeClr val="accent1"/>
-          </a:lnRef>
-          <a:fillRef idx="3">
-            <a:schemeClr val="accent1"/>
-          </a:fillRef>
-          <a:effectRef idx="2">
-            <a:schemeClr val="accent1"/>
-          </a:effectRef>
-          <a:fontRef idx="minor">
-            <a:schemeClr val="lt1"/>
-          </a:fontRef>
-        </p:style>
-        <p:txBody>
-          <a:bodyPr rtlCol="0" anchor="ctr"/>
-          <a:lstStyle/>
-          <a:p>
-            <a:pPr algn="ctr"/>
-          </a:p>
-        </p:txBody>
-      </p:sp>
-      <p:sp>
-        <p:nvSpPr>
-          <p:cNvPr id="24" name="TextBox 23"/>
-          <p:cNvSpPr txBox="1"/>
-          <p:nvPr/>
-        </p:nvSpPr>
-        <p:spPr>
-          <a:xfrm>
-            <a:off x="8153196" y="2468879"/>
-            <a:ext cx="3276518" cy="243840"/>
-          </a:xfrm>
-          <a:prstGeom prst="rect">
-            <a:avLst/>
-          </a:prstGeom>
-          <a:noFill/>
-        </p:spPr>
-        <p:txBody>
-          <a:bodyPr wrap="square" lIns="25400" rIns="25400" tIns="25400" bIns="25400" anchor="t">
-            <a:spAutoFit/>
-          </a:bodyPr>
-          <a:lstStyle/>
-          <a:p>
-            <a:pPr algn="ctr"/>
-            <a:r>
-              <a:rPr sz="2200" b="1">
-                <a:solidFill>
-                  <a:srgbClr val="FFFDFA"/>
-                </a:solidFill>
-                <a:latin typeface="Arial"/>
-              </a:rPr>
-              <a:t>Leakage-safe benchmark</a:t>
-            </a:r>
-          </a:p>
-        </p:txBody>
-      </p:sp>
-      <p:sp>
-        <p:nvSpPr>
-          <p:cNvPr id="25" name="TextBox 24"/>
-          <p:cNvSpPr txBox="1"/>
-          <p:nvPr/>
-        </p:nvSpPr>
-        <p:spPr>
-          <a:xfrm>
-            <a:off x="8000799" y="3200400"/>
-            <a:ext cx="3291757" cy="990599"/>
-          </a:xfrm>
-          <a:prstGeom prst="rect">
-            <a:avLst/>
-          </a:prstGeom>
-          <a:noFill/>
-        </p:spPr>
-        <p:txBody>
-          <a:bodyPr wrap="square" lIns="25400" rIns="25400" tIns="25400" bIns="25400" anchor="t">
-            <a:spAutoFit/>
-          </a:bodyPr>
-          <a:lstStyle/>
-          <a:p>
-            <a:pPr algn="l"/>
-            <a:r>
-              <a:rPr sz="2100" b="0">
-                <a:solidFill>
-                  <a:srgbClr val="1E2A2F"/>
-                </a:solidFill>
-                <a:latin typeface="Arial"/>
-              </a:rPr>
-              <a:t>6 held-out cities per fold.</a:t>
-            </a:r>
-          </a:p>
-          <a:p>
-            <a:pPr algn="l"/>
-            <a:r>
-              <a:rPr sz="2100" b="0">
-                <a:solidFill>
-                  <a:srgbClr val="1E2A2F"/>
-                </a:solidFill>
-                <a:latin typeface="Arial"/>
-              </a:rPr>
-              <a:t>Preprocessing, tuning,</a:t>
-            </a:r>
-          </a:p>
-          <a:p>
-            <a:pPr algn="l"/>
-            <a:r>
-              <a:rPr sz="2100" b="0">
-                <a:solidFill>
-                  <a:srgbClr val="1E2A2F"/>
-                </a:solidFill>
-                <a:latin typeface="Arial"/>
-              </a:rPr>
-              <a:t>and model fitting use</a:t>
-            </a:r>
-          </a:p>
-          <a:p>
-            <a:pPr algn="l"/>
-            <a:r>
-              <a:rPr sz="2100" b="0">
-                <a:solidFill>
-                  <a:srgbClr val="1E2A2F"/>
-                </a:solidFill>
-                <a:latin typeface="Arial"/>
-              </a:rPr>
-              <a:t>training-city rows only.</a:t>
-            </a:r>
-          </a:p>
-        </p:txBody>
-      </p:sp>
-      <p:sp>
-        <p:nvSpPr>
-          <p:cNvPr id="26" name="Rounded Rectangle 25"/>
-          <p:cNvSpPr/>
-          <p:nvPr/>
-        </p:nvSpPr>
-        <p:spPr>
-          <a:xfrm>
-            <a:off x="685782" y="4937759"/>
-            <a:ext cx="1615399" cy="807720"/>
-          </a:xfrm>
-          <a:prstGeom prst="roundRect">
-            <a:avLst/>
-          </a:prstGeom>
-          <a:solidFill>
-            <a:srgbClr val="3A7182"/>
-          </a:solidFill>
-          <a:ln>
-            <a:noFill/>
-          </a:ln>
-        </p:spPr>
-        <p:style>
-          <a:lnRef idx="1">
-            <a:schemeClr val="accent1"/>
-          </a:lnRef>
-          <a:fillRef idx="3">
-            <a:schemeClr val="accent1"/>
-          </a:fillRef>
-          <a:effectRef idx="2">
-            <a:schemeClr val="accent1"/>
-          </a:effectRef>
-          <a:fontRef idx="minor">
-            <a:schemeClr val="lt1"/>
-          </a:fontRef>
-        </p:style>
-        <p:txBody>
-          <a:bodyPr rtlCol="0" anchor="ctr"/>
-          <a:lstStyle/>
-          <a:p>
-            <a:pPr algn="ctr"/>
-          </a:p>
-        </p:txBody>
-      </p:sp>
-      <p:sp>
-        <p:nvSpPr>
-          <p:cNvPr id="27" name="TextBox 26"/>
-          <p:cNvSpPr txBox="1"/>
-          <p:nvPr/>
-        </p:nvSpPr>
-        <p:spPr>
-          <a:xfrm>
-            <a:off x="822939" y="5074920"/>
-            <a:ext cx="1341086" cy="533400"/>
-          </a:xfrm>
-          <a:prstGeom prst="rect">
-            <a:avLst/>
-          </a:prstGeom>
-          <a:noFill/>
-        </p:spPr>
-        <p:txBody>
-          <a:bodyPr wrap="square" lIns="25400" rIns="25400" tIns="25400" bIns="25400" anchor="t">
-            <a:spAutoFit/>
-          </a:bodyPr>
-          <a:lstStyle/>
-          <a:p>
-            <a:pPr algn="ctr"/>
-            <a:r>
-              <a:rPr sz="1800" b="1">
-                <a:solidFill>
-                  <a:srgbClr val="FFFDFA"/>
-                </a:solidFill>
-                <a:latin typeface="Arial"/>
-              </a:rPr>
-              <a:t>Assemble</a:t>
-            </a:r>
-          </a:p>
-          <a:p>
-            <a:pPr algn="ctr"/>
-            <a:r>
-              <a:rPr sz="1800" b="1">
-                <a:solidFill>
-                  <a:srgbClr val="FFFDFA"/>
-                </a:solidFill>
-                <a:latin typeface="Arial"/>
-              </a:rPr>
-              <a:t>features</a:t>
-            </a:r>
-          </a:p>
-        </p:txBody>
-      </p:sp>
-      <p:sp>
-        <p:nvSpPr>
-          <p:cNvPr id="28" name="Chevron 27"/>
-          <p:cNvSpPr/>
-          <p:nvPr/>
-        </p:nvSpPr>
-        <p:spPr>
-          <a:xfrm>
-            <a:off x="2438339" y="5196840"/>
-            <a:ext cx="304792" cy="304800"/>
-          </a:xfrm>
-          <a:prstGeom prst="chevron">
-            <a:avLst/>
-          </a:prstGeom>
-          <a:solidFill>
-            <a:srgbClr val="5C696D"/>
-          </a:solidFill>
-          <a:ln>
-            <a:noFill/>
-          </a:ln>
-        </p:spPr>
-        <p:style>
-          <a:lnRef idx="1">
-            <a:schemeClr val="accent1"/>
-          </a:lnRef>
-          <a:fillRef idx="3">
-            <a:schemeClr val="accent1"/>
-          </a:fillRef>
-          <a:effectRef idx="2">
-            <a:schemeClr val="accent1"/>
-          </a:effectRef>
-          <a:fontRef idx="minor">
-            <a:schemeClr val="lt1"/>
-          </a:fontRef>
-        </p:style>
-        <p:txBody>
-          <a:bodyPr rtlCol="0" anchor="ctr"/>
-          <a:lstStyle/>
-          <a:p>
-            <a:pPr algn="ctr"/>
-          </a:p>
-        </p:txBody>
-      </p:sp>
-      <p:sp>
-        <p:nvSpPr>
-          <p:cNvPr id="29" name="Rounded Rectangle 28"/>
-          <p:cNvSpPr/>
-          <p:nvPr/>
-        </p:nvSpPr>
-        <p:spPr>
-          <a:xfrm>
-            <a:off x="2926006" y="4937759"/>
-            <a:ext cx="1737316" cy="807720"/>
-          </a:xfrm>
-          <a:prstGeom prst="roundRect">
-            <a:avLst/>
-          </a:prstGeom>
-          <a:solidFill>
-            <a:srgbClr val="8AA07A"/>
-          </a:solidFill>
-          <a:ln>
-            <a:noFill/>
-          </a:ln>
-        </p:spPr>
-        <p:style>
-          <a:lnRef idx="1">
-            <a:schemeClr val="accent1"/>
-          </a:lnRef>
-          <a:fillRef idx="3">
-            <a:schemeClr val="accent1"/>
-          </a:fillRef>
-          <a:effectRef idx="2">
-            <a:schemeClr val="accent1"/>
-          </a:effectRef>
-          <a:fontRef idx="minor">
-            <a:schemeClr val="lt1"/>
-          </a:fontRef>
-        </p:style>
-        <p:txBody>
-          <a:bodyPr rtlCol="0" anchor="ctr"/>
-          <a:lstStyle/>
-          <a:p>
-            <a:pPr algn="ctr"/>
-          </a:p>
-        </p:txBody>
-      </p:sp>
-      <p:sp>
-        <p:nvSpPr>
-          <p:cNvPr id="30" name="TextBox 29"/>
-          <p:cNvSpPr txBox="1"/>
-          <p:nvPr/>
-        </p:nvSpPr>
-        <p:spPr>
-          <a:xfrm>
-            <a:off x="3063163" y="5074920"/>
-            <a:ext cx="1463003" cy="533400"/>
-          </a:xfrm>
-          <a:prstGeom prst="rect">
-            <a:avLst/>
-          </a:prstGeom>
-          <a:noFill/>
-        </p:spPr>
-        <p:txBody>
-          <a:bodyPr wrap="square" lIns="25400" rIns="25400" tIns="25400" bIns="25400" anchor="t">
-            <a:spAutoFit/>
-          </a:bodyPr>
-          <a:lstStyle/>
-          <a:p>
-            <a:pPr algn="ctr"/>
-            <a:r>
-              <a:rPr sz="1800" b="1">
-                <a:solidFill>
-                  <a:srgbClr val="FFFDFA"/>
-                </a:solidFill>
-                <a:latin typeface="Arial"/>
-              </a:rPr>
-              <a:t>Train on 24</a:t>
-            </a:r>
-          </a:p>
-          <a:p>
-            <a:pPr algn="ctr"/>
-            <a:r>
-              <a:rPr sz="1800" b="1">
-                <a:solidFill>
-                  <a:srgbClr val="FFFDFA"/>
-                </a:solidFill>
-                <a:latin typeface="Arial"/>
-              </a:rPr>
-              <a:t>cities</a:t>
-            </a:r>
-          </a:p>
-        </p:txBody>
-      </p:sp>
-      <p:sp>
-        <p:nvSpPr>
-          <p:cNvPr id="31" name="Chevron 30"/>
-          <p:cNvSpPr/>
-          <p:nvPr/>
-        </p:nvSpPr>
-        <p:spPr>
-          <a:xfrm>
-            <a:off x="4800479" y="5196840"/>
-            <a:ext cx="304792" cy="304800"/>
-          </a:xfrm>
-          <a:prstGeom prst="chevron">
-            <a:avLst/>
-          </a:prstGeom>
-          <a:solidFill>
-            <a:srgbClr val="5C696D"/>
-          </a:solidFill>
-          <a:ln>
-            <a:noFill/>
-          </a:ln>
-        </p:spPr>
-        <p:style>
-          <a:lnRef idx="1">
-            <a:schemeClr val="accent1"/>
-          </a:lnRef>
-          <a:fillRef idx="3">
-            <a:schemeClr val="accent1"/>
-          </a:fillRef>
-          <a:effectRef idx="2">
-            <a:schemeClr val="accent1"/>
-          </a:effectRef>
-          <a:fontRef idx="minor">
-            <a:schemeClr val="lt1"/>
-          </a:fontRef>
-        </p:style>
-        <p:txBody>
-          <a:bodyPr rtlCol="0" anchor="ctr"/>
-          <a:lstStyle/>
-          <a:p>
-            <a:pPr algn="ctr"/>
-          </a:p>
-        </p:txBody>
-      </p:sp>
-      <p:sp>
-        <p:nvSpPr>
-          <p:cNvPr id="32" name="Rounded Rectangle 31"/>
-          <p:cNvSpPr/>
-          <p:nvPr/>
-        </p:nvSpPr>
-        <p:spPr>
-          <a:xfrm>
-            <a:off x="5288147" y="4937759"/>
-            <a:ext cx="1737316" cy="807720"/>
-          </a:xfrm>
-          <a:prstGeom prst="roundRect">
-            <a:avLst/>
-          </a:prstGeom>
-          <a:solidFill>
-            <a:srgbClr val="D26B34"/>
-          </a:solidFill>
-          <a:ln>
-            <a:noFill/>
-          </a:ln>
-        </p:spPr>
-        <p:style>
-          <a:lnRef idx="1">
-            <a:schemeClr val="accent1"/>
-          </a:lnRef>
-          <a:fillRef idx="3">
-            <a:schemeClr val="accent1"/>
-          </a:fillRef>
-          <a:effectRef idx="2">
-            <a:schemeClr val="accent1"/>
-          </a:effectRef>
-          <a:fontRef idx="minor">
-            <a:schemeClr val="lt1"/>
-          </a:fontRef>
-        </p:style>
-        <p:txBody>
-          <a:bodyPr rtlCol="0" anchor="ctr"/>
-          <a:lstStyle/>
-          <a:p>
-            <a:pPr algn="ctr"/>
-          </a:p>
-        </p:txBody>
-      </p:sp>
-      <p:sp>
-        <p:nvSpPr>
-          <p:cNvPr id="33" name="TextBox 32"/>
-          <p:cNvSpPr txBox="1"/>
-          <p:nvPr/>
-        </p:nvSpPr>
-        <p:spPr>
-          <a:xfrm>
-            <a:off x="5425304" y="5074920"/>
-            <a:ext cx="1463003" cy="533400"/>
-          </a:xfrm>
-          <a:prstGeom prst="rect">
-            <a:avLst/>
-          </a:prstGeom>
-          <a:noFill/>
-        </p:spPr>
-        <p:txBody>
-          <a:bodyPr wrap="square" lIns="25400" rIns="25400" tIns="25400" bIns="25400" anchor="t">
-            <a:spAutoFit/>
-          </a:bodyPr>
-          <a:lstStyle/>
-          <a:p>
-            <a:pPr algn="ctr"/>
-            <a:r>
-              <a:rPr sz="1800" b="1">
-                <a:solidFill>
-                  <a:srgbClr val="FFFDFA"/>
-                </a:solidFill>
-                <a:latin typeface="Arial"/>
-              </a:rPr>
-              <a:t>Tune on</a:t>
-            </a:r>
-          </a:p>
-          <a:p>
-            <a:pPr algn="ctr"/>
-            <a:r>
-              <a:rPr sz="1800" b="1">
-                <a:solidFill>
-                  <a:srgbClr val="FFFDFA"/>
-                </a:solidFill>
-                <a:latin typeface="Arial"/>
-              </a:rPr>
-              <a:t>train only</a:t>
-            </a:r>
-          </a:p>
-        </p:txBody>
-      </p:sp>
-      <p:sp>
-        <p:nvSpPr>
-          <p:cNvPr id="34" name="Chevron 33"/>
-          <p:cNvSpPr/>
-          <p:nvPr/>
-        </p:nvSpPr>
-        <p:spPr>
-          <a:xfrm>
-            <a:off x="7162620" y="5196840"/>
-            <a:ext cx="304792" cy="304800"/>
-          </a:xfrm>
-          <a:prstGeom prst="chevron">
-            <a:avLst/>
-          </a:prstGeom>
-          <a:solidFill>
-            <a:srgbClr val="5C696D"/>
-          </a:solidFill>
-          <a:ln>
-            <a:noFill/>
-          </a:ln>
-        </p:spPr>
-        <p:style>
-          <a:lnRef idx="1">
-            <a:schemeClr val="accent1"/>
-          </a:lnRef>
-          <a:fillRef idx="3">
-            <a:schemeClr val="accent1"/>
-          </a:fillRef>
-          <a:effectRef idx="2">
-            <a:schemeClr val="accent1"/>
-          </a:effectRef>
-          <a:fontRef idx="minor">
-            <a:schemeClr val="lt1"/>
-          </a:fontRef>
-        </p:style>
-        <p:txBody>
-          <a:bodyPr rtlCol="0" anchor="ctr"/>
-          <a:lstStyle/>
-          <a:p>
-            <a:pPr algn="ctr"/>
-          </a:p>
-        </p:txBody>
-      </p:sp>
-      <p:sp>
-        <p:nvSpPr>
-          <p:cNvPr id="35" name="Rounded Rectangle 34"/>
-          <p:cNvSpPr/>
-          <p:nvPr/>
-        </p:nvSpPr>
-        <p:spPr>
-          <a:xfrm>
-            <a:off x="7650288" y="4937759"/>
-            <a:ext cx="1874473" cy="807720"/>
-          </a:xfrm>
-          <a:prstGeom prst="roundRect">
-            <a:avLst/>
-          </a:prstGeom>
-          <a:solidFill>
-            <a:srgbClr val="9A402D"/>
-          </a:solidFill>
-          <a:ln>
-            <a:noFill/>
-          </a:ln>
-        </p:spPr>
-        <p:style>
-          <a:lnRef idx="1">
-            <a:schemeClr val="accent1"/>
-          </a:lnRef>
-          <a:fillRef idx="3">
-            <a:schemeClr val="accent1"/>
-          </a:fillRef>
-          <a:effectRef idx="2">
-            <a:schemeClr val="accent1"/>
-          </a:effectRef>
-          <a:fontRef idx="minor">
-            <a:schemeClr val="lt1"/>
-          </a:fontRef>
-        </p:style>
-        <p:txBody>
-          <a:bodyPr rtlCol="0" anchor="ctr"/>
-          <a:lstStyle/>
-          <a:p>
-            <a:pPr algn="ctr"/>
-          </a:p>
-        </p:txBody>
-      </p:sp>
-      <p:sp>
-        <p:nvSpPr>
-          <p:cNvPr id="36" name="TextBox 35"/>
-          <p:cNvSpPr txBox="1"/>
-          <p:nvPr/>
-        </p:nvSpPr>
-        <p:spPr>
-          <a:xfrm>
-            <a:off x="7787445" y="5074920"/>
-            <a:ext cx="1600159" cy="533400"/>
-          </a:xfrm>
-          <a:prstGeom prst="rect">
-            <a:avLst/>
-          </a:prstGeom>
-          <a:noFill/>
-        </p:spPr>
-        <p:txBody>
-          <a:bodyPr wrap="square" lIns="25400" rIns="25400" tIns="25400" bIns="25400" anchor="t">
-            <a:spAutoFit/>
-          </a:bodyPr>
-          <a:lstStyle/>
-          <a:p>
-            <a:pPr algn="ctr"/>
-            <a:r>
-              <a:rPr sz="1800" b="1">
-                <a:solidFill>
-                  <a:srgbClr val="FFFDFA"/>
-                </a:solidFill>
-                <a:latin typeface="Arial"/>
-              </a:rPr>
-              <a:t>Score 6</a:t>
-            </a:r>
-          </a:p>
-          <a:p>
-            <a:pPr algn="ctr"/>
-            <a:r>
-              <a:rPr sz="1800" b="1">
-                <a:solidFill>
-                  <a:srgbClr val="FFFDFA"/>
-                </a:solidFill>
-                <a:latin typeface="Arial"/>
-              </a:rPr>
-              <a:t>unseen cities</a:t>
+              <a:t>Train, tune, and preprocess only on seen cities before scoring unseen cities.</a:t>
             </a:r>
           </a:p>
         </p:txBody>
@@ -6213,8 +4857,8 @@
         </p:nvSpPr>
         <p:spPr>
           <a:xfrm>
-            <a:off x="259073" y="259080"/>
-            <a:ext cx="3444153" cy="6172200"/>
+            <a:off x="274313" y="228600"/>
+            <a:ext cx="3474633" cy="6248400"/>
           </a:xfrm>
           <a:prstGeom prst="roundRect">
             <a:avLst/>
@@ -6258,8 +4902,8 @@
         </p:nvSpPr>
         <p:spPr>
           <a:xfrm>
-            <a:off x="441948" y="518160"/>
-            <a:ext cx="3078403" cy="441960"/>
+            <a:off x="472428" y="472439"/>
+            <a:ext cx="3078403" cy="426720"/>
           </a:xfrm>
           <a:prstGeom prst="roundRect">
             <a:avLst/>
@@ -6301,8 +4945,8 @@
         </p:nvSpPr>
         <p:spPr>
           <a:xfrm>
-            <a:off x="624824" y="624840"/>
-            <a:ext cx="2712652" cy="198119"/>
+            <a:off x="685782" y="548640"/>
+            <a:ext cx="2636454" cy="228600"/>
           </a:xfrm>
           <a:prstGeom prst="rect">
             <a:avLst/>
@@ -6310,8 +4954,8 @@
           <a:noFill/>
         </p:spPr>
         <p:txBody>
-          <a:bodyPr wrap="square" lIns="25400" rIns="25400" tIns="25400" bIns="25400" anchor="t">
-            <a:spAutoFit/>
+          <a:bodyPr wrap="square" lIns="63500" rIns="63500" tIns="63500" bIns="63500" anchor="t">
+            <a:normAutofit/>
           </a:bodyPr>
           <a:lstStyle/>
           <a:p>
@@ -6336,8 +4980,8 @@
         </p:nvSpPr>
         <p:spPr>
           <a:xfrm>
-            <a:off x="441948" y="1112520"/>
-            <a:ext cx="2849808" cy="838200"/>
+            <a:off x="472428" y="1051560"/>
+            <a:ext cx="2910767" cy="701040"/>
           </a:xfrm>
           <a:prstGeom prst="rect">
             <a:avLst/>
@@ -6345,14 +4989,14 @@
           <a:noFill/>
         </p:spPr>
         <p:txBody>
-          <a:bodyPr wrap="square" lIns="25400" rIns="25400" tIns="25400" bIns="25400" anchor="t">
-            <a:spAutoFit/>
+          <a:bodyPr wrap="square" lIns="63500" rIns="63500" tIns="63500" bIns="63500" anchor="t">
+            <a:normAutofit/>
           </a:bodyPr>
           <a:lstStyle/>
           <a:p>
             <a:pPr algn="l"/>
             <a:r>
-              <a:rPr sz="2000" b="0">
+              <a:rPr sz="1800" b="0">
                 <a:solidFill>
                   <a:srgbClr val="1E2A2F"/>
                 </a:solidFill>
@@ -6364,37 +5008,25 @@
           <a:p>
             <a:pPr algn="l"/>
             <a:r>
-              <a:rPr sz="2000" b="0">
+              <a:rPr sz="1800" b="0">
                 <a:solidFill>
                   <a:srgbClr val="1E2A2F"/>
                 </a:solidFill>
                 <a:latin typeface="Arial"/>
               </a:rPr>
-              <a:t>The comparison isolates</a:t>
+              <a:t>The comparison isolates linear</a:t>
             </a:r>
           </a:p>
           <a:p>
             <a:pPr algn="l"/>
             <a:r>
-              <a:rPr sz="2000" b="0">
+              <a:rPr sz="1800" b="0">
                 <a:solidFill>
                   <a:srgbClr val="1E2A2F"/>
                 </a:solidFill>
                 <a:latin typeface="Arial"/>
               </a:rPr>
-              <a:t>linear vs nonlinear</a:t>
-            </a:r>
-          </a:p>
-          <a:p>
-            <a:pPr algn="l"/>
-            <a:r>
-              <a:rPr sz="2000" b="0">
-                <a:solidFill>
-                  <a:srgbClr val="1E2A2F"/>
-                </a:solidFill>
-                <a:latin typeface="Arial"/>
-              </a:rPr>
-              <a:t>transfer behavior.</a:t>
+              <a:t>versus nonlinear transfer.</a:t>
             </a:r>
           </a:p>
         </p:txBody>
@@ -6407,8 +5039,8 @@
         </p:nvSpPr>
         <p:spPr>
           <a:xfrm>
-            <a:off x="502907" y="1935480"/>
-            <a:ext cx="2956486" cy="1600200"/>
+            <a:off x="548626" y="1874519"/>
+            <a:ext cx="2910767" cy="1463040"/>
           </a:xfrm>
           <a:prstGeom prst="roundRect">
             <a:avLst/>
@@ -6452,8 +5084,8 @@
         </p:nvSpPr>
         <p:spPr>
           <a:xfrm>
-            <a:off x="701022" y="2087880"/>
-            <a:ext cx="2285942" cy="213360"/>
+            <a:off x="731501" y="2026920"/>
+            <a:ext cx="1981150" cy="213360"/>
           </a:xfrm>
           <a:prstGeom prst="rect">
             <a:avLst/>
@@ -6461,14 +5093,14 @@
           <a:noFill/>
         </p:spPr>
         <p:txBody>
-          <a:bodyPr wrap="square" lIns="25400" rIns="25400" tIns="25400" bIns="25400" anchor="t">
-            <a:spAutoFit/>
+          <a:bodyPr wrap="square" lIns="63500" rIns="63500" tIns="63500" bIns="63500" anchor="t">
+            <a:normAutofit/>
           </a:bodyPr>
           <a:lstStyle/>
           <a:p>
             <a:pPr algn="l"/>
             <a:r>
-              <a:rPr sz="2200" b="1">
+              <a:rPr sz="2100" b="1">
                 <a:solidFill>
                   <a:srgbClr val="1E2A2F"/>
                 </a:solidFill>
@@ -6487,8 +5119,8 @@
         </p:nvSpPr>
         <p:spPr>
           <a:xfrm>
-            <a:off x="701022" y="2453640"/>
-            <a:ext cx="2285942" cy="533400"/>
+            <a:off x="731501" y="2392680"/>
+            <a:ext cx="2057348" cy="411479"/>
           </a:xfrm>
           <a:prstGeom prst="rect">
             <a:avLst/>
@@ -6496,20 +5128,20 @@
           <a:noFill/>
         </p:spPr>
         <p:txBody>
-          <a:bodyPr wrap="square" lIns="25400" rIns="25400" tIns="25400" bIns="25400" anchor="t">
-            <a:spAutoFit/>
+          <a:bodyPr wrap="square" lIns="63500" rIns="63500" tIns="63500" bIns="63500" anchor="t">
+            <a:normAutofit/>
           </a:bodyPr>
           <a:lstStyle/>
           <a:p>
             <a:pPr algn="l"/>
             <a:r>
-              <a:rPr sz="1900" b="1">
+              <a:rPr sz="1600" b="1">
                 <a:solidFill>
                   <a:srgbClr val="9A402D"/>
                 </a:solidFill>
                 <a:latin typeface="Arial"/>
               </a:rPr>
-              <a:t>Pr(Y=1|x) = σ(β₀ + xᵀβ)</a:t>
+              <a:t>Pr(Y=1|x) = sigma(beta_0 + x^T beta)</a:t>
             </a:r>
           </a:p>
         </p:txBody>
@@ -6522,8 +5154,8 @@
         </p:nvSpPr>
         <p:spPr>
           <a:xfrm>
-            <a:off x="701022" y="3032760"/>
-            <a:ext cx="2209744" cy="228600"/>
+            <a:off x="731501" y="2910840"/>
+            <a:ext cx="1889712" cy="198119"/>
           </a:xfrm>
           <a:prstGeom prst="rect">
             <a:avLst/>
@@ -6531,14 +5163,14 @@
           <a:noFill/>
         </p:spPr>
         <p:txBody>
-          <a:bodyPr wrap="square" lIns="25400" rIns="25400" tIns="25400" bIns="25400" anchor="t">
-            <a:spAutoFit/>
+          <a:bodyPr wrap="square" lIns="63500" rIns="63500" tIns="63500" bIns="63500" anchor="t">
+            <a:normAutofit/>
           </a:bodyPr>
           <a:lstStyle/>
           <a:p>
             <a:pPr algn="l"/>
             <a:r>
-              <a:rPr sz="1700" b="0">
+              <a:rPr sz="1500" b="0">
                 <a:solidFill>
                   <a:srgbClr val="5C696D"/>
                 </a:solidFill>
@@ -6557,8 +5189,8 @@
         </p:nvSpPr>
         <p:spPr>
           <a:xfrm>
-            <a:off x="502907" y="3627119"/>
-            <a:ext cx="2956486" cy="1600200"/>
+            <a:off x="548626" y="3474720"/>
+            <a:ext cx="2910767" cy="1463040"/>
           </a:xfrm>
           <a:prstGeom prst="roundRect">
             <a:avLst/>
@@ -6602,8 +5234,8 @@
         </p:nvSpPr>
         <p:spPr>
           <a:xfrm>
-            <a:off x="701022" y="3779519"/>
-            <a:ext cx="2285942" cy="213360"/>
+            <a:off x="731501" y="3627119"/>
+            <a:ext cx="1752556" cy="213360"/>
           </a:xfrm>
           <a:prstGeom prst="rect">
             <a:avLst/>
@@ -6611,14 +5243,14 @@
           <a:noFill/>
         </p:spPr>
         <p:txBody>
-          <a:bodyPr wrap="square" lIns="25400" rIns="25400" tIns="25400" bIns="25400" anchor="t">
-            <a:spAutoFit/>
+          <a:bodyPr wrap="square" lIns="63500" rIns="63500" tIns="63500" bIns="63500" anchor="t">
+            <a:normAutofit/>
           </a:bodyPr>
           <a:lstStyle/>
           <a:p>
             <a:pPr algn="l"/>
             <a:r>
-              <a:rPr sz="2200" b="1">
+              <a:rPr sz="2100" b="1">
                 <a:solidFill>
                   <a:srgbClr val="1E2A2F"/>
                 </a:solidFill>
@@ -6637,8 +5269,8 @@
         </p:nvSpPr>
         <p:spPr>
           <a:xfrm>
-            <a:off x="701022" y="4145280"/>
-            <a:ext cx="2285942" cy="533400"/>
+            <a:off x="731501" y="3992879"/>
+            <a:ext cx="1935431" cy="411479"/>
           </a:xfrm>
           <a:prstGeom prst="rect">
             <a:avLst/>
@@ -6646,20 +5278,20 @@
           <a:noFill/>
         </p:spPr>
         <p:txBody>
-          <a:bodyPr wrap="square" lIns="25400" rIns="25400" tIns="25400" bIns="25400" anchor="t">
-            <a:spAutoFit/>
+          <a:bodyPr wrap="square" lIns="63500" rIns="63500" tIns="63500" bIns="63500" anchor="t">
+            <a:normAutofit/>
           </a:bodyPr>
           <a:lstStyle/>
           <a:p>
             <a:pPr algn="l"/>
             <a:r>
-              <a:rPr sz="1900" b="1">
+              <a:rPr sz="1600" b="1">
                 <a:solidFill>
                   <a:srgbClr val="9A402D"/>
                 </a:solidFill>
                 <a:latin typeface="Arial"/>
               </a:rPr>
-              <a:t>p̂(x) = (1/B) Σ T_b(x)</a:t>
+              <a:t>p_hat(x) = (1/B) sum T_b(x)</a:t>
             </a:r>
           </a:p>
         </p:txBody>
@@ -6672,8 +5304,8 @@
         </p:nvSpPr>
         <p:spPr>
           <a:xfrm>
-            <a:off x="701022" y="4739640"/>
-            <a:ext cx="2316422" cy="304800"/>
+            <a:off x="731501" y="4511040"/>
+            <a:ext cx="1904952" cy="259080"/>
           </a:xfrm>
           <a:prstGeom prst="rect">
             <a:avLst/>
@@ -6681,32 +5313,20 @@
           <a:noFill/>
         </p:spPr>
         <p:txBody>
-          <a:bodyPr wrap="square" lIns="25400" rIns="25400" tIns="25400" bIns="25400" anchor="t">
-            <a:spAutoFit/>
+          <a:bodyPr wrap="square" lIns="63500" rIns="63500" tIns="63500" bIns="63500" anchor="t">
+            <a:normAutofit/>
           </a:bodyPr>
           <a:lstStyle/>
           <a:p>
             <a:pPr algn="l"/>
             <a:r>
-              <a:rPr sz="1700" b="0">
+              <a:rPr sz="1500" b="0">
                 <a:solidFill>
                   <a:srgbClr val="5C696D"/>
                 </a:solidFill>
                 <a:latin typeface="Arial"/>
               </a:rPr>
-              <a:t>Tree ensemble for nonlinear</a:t>
-            </a:r>
-          </a:p>
-          <a:p>
-            <a:pPr algn="l"/>
-            <a:r>
-              <a:rPr sz="1700" b="0">
-                <a:solidFill>
-                  <a:srgbClr val="5C696D"/>
-                </a:solidFill>
-                <a:latin typeface="Arial"/>
-              </a:rPr>
-              <a:t>effects</a:t>
+              <a:t>Tree ensemble for nonlinear effects</a:t>
             </a:r>
           </a:p>
         </p:txBody>
@@ -6727,8 +5347,8 @@
         </p:blipFill>
         <p:spPr>
           <a:xfrm>
-            <a:off x="3886102" y="182880"/>
-            <a:ext cx="7924601" cy="3596640"/>
+            <a:off x="3931821" y="182880"/>
+            <a:ext cx="7863643" cy="3566160"/>
           </a:xfrm>
           <a:prstGeom prst="rect">
             <a:avLst/>
@@ -6743,8 +5363,8 @@
         </p:nvSpPr>
         <p:spPr>
           <a:xfrm>
-            <a:off x="4038499" y="4099560"/>
-            <a:ext cx="2377380" cy="1280160"/>
+            <a:off x="4008019" y="4038600"/>
+            <a:ext cx="2377380" cy="1249680"/>
           </a:xfrm>
           <a:prstGeom prst="roundRect">
             <a:avLst/>
@@ -6786,8 +5406,8 @@
         </p:nvSpPr>
         <p:spPr>
           <a:xfrm>
-            <a:off x="4251853" y="4343400"/>
-            <a:ext cx="1935431" cy="761999"/>
+            <a:off x="4190895" y="4221480"/>
+            <a:ext cx="2011629" cy="304800"/>
           </a:xfrm>
           <a:prstGeom prst="rect">
             <a:avLst/>
@@ -6795,38 +5415,49 @@
           <a:noFill/>
         </p:spPr>
         <p:txBody>
-          <a:bodyPr wrap="square" lIns="25400" rIns="25400" tIns="25400" bIns="25400" anchor="t">
-            <a:spAutoFit/>
+          <a:bodyPr wrap="square" lIns="63500" rIns="63500" tIns="63500" bIns="63500" anchor="t">
+            <a:normAutofit/>
           </a:bodyPr>
           <a:lstStyle/>
           <a:p>
             <a:pPr algn="l"/>
             <a:r>
-              <a:rPr sz="2300" b="1">
+              <a:rPr sz="1600" b="1">
                 <a:solidFill>
                   <a:srgbClr val="FFFDFA"/>
                 </a:solidFill>
                 <a:latin typeface="Arial"/>
               </a:rPr>
-              <a:t>RF pooled PR</a:t>
-            </a:r>
-          </a:p>
+              <a:t>RF pooled PR AUC</a:t>
+            </a:r>
+          </a:p>
+        </p:txBody>
+      </p:sp>
+      <p:sp>
+        <p:nvSpPr>
+          <p:cNvPr id="17" name="TextBox 16"/>
+          <p:cNvSpPr txBox="1"/>
+          <p:nvPr/>
+        </p:nvSpPr>
+        <p:spPr>
+          <a:xfrm>
+            <a:off x="4190895" y="4587240"/>
+            <a:ext cx="2011629" cy="320040"/>
+          </a:xfrm>
+          <a:prstGeom prst="rect">
+            <a:avLst/>
+          </a:prstGeom>
+          <a:noFill/>
+        </p:spPr>
+        <p:txBody>
+          <a:bodyPr wrap="square" lIns="63500" rIns="63500" tIns="63500" bIns="63500" anchor="t">
+            <a:normAutofit/>
+          </a:bodyPr>
+          <a:lstStyle/>
           <a:p>
             <a:pPr algn="l"/>
             <a:r>
-              <a:rPr sz="2300" b="1">
-                <a:solidFill>
-                  <a:srgbClr val="FFFDFA"/>
-                </a:solidFill>
-                <a:latin typeface="Arial"/>
-              </a:rPr>
-              <a:t>AUC</a:t>
-            </a:r>
-          </a:p>
-          <a:p>
-            <a:pPr algn="l"/>
-            <a:r>
-              <a:rPr sz="2300" b="1">
+              <a:rPr sz="2800" b="1">
                 <a:solidFill>
                   <a:srgbClr val="FFFDFA"/>
                 </a:solidFill>
@@ -6839,14 +5470,14 @@
       </p:sp>
       <p:sp>
         <p:nvSpPr>
-          <p:cNvPr id="17" name="Rounded Rectangle 16"/>
+          <p:cNvPr id="18" name="Rounded Rectangle 17"/>
           <p:cNvSpPr/>
           <p:nvPr/>
         </p:nvSpPr>
         <p:spPr>
           <a:xfrm>
-            <a:off x="6690192" y="4099560"/>
-            <a:ext cx="2377380" cy="1280160"/>
+            <a:off x="6674953" y="4038600"/>
+            <a:ext cx="2377380" cy="1249680"/>
           </a:xfrm>
           <a:prstGeom prst="roundRect">
             <a:avLst/>
@@ -6882,14 +5513,14 @@
       </p:sp>
       <p:sp>
         <p:nvSpPr>
-          <p:cNvPr id="18" name="TextBox 17"/>
+          <p:cNvPr id="19" name="TextBox 18"/>
           <p:cNvSpPr txBox="1"/>
           <p:nvPr/>
         </p:nvSpPr>
         <p:spPr>
           <a:xfrm>
-            <a:off x="6903547" y="4343400"/>
-            <a:ext cx="1935431" cy="761999"/>
+            <a:off x="6857828" y="4221480"/>
+            <a:ext cx="2011629" cy="304800"/>
           </a:xfrm>
           <a:prstGeom prst="rect">
             <a:avLst/>
@@ -6897,38 +5528,49 @@
           <a:noFill/>
         </p:spPr>
         <p:txBody>
-          <a:bodyPr wrap="square" lIns="25400" rIns="25400" tIns="25400" bIns="25400" anchor="t">
-            <a:spAutoFit/>
+          <a:bodyPr wrap="square" lIns="63500" rIns="63500" tIns="63500" bIns="63500" anchor="t">
+            <a:normAutofit/>
           </a:bodyPr>
           <a:lstStyle/>
           <a:p>
             <a:pPr algn="l"/>
             <a:r>
-              <a:rPr sz="2300" b="1">
+              <a:rPr sz="1600" b="1">
                 <a:solidFill>
                   <a:srgbClr val="FFFDFA"/>
                 </a:solidFill>
                 <a:latin typeface="Arial"/>
               </a:rPr>
-              <a:t>RF</a:t>
-            </a:r>
-          </a:p>
+              <a:t>RF recall@10%</a:t>
+            </a:r>
+          </a:p>
+        </p:txBody>
+      </p:sp>
+      <p:sp>
+        <p:nvSpPr>
+          <p:cNvPr id="20" name="TextBox 19"/>
+          <p:cNvSpPr txBox="1"/>
+          <p:nvPr/>
+        </p:nvSpPr>
+        <p:spPr>
+          <a:xfrm>
+            <a:off x="6857828" y="4587240"/>
+            <a:ext cx="2011629" cy="320040"/>
+          </a:xfrm>
+          <a:prstGeom prst="rect">
+            <a:avLst/>
+          </a:prstGeom>
+          <a:noFill/>
+        </p:spPr>
+        <p:txBody>
+          <a:bodyPr wrap="square" lIns="63500" rIns="63500" tIns="63500" bIns="63500" anchor="t">
+            <a:normAutofit/>
+          </a:bodyPr>
+          <a:lstStyle/>
           <a:p>
             <a:pPr algn="l"/>
             <a:r>
-              <a:rPr sz="2300" b="1">
-                <a:solidFill>
-                  <a:srgbClr val="FFFDFA"/>
-                </a:solidFill>
-                <a:latin typeface="Arial"/>
-              </a:rPr>
-              <a:t>recall@10%</a:t>
-            </a:r>
-          </a:p>
-          <a:p>
-            <a:pPr algn="l"/>
-            <a:r>
-              <a:rPr sz="2300" b="1">
+              <a:rPr sz="2800" b="1">
                 <a:solidFill>
                   <a:srgbClr val="FFFDFA"/>
                 </a:solidFill>
@@ -6941,14 +5583,14 @@
       </p:sp>
       <p:sp>
         <p:nvSpPr>
-          <p:cNvPr id="19" name="Rounded Rectangle 18"/>
+          <p:cNvPr id="21" name="Rounded Rectangle 20"/>
           <p:cNvSpPr/>
           <p:nvPr/>
         </p:nvSpPr>
         <p:spPr>
           <a:xfrm>
-            <a:off x="9341886" y="4099560"/>
-            <a:ext cx="2377380" cy="1280160"/>
+            <a:off x="9341886" y="4038600"/>
+            <a:ext cx="2377380" cy="1249680"/>
           </a:xfrm>
           <a:prstGeom prst="roundRect">
             <a:avLst/>
@@ -6984,14 +5626,14 @@
       </p:sp>
       <p:sp>
         <p:nvSpPr>
-          <p:cNvPr id="20" name="TextBox 19"/>
+          <p:cNvPr id="22" name="TextBox 21"/>
           <p:cNvSpPr txBox="1"/>
           <p:nvPr/>
         </p:nvSpPr>
         <p:spPr>
           <a:xfrm>
-            <a:off x="9555241" y="4343400"/>
-            <a:ext cx="1935431" cy="761999"/>
+            <a:off x="9524761" y="4221480"/>
+            <a:ext cx="2011629" cy="304800"/>
           </a:xfrm>
           <a:prstGeom prst="rect">
             <a:avLst/>
@@ -6999,38 +5641,49 @@
           <a:noFill/>
         </p:spPr>
         <p:txBody>
-          <a:bodyPr wrap="square" lIns="25400" rIns="25400" tIns="25400" bIns="25400" anchor="t">
-            <a:spAutoFit/>
+          <a:bodyPr wrap="square" lIns="63500" rIns="63500" tIns="63500" bIns="63500" anchor="t">
+            <a:normAutofit/>
           </a:bodyPr>
           <a:lstStyle/>
           <a:p>
             <a:pPr algn="l"/>
             <a:r>
-              <a:rPr sz="2300" b="1">
+              <a:rPr sz="1600" b="1">
                 <a:solidFill>
                   <a:srgbClr val="1E2A2F"/>
                 </a:solidFill>
                 <a:latin typeface="Arial"/>
               </a:rPr>
-              <a:t>Logistic mean</a:t>
-            </a:r>
-          </a:p>
+              <a:t>Logistic mean city PR AUC</a:t>
+            </a:r>
+          </a:p>
+        </p:txBody>
+      </p:sp>
+      <p:sp>
+        <p:nvSpPr>
+          <p:cNvPr id="23" name="TextBox 22"/>
+          <p:cNvSpPr txBox="1"/>
+          <p:nvPr/>
+        </p:nvSpPr>
+        <p:spPr>
+          <a:xfrm>
+            <a:off x="9524761" y="4587240"/>
+            <a:ext cx="2011629" cy="320040"/>
+          </a:xfrm>
+          <a:prstGeom prst="rect">
+            <a:avLst/>
+          </a:prstGeom>
+          <a:noFill/>
+        </p:spPr>
+        <p:txBody>
+          <a:bodyPr wrap="square" lIns="63500" rIns="63500" tIns="63500" bIns="63500" anchor="t">
+            <a:normAutofit/>
+          </a:bodyPr>
+          <a:lstStyle/>
           <a:p>
             <a:pPr algn="l"/>
             <a:r>
-              <a:rPr sz="2300" b="1">
-                <a:solidFill>
-                  <a:srgbClr val="1E2A2F"/>
-                </a:solidFill>
-                <a:latin typeface="Arial"/>
-              </a:rPr>
-              <a:t>city PR AUC</a:t>
-            </a:r>
-          </a:p>
-          <a:p>
-            <a:pPr algn="l"/>
-            <a:r>
-              <a:rPr sz="2300" b="1">
+              <a:rPr sz="2800" b="1">
                 <a:solidFill>
                   <a:srgbClr val="1E2A2F"/>
                 </a:solidFill>
@@ -7043,14 +5696,14 @@
       </p:sp>
       <p:sp>
         <p:nvSpPr>
-          <p:cNvPr id="21" name="Rounded Rectangle 20"/>
+          <p:cNvPr id="24" name="Rounded Rectangle 23"/>
           <p:cNvSpPr/>
           <p:nvPr/>
         </p:nvSpPr>
         <p:spPr>
           <a:xfrm>
-            <a:off x="4008019" y="5699760"/>
-            <a:ext cx="7680767" cy="502920"/>
+            <a:off x="4008019" y="5669280"/>
+            <a:ext cx="7680767" cy="533400"/>
           </a:xfrm>
           <a:prstGeom prst="roundRect">
             <a:avLst/>
@@ -7086,14 +5739,14 @@
       </p:sp>
       <p:sp>
         <p:nvSpPr>
-          <p:cNvPr id="22" name="TextBox 21"/>
+          <p:cNvPr id="25" name="TextBox 24"/>
           <p:cNvSpPr txBox="1"/>
           <p:nvPr/>
         </p:nvSpPr>
         <p:spPr>
           <a:xfrm>
-            <a:off x="4282332" y="5852160"/>
-            <a:ext cx="7086422" cy="198119"/>
+            <a:off x="4221374" y="5806440"/>
+            <a:ext cx="7223579" cy="259080"/>
           </a:xfrm>
           <a:prstGeom prst="rect">
             <a:avLst/>
@@ -7101,14 +5754,14 @@
           <a:noFill/>
         </p:spPr>
         <p:txBody>
-          <a:bodyPr wrap="square" lIns="25400" rIns="25400" tIns="25400" bIns="25400" anchor="t">
-            <a:spAutoFit/>
+          <a:bodyPr wrap="square" lIns="63500" rIns="63500" tIns="63500" bIns="63500" anchor="t">
+            <a:normAutofit/>
           </a:bodyPr>
           <a:lstStyle/>
           <a:p>
             <a:pPr algn="l"/>
             <a:r>
-              <a:rPr sz="1700" b="0">
+              <a:rPr sz="1500" b="0">
                 <a:solidFill>
                   <a:srgbClr val="5C696D"/>
                 </a:solidFill>
@@ -7153,8 +5806,8 @@
         </p:nvSpPr>
         <p:spPr>
           <a:xfrm>
-            <a:off x="167635" y="152400"/>
-            <a:ext cx="11856423" cy="5516880"/>
+            <a:off x="182875" y="152400"/>
+            <a:ext cx="11825944" cy="5516880"/>
           </a:xfrm>
           <a:prstGeom prst="roundRect">
             <a:avLst/>
@@ -7206,8 +5859,8 @@
         </p:blipFill>
         <p:spPr>
           <a:xfrm>
-            <a:off x="274313" y="304800"/>
-            <a:ext cx="11643068" cy="5227320"/>
+            <a:off x="289552" y="289560"/>
+            <a:ext cx="11612589" cy="5242560"/>
           </a:xfrm>
           <a:prstGeom prst="rect">
             <a:avLst/>
@@ -7222,8 +5875,8 @@
         </p:nvSpPr>
         <p:spPr>
           <a:xfrm>
-            <a:off x="289552" y="5882640"/>
-            <a:ext cx="8000799" cy="640080"/>
+            <a:off x="304792" y="5882640"/>
+            <a:ext cx="8122716" cy="640080"/>
           </a:xfrm>
           <a:prstGeom prst="roundRect">
             <a:avLst/>
@@ -7265,8 +5918,8 @@
         </p:nvSpPr>
         <p:spPr>
           <a:xfrm>
-            <a:off x="518147" y="6050280"/>
-            <a:ext cx="7467413" cy="320040"/>
+            <a:off x="518147" y="6035040"/>
+            <a:ext cx="7696007" cy="320040"/>
           </a:xfrm>
           <a:prstGeom prst="rect">
             <a:avLst/>
@@ -7274,14 +5927,14 @@
           <a:noFill/>
         </p:spPr>
         <p:txBody>
-          <a:bodyPr wrap="square" lIns="25400" rIns="25400" tIns="25400" bIns="25400" anchor="t">
-            <a:spAutoFit/>
+          <a:bodyPr wrap="square" lIns="63500" rIns="63500" tIns="63500" bIns="63500" anchor="t">
+            <a:normAutofit/>
           </a:bodyPr>
           <a:lstStyle/>
           <a:p>
             <a:pPr algn="l"/>
             <a:r>
-              <a:rPr sz="2800" b="1">
+              <a:rPr sz="2500" b="1">
                 <a:solidFill>
                   <a:srgbClr val="1E2A2F"/>
                 </a:solidFill>
@@ -7301,7 +5954,7 @@
         <p:spPr>
           <a:xfrm>
             <a:off x="8610384" y="5943600"/>
-            <a:ext cx="3154601" cy="533400"/>
+            <a:ext cx="3154601" cy="518160"/>
           </a:xfrm>
           <a:prstGeom prst="roundRect">
             <a:avLst/>
@@ -7343,8 +5996,8 @@
         </p:nvSpPr>
         <p:spPr>
           <a:xfrm>
-            <a:off x="8838979" y="6111239"/>
-            <a:ext cx="2666933" cy="213360"/>
+            <a:off x="8854218" y="6065520"/>
+            <a:ext cx="2651693" cy="228600"/>
           </a:xfrm>
           <a:prstGeom prst="rect">
             <a:avLst/>
@@ -7352,14 +6005,14 @@
           <a:noFill/>
         </p:spPr>
         <p:txBody>
-          <a:bodyPr wrap="square" lIns="25400" rIns="25400" tIns="25400" bIns="25400" anchor="t">
-            <a:spAutoFit/>
+          <a:bodyPr wrap="square" lIns="63500" rIns="63500" tIns="63500" bIns="63500" anchor="t">
+            <a:normAutofit/>
           </a:bodyPr>
           <a:lstStyle/>
           <a:p>
             <a:pPr algn="ctr"/>
             <a:r>
-              <a:rPr sz="2200" b="1">
+              <a:rPr sz="1800" b="1">
                 <a:solidFill>
                   <a:srgbClr val="FFFDFA"/>
                 </a:solidFill>
@@ -7404,8 +6057,8 @@
         </p:nvSpPr>
         <p:spPr>
           <a:xfrm>
-            <a:off x="9296167" y="-380999"/>
-            <a:ext cx="3200319" cy="2438400"/>
+            <a:off x="9677158" y="-609600"/>
+            <a:ext cx="2285942" cy="1981199"/>
           </a:xfrm>
           <a:prstGeom prst="ellipse">
             <a:avLst/>
@@ -7441,57 +6094,14 @@
       </p:sp>
       <p:sp>
         <p:nvSpPr>
-          <p:cNvPr id="3" name="Oval 2"/>
+          <p:cNvPr id="3" name="Rounded Rectangle 2"/>
           <p:cNvSpPr/>
           <p:nvPr/>
         </p:nvSpPr>
         <p:spPr>
           <a:xfrm>
-            <a:off x="-152396" y="5334000"/>
-            <a:ext cx="3657508" cy="2133600"/>
-          </a:xfrm>
-          <a:prstGeom prst="ellipse">
-            <a:avLst/>
-          </a:prstGeom>
-          <a:solidFill>
-            <a:srgbClr val="3A7182"/>
-          </a:solidFill>
-          <a:ln>
-            <a:noFill/>
-          </a:ln>
-        </p:spPr>
-        <p:style>
-          <a:lnRef idx="1">
-            <a:schemeClr val="accent1"/>
-          </a:lnRef>
-          <a:fillRef idx="3">
-            <a:schemeClr val="accent1"/>
-          </a:fillRef>
-          <a:effectRef idx="2">
-            <a:schemeClr val="accent1"/>
-          </a:effectRef>
-          <a:fontRef idx="minor">
-            <a:schemeClr val="lt1"/>
-          </a:fontRef>
-        </p:style>
-        <p:txBody>
-          <a:bodyPr rtlCol="0" anchor="ctr"/>
-          <a:lstStyle/>
-          <a:p>
-            <a:pPr algn="ctr"/>
-          </a:p>
-        </p:txBody>
-      </p:sp>
-      <p:sp>
-        <p:nvSpPr>
-          <p:cNvPr id="4" name="Rounded Rectangle 3"/>
-          <p:cNvSpPr/>
-          <p:nvPr/>
-        </p:nvSpPr>
-        <p:spPr>
-          <a:xfrm>
-            <a:off x="365750" y="365760"/>
-            <a:ext cx="11460193" cy="1950720"/>
+            <a:off x="396230" y="411479"/>
+            <a:ext cx="11353516" cy="1356360"/>
           </a:xfrm>
           <a:prstGeom prst="roundRect">
             <a:avLst/>
@@ -7529,14 +6139,14 @@
       </p:sp>
       <p:sp>
         <p:nvSpPr>
-          <p:cNvPr id="5" name="TextBox 4"/>
+          <p:cNvPr id="4" name="TextBox 3"/>
           <p:cNvSpPr txBox="1"/>
           <p:nvPr/>
         </p:nvSpPr>
         <p:spPr>
           <a:xfrm>
-            <a:off x="655303" y="701040"/>
-            <a:ext cx="10576295" cy="1295399"/>
+            <a:off x="701022" y="701040"/>
+            <a:ext cx="10362940" cy="761999"/>
           </a:xfrm>
           <a:prstGeom prst="rect">
             <a:avLst/>
@@ -7544,58 +6154,34 @@
           <a:noFill/>
         </p:spPr>
         <p:txBody>
-          <a:bodyPr wrap="square" lIns="25400" rIns="25400" tIns="25400" bIns="25400" anchor="t">
-            <a:spAutoFit/>
+          <a:bodyPr wrap="square" lIns="63500" rIns="63500" tIns="63500" bIns="63500" anchor="t">
+            <a:normAutofit/>
           </a:bodyPr>
           <a:lstStyle/>
           <a:p>
             <a:pPr algn="l"/>
             <a:r>
-              <a:rPr sz="3400" b="1">
+              <a:rPr sz="2800" b="1">
                 <a:solidFill>
                   <a:srgbClr val="1E2A2F"/>
                 </a:solidFill>
                 <a:latin typeface="Arial"/>
               </a:rPr>
-              <a:t>Yes: cross-city hotspot transfer is</a:t>
-            </a:r>
-          </a:p>
-          <a:p>
-            <a:pPr algn="l"/>
-            <a:r>
-              <a:rPr sz="3400" b="1">
-                <a:solidFill>
-                  <a:srgbClr val="1E2A2F"/>
-                </a:solidFill>
-                <a:latin typeface="Arial"/>
-              </a:rPr>
-              <a:t>feasible, but performance is not yet</a:t>
-            </a:r>
-          </a:p>
-          <a:p>
-            <a:pPr algn="l"/>
-            <a:r>
-              <a:rPr sz="3400" b="1">
-                <a:solidFill>
-                  <a:srgbClr val="1E2A2F"/>
-                </a:solidFill>
-                <a:latin typeface="Arial"/>
-              </a:rPr>
-              <a:t>uniform across climates.</a:t>
-            </a:r>
-          </a:p>
-        </p:txBody>
-      </p:sp>
-      <p:sp>
-        <p:nvSpPr>
-          <p:cNvPr id="6" name="Rounded Rectangle 5"/>
+              <a:t>Yes: cross-city hotspot transfer is feasible, but performance is not yet uniform across climates.</a:t>
+            </a:r>
+          </a:p>
+        </p:txBody>
+      </p:sp>
+      <p:sp>
+        <p:nvSpPr>
+          <p:cNvPr id="5" name="Rounded Rectangle 4"/>
           <p:cNvSpPr/>
           <p:nvPr/>
         </p:nvSpPr>
         <p:spPr>
           <a:xfrm>
-            <a:off x="365750" y="2910840"/>
-            <a:ext cx="3657508" cy="2667000"/>
+            <a:off x="548626" y="2392680"/>
+            <a:ext cx="3200319" cy="2834640"/>
           </a:xfrm>
           <a:prstGeom prst="roundRect">
             <a:avLst/>
@@ -7631,14 +6217,57 @@
       </p:sp>
       <p:sp>
         <p:nvSpPr>
+          <p:cNvPr id="6" name="Oval 5"/>
+          <p:cNvSpPr/>
+          <p:nvPr/>
+        </p:nvSpPr>
+        <p:spPr>
+          <a:xfrm>
+            <a:off x="761980" y="2590799"/>
+            <a:ext cx="411469" cy="411479"/>
+          </a:xfrm>
+          <a:prstGeom prst="ellipse">
+            <a:avLst/>
+          </a:prstGeom>
+          <a:solidFill>
+            <a:srgbClr val="FFFDFA"/>
+          </a:solidFill>
+          <a:ln>
+            <a:noFill/>
+          </a:ln>
+        </p:spPr>
+        <p:style>
+          <a:lnRef idx="1">
+            <a:schemeClr val="accent1"/>
+          </a:lnRef>
+          <a:fillRef idx="3">
+            <a:schemeClr val="accent1"/>
+          </a:fillRef>
+          <a:effectRef idx="2">
+            <a:schemeClr val="accent1"/>
+          </a:effectRef>
+          <a:fontRef idx="minor">
+            <a:schemeClr val="lt1"/>
+          </a:fontRef>
+        </p:style>
+        <p:txBody>
+          <a:bodyPr rtlCol="0" anchor="ctr"/>
+          <a:lstStyle/>
+          <a:p>
+            <a:pPr algn="ctr"/>
+          </a:p>
+        </p:txBody>
+      </p:sp>
+      <p:sp>
+        <p:nvSpPr>
           <p:cNvPr id="7" name="TextBox 6"/>
           <p:cNvSpPr txBox="1"/>
           <p:nvPr/>
         </p:nvSpPr>
         <p:spPr>
           <a:xfrm>
-            <a:off x="594345" y="3230880"/>
-            <a:ext cx="2285942" cy="228600"/>
+            <a:off x="1295367" y="2621280"/>
+            <a:ext cx="1584920" cy="213360"/>
           </a:xfrm>
           <a:prstGeom prst="rect">
             <a:avLst/>
@@ -7646,20 +6275,20 @@
           <a:noFill/>
         </p:spPr>
         <p:txBody>
-          <a:bodyPr wrap="square" lIns="25400" rIns="25400" tIns="25400" bIns="25400" anchor="t">
-            <a:spAutoFit/>
+          <a:bodyPr wrap="square" lIns="63500" rIns="63500" tIns="63500" bIns="63500" anchor="t">
+            <a:normAutofit/>
           </a:bodyPr>
           <a:lstStyle/>
           <a:p>
             <a:pPr algn="l"/>
             <a:r>
-              <a:rPr sz="2400" b="1">
+              <a:rPr sz="2100" b="1">
                 <a:solidFill>
                   <a:srgbClr val="FFFDFA"/>
                 </a:solidFill>
                 <a:latin typeface="Arial"/>
               </a:rPr>
-              <a:t>Best current signal</a:t>
+              <a:t>Signal</a:t>
             </a:r>
           </a:p>
         </p:txBody>
@@ -7672,8 +6301,8 @@
         </p:nvSpPr>
         <p:spPr>
           <a:xfrm>
-            <a:off x="548626" y="3825240"/>
-            <a:ext cx="3291757" cy="1402080"/>
+            <a:off x="731501" y="3185160"/>
+            <a:ext cx="2834569" cy="1341120"/>
           </a:xfrm>
           <a:prstGeom prst="roundRect">
             <a:avLst/>
@@ -7715,8 +6344,8 @@
         </p:nvSpPr>
         <p:spPr>
           <a:xfrm>
-            <a:off x="701022" y="4023360"/>
-            <a:ext cx="2926006" cy="990599"/>
+            <a:off x="883897" y="3413760"/>
+            <a:ext cx="2529776" cy="640080"/>
           </a:xfrm>
           <a:prstGeom prst="rect">
             <a:avLst/>
@@ -7724,58 +6353,81 @@
           <a:noFill/>
         </p:spPr>
         <p:txBody>
-          <a:bodyPr wrap="square" lIns="25400" rIns="25400" tIns="25400" bIns="25400" anchor="t">
-            <a:spAutoFit/>
+          <a:bodyPr wrap="square" lIns="63500" rIns="63500" tIns="63500" bIns="63500" anchor="t">
+            <a:normAutofit/>
           </a:bodyPr>
           <a:lstStyle/>
           <a:p>
             <a:pPr algn="l"/>
             <a:r>
-              <a:rPr sz="2100" b="0">
+              <a:rPr sz="2200" b="1">
                 <a:solidFill>
                   <a:srgbClr val="1E2A2F"/>
                 </a:solidFill>
                 <a:latin typeface="Arial"/>
               </a:rPr>
-              <a:t>RF improves pooled PR</a:t>
+              <a:t>RF &gt; logistic</a:t>
             </a:r>
           </a:p>
           <a:p>
             <a:pPr algn="l"/>
             <a:r>
-              <a:rPr sz="2100" b="0">
+              <a:rPr sz="2200" b="1">
                 <a:solidFill>
                   <a:srgbClr val="1E2A2F"/>
                 </a:solidFill>
                 <a:latin typeface="Arial"/>
               </a:rPr>
-              <a:t>AUC (0.1486) and</a:t>
-            </a:r>
-          </a:p>
+              <a:t>PR AUC 0.1486</a:t>
+            </a:r>
+          </a:p>
+        </p:txBody>
+      </p:sp>
+      <p:sp>
+        <p:nvSpPr>
+          <p:cNvPr id="10" name="TextBox 9"/>
+          <p:cNvSpPr txBox="1"/>
+          <p:nvPr/>
+        </p:nvSpPr>
+        <p:spPr>
+          <a:xfrm>
+            <a:off x="883897" y="4678680"/>
+            <a:ext cx="2529776" cy="228600"/>
+          </a:xfrm>
+          <a:prstGeom prst="rect">
+            <a:avLst/>
+          </a:prstGeom>
+          <a:noFill/>
+        </p:spPr>
+        <p:txBody>
+          <a:bodyPr wrap="square" lIns="63500" rIns="63500" tIns="63500" bIns="63500" anchor="t">
+            <a:normAutofit/>
+          </a:bodyPr>
+          <a:lstStyle/>
           <a:p>
             <a:pPr algn="l"/>
             <a:r>
-              <a:rPr sz="2100" b="0">
-                <a:solidFill>
-                  <a:srgbClr val="1E2A2F"/>
+              <a:rPr sz="1500" b="0">
+                <a:solidFill>
+                  <a:srgbClr val="5C696D"/>
                 </a:solidFill>
                 <a:latin typeface="Arial"/>
               </a:rPr>
-              <a:t>recall@10% (0.1961).</a:t>
-            </a:r>
-          </a:p>
-        </p:txBody>
-      </p:sp>
-      <p:sp>
-        <p:nvSpPr>
-          <p:cNvPr id="10" name="Rounded Rectangle 9"/>
+              <a:t>best current benchmark</a:t>
+            </a:r>
+          </a:p>
+        </p:txBody>
+      </p:sp>
+      <p:sp>
+        <p:nvSpPr>
+          <p:cNvPr id="11" name="Rounded Rectangle 10"/>
           <p:cNvSpPr/>
           <p:nvPr/>
         </p:nvSpPr>
         <p:spPr>
           <a:xfrm>
-            <a:off x="4267093" y="2910840"/>
-            <a:ext cx="3657508" cy="2667000"/>
+            <a:off x="4267093" y="2392680"/>
+            <a:ext cx="3200319" cy="2834640"/>
           </a:xfrm>
           <a:prstGeom prst="roundRect">
             <a:avLst/>
@@ -7811,14 +6463,57 @@
       </p:sp>
       <p:sp>
         <p:nvSpPr>
-          <p:cNvPr id="11" name="TextBox 10"/>
+          <p:cNvPr id="12" name="Oval 11"/>
+          <p:cNvSpPr/>
+          <p:nvPr/>
+        </p:nvSpPr>
+        <p:spPr>
+          <a:xfrm>
+            <a:off x="4480447" y="2590799"/>
+            <a:ext cx="411469" cy="411479"/>
+          </a:xfrm>
+          <a:prstGeom prst="ellipse">
+            <a:avLst/>
+          </a:prstGeom>
+          <a:solidFill>
+            <a:srgbClr val="FFFDFA"/>
+          </a:solidFill>
+          <a:ln>
+            <a:noFill/>
+          </a:ln>
+        </p:spPr>
+        <p:style>
+          <a:lnRef idx="1">
+            <a:schemeClr val="accent1"/>
+          </a:lnRef>
+          <a:fillRef idx="3">
+            <a:schemeClr val="accent1"/>
+          </a:fillRef>
+          <a:effectRef idx="2">
+            <a:schemeClr val="accent1"/>
+          </a:effectRef>
+          <a:fontRef idx="minor">
+            <a:schemeClr val="lt1"/>
+          </a:fontRef>
+        </p:style>
+        <p:txBody>
+          <a:bodyPr rtlCol="0" anchor="ctr"/>
+          <a:lstStyle/>
+          <a:p>
+            <a:pPr algn="ctr"/>
+          </a:p>
+        </p:txBody>
+      </p:sp>
+      <p:sp>
+        <p:nvSpPr>
+          <p:cNvPr id="13" name="TextBox 12"/>
           <p:cNvSpPr txBox="1"/>
           <p:nvPr/>
         </p:nvSpPr>
         <p:spPr>
           <a:xfrm>
-            <a:off x="4495687" y="3230880"/>
-            <a:ext cx="2285942" cy="228600"/>
+            <a:off x="5013834" y="2621280"/>
+            <a:ext cx="1584920" cy="213360"/>
           </a:xfrm>
           <a:prstGeom prst="rect">
             <a:avLst/>
@@ -7826,34 +6521,34 @@
           <a:noFill/>
         </p:spPr>
         <p:txBody>
-          <a:bodyPr wrap="square" lIns="25400" rIns="25400" tIns="25400" bIns="25400" anchor="t">
-            <a:spAutoFit/>
+          <a:bodyPr wrap="square" lIns="63500" rIns="63500" tIns="63500" bIns="63500" anchor="t">
+            <a:normAutofit/>
           </a:bodyPr>
           <a:lstStyle/>
           <a:p>
             <a:pPr algn="l"/>
             <a:r>
-              <a:rPr sz="2400" b="1">
+              <a:rPr sz="2100" b="1">
                 <a:solidFill>
                   <a:srgbClr val="FFFDFA"/>
                 </a:solidFill>
                 <a:latin typeface="Arial"/>
               </a:rPr>
-              <a:t>Key caveat</a:t>
-            </a:r>
-          </a:p>
-        </p:txBody>
-      </p:sp>
-      <p:sp>
-        <p:nvSpPr>
-          <p:cNvPr id="12" name="Rounded Rectangle 11"/>
+              <a:t>Caveat</a:t>
+            </a:r>
+          </a:p>
+        </p:txBody>
+      </p:sp>
+      <p:sp>
+        <p:nvSpPr>
+          <p:cNvPr id="14" name="Rounded Rectangle 13"/>
           <p:cNvSpPr/>
           <p:nvPr/>
         </p:nvSpPr>
         <p:spPr>
           <a:xfrm>
-            <a:off x="4449968" y="3825240"/>
-            <a:ext cx="3291757" cy="1402080"/>
+            <a:off x="4449968" y="3185160"/>
+            <a:ext cx="2834569" cy="1341120"/>
           </a:xfrm>
           <a:prstGeom prst="roundRect">
             <a:avLst/>
@@ -7889,14 +6584,14 @@
       </p:sp>
       <p:sp>
         <p:nvSpPr>
-          <p:cNvPr id="13" name="TextBox 12"/>
+          <p:cNvPr id="15" name="TextBox 14"/>
           <p:cNvSpPr txBox="1"/>
           <p:nvPr/>
         </p:nvSpPr>
         <p:spPr>
           <a:xfrm>
-            <a:off x="4602364" y="4023360"/>
-            <a:ext cx="2926006" cy="990599"/>
+            <a:off x="4602364" y="3413760"/>
+            <a:ext cx="2529776" cy="640080"/>
           </a:xfrm>
           <a:prstGeom prst="rect">
             <a:avLst/>
@@ -7904,70 +6599,81 @@
           <a:noFill/>
         </p:spPr>
         <p:txBody>
-          <a:bodyPr wrap="square" lIns="25400" rIns="25400" tIns="25400" bIns="25400" anchor="t">
-            <a:spAutoFit/>
+          <a:bodyPr wrap="square" lIns="63500" rIns="63500" tIns="63500" bIns="63500" anchor="t">
+            <a:normAutofit/>
           </a:bodyPr>
           <a:lstStyle/>
           <a:p>
             <a:pPr algn="l"/>
             <a:r>
-              <a:rPr sz="2100" b="0">
+              <a:rPr sz="2200" b="1">
                 <a:solidFill>
                   <a:srgbClr val="1E2A2F"/>
                 </a:solidFill>
                 <a:latin typeface="Arial"/>
               </a:rPr>
-              <a:t>The headline</a:t>
+              <a:t>sampled all-fold</a:t>
             </a:r>
           </a:p>
           <a:p>
             <a:pPr algn="l"/>
             <a:r>
-              <a:rPr sz="2100" b="0">
+              <a:rPr sz="2200" b="1">
                 <a:solidFill>
                   <a:srgbClr val="1E2A2F"/>
                 </a:solidFill>
                 <a:latin typeface="Arial"/>
               </a:rPr>
-              <a:t>comparison is the</a:t>
-            </a:r>
-          </a:p>
+              <a:t>benchmark path</a:t>
+            </a:r>
+          </a:p>
+        </p:txBody>
+      </p:sp>
+      <p:sp>
+        <p:nvSpPr>
+          <p:cNvPr id="16" name="TextBox 15"/>
+          <p:cNvSpPr txBox="1"/>
+          <p:nvPr/>
+        </p:nvSpPr>
+        <p:spPr>
+          <a:xfrm>
+            <a:off x="4602364" y="4678680"/>
+            <a:ext cx="2529776" cy="228600"/>
+          </a:xfrm>
+          <a:prstGeom prst="rect">
+            <a:avLst/>
+          </a:prstGeom>
+          <a:noFill/>
+        </p:spPr>
+        <p:txBody>
+          <a:bodyPr wrap="square" lIns="63500" rIns="63500" tIns="63500" bIns="63500" anchor="t">
+            <a:normAutofit/>
+          </a:bodyPr>
+          <a:lstStyle/>
           <a:p>
             <a:pPr algn="l"/>
             <a:r>
-              <a:rPr sz="2100" b="0">
-                <a:solidFill>
-                  <a:srgbClr val="1E2A2F"/>
+              <a:rPr sz="1500" b="0">
+                <a:solidFill>
+                  <a:srgbClr val="5C696D"/>
                 </a:solidFill>
                 <a:latin typeface="Arial"/>
               </a:rPr>
-              <a:t>retained sampled</a:t>
-            </a:r>
-          </a:p>
-          <a:p>
-            <a:pPr algn="l"/>
-            <a:r>
-              <a:rPr sz="2100" b="0">
-                <a:solidFill>
-                  <a:srgbClr val="1E2A2F"/>
-                </a:solidFill>
-                <a:latin typeface="Arial"/>
-              </a:rPr>
-              <a:t>all-fold benchmark path.</a:t>
-            </a:r>
-          </a:p>
-        </p:txBody>
-      </p:sp>
-      <p:sp>
-        <p:nvSpPr>
-          <p:cNvPr id="14" name="Rounded Rectangle 13"/>
+              <a:t>not exhaustive 71M-cell scoring</a:t>
+            </a:r>
+          </a:p>
+        </p:txBody>
+      </p:sp>
+      <p:sp>
+        <p:nvSpPr>
+          <p:cNvPr id="17" name="Rounded Rectangle 16"/>
           <p:cNvSpPr/>
           <p:nvPr/>
         </p:nvSpPr>
         <p:spPr>
           <a:xfrm>
-            <a:off x="8168435" y="2910840"/>
-            <a:ext cx="3657508" cy="2667000"/>
+            <a:off x="7985560" y="2392680"/>
+            <a:ext cx="3200319" cy="2834640"/>
           </a:xfrm>
           <a:prstGeom prst="roundRect">
             <a:avLst/>
@@ -8003,14 +6709,57 @@
       </p:sp>
       <p:sp>
         <p:nvSpPr>
-          <p:cNvPr id="15" name="TextBox 14"/>
+          <p:cNvPr id="18" name="Oval 17"/>
+          <p:cNvSpPr/>
+          <p:nvPr/>
+        </p:nvSpPr>
+        <p:spPr>
+          <a:xfrm>
+            <a:off x="8198915" y="2590799"/>
+            <a:ext cx="411469" cy="411479"/>
+          </a:xfrm>
+          <a:prstGeom prst="ellipse">
+            <a:avLst/>
+          </a:prstGeom>
+          <a:solidFill>
+            <a:srgbClr val="FFFAF2"/>
+          </a:solidFill>
+          <a:ln>
+            <a:noFill/>
+          </a:ln>
+        </p:spPr>
+        <p:style>
+          <a:lnRef idx="1">
+            <a:schemeClr val="accent1"/>
+          </a:lnRef>
+          <a:fillRef idx="3">
+            <a:schemeClr val="accent1"/>
+          </a:fillRef>
+          <a:effectRef idx="2">
+            <a:schemeClr val="accent1"/>
+          </a:effectRef>
+          <a:fontRef idx="minor">
+            <a:schemeClr val="lt1"/>
+          </a:fontRef>
+        </p:style>
+        <p:txBody>
+          <a:bodyPr rtlCol="0" anchor="ctr"/>
+          <a:lstStyle/>
+          <a:p>
+            <a:pPr algn="ctr"/>
+          </a:p>
+        </p:txBody>
+      </p:sp>
+      <p:sp>
+        <p:nvSpPr>
+          <p:cNvPr id="19" name="TextBox 18"/>
           <p:cNvSpPr txBox="1"/>
           <p:nvPr/>
         </p:nvSpPr>
         <p:spPr>
           <a:xfrm>
-            <a:off x="8397030" y="3230880"/>
-            <a:ext cx="2285942" cy="228600"/>
+            <a:off x="8732301" y="2621280"/>
+            <a:ext cx="1584920" cy="213360"/>
           </a:xfrm>
           <a:prstGeom prst="rect">
             <a:avLst/>
@@ -8018,34 +6767,34 @@
           <a:noFill/>
         </p:spPr>
         <p:txBody>
-          <a:bodyPr wrap="square" lIns="25400" rIns="25400" tIns="25400" bIns="25400" anchor="t">
-            <a:spAutoFit/>
+          <a:bodyPr wrap="square" lIns="63500" rIns="63500" tIns="63500" bIns="63500" anchor="t">
+            <a:normAutofit/>
           </a:bodyPr>
           <a:lstStyle/>
           <a:p>
             <a:pPr algn="l"/>
             <a:r>
-              <a:rPr sz="2400" b="1">
+              <a:rPr sz="2100" b="1">
                 <a:solidFill>
                   <a:srgbClr val="1E2A2F"/>
                 </a:solidFill>
                 <a:latin typeface="Arial"/>
               </a:rPr>
-              <a:t>Next step</a:t>
-            </a:r>
-          </a:p>
-        </p:txBody>
-      </p:sp>
-      <p:sp>
-        <p:nvSpPr>
-          <p:cNvPr id="16" name="Rounded Rectangle 15"/>
+              <a:t>Next</a:t>
+            </a:r>
+          </a:p>
+        </p:txBody>
+      </p:sp>
+      <p:sp>
+        <p:nvSpPr>
+          <p:cNvPr id="20" name="Rounded Rectangle 19"/>
           <p:cNvSpPr/>
           <p:nvPr/>
         </p:nvSpPr>
         <p:spPr>
           <a:xfrm>
-            <a:off x="8351311" y="3825240"/>
-            <a:ext cx="3291757" cy="1402080"/>
+            <a:off x="8168435" y="3185160"/>
+            <a:ext cx="2834569" cy="1341120"/>
           </a:xfrm>
           <a:prstGeom prst="roundRect">
             <a:avLst/>
@@ -8081,14 +6830,14 @@
       </p:sp>
       <p:sp>
         <p:nvSpPr>
-          <p:cNvPr id="17" name="TextBox 16"/>
+          <p:cNvPr id="21" name="TextBox 20"/>
           <p:cNvSpPr txBox="1"/>
           <p:nvPr/>
         </p:nvSpPr>
         <p:spPr>
           <a:xfrm>
-            <a:off x="8503707" y="4023360"/>
-            <a:ext cx="2926006" cy="990599"/>
+            <a:off x="8320831" y="3413760"/>
+            <a:ext cx="2529776" cy="640080"/>
           </a:xfrm>
           <a:prstGeom prst="rect">
             <a:avLst/>
@@ -8096,70 +6845,271 @@
           <a:noFill/>
         </p:spPr>
         <p:txBody>
-          <a:bodyPr wrap="square" lIns="25400" rIns="25400" tIns="25400" bIns="25400" anchor="t">
-            <a:spAutoFit/>
+          <a:bodyPr wrap="square" lIns="63500" rIns="63500" tIns="63500" bIns="63500" anchor="t">
+            <a:normAutofit/>
           </a:bodyPr>
           <a:lstStyle/>
           <a:p>
             <a:pPr algn="l"/>
             <a:r>
-              <a:rPr sz="2100" b="0">
+              <a:rPr sz="2200" b="1">
                 <a:solidFill>
                   <a:srgbClr val="1E2A2F"/>
                 </a:solidFill>
                 <a:latin typeface="Arial"/>
               </a:rPr>
-              <a:t>Run broader full scoring</a:t>
+              <a:t>full scoring +</a:t>
             </a:r>
           </a:p>
           <a:p>
             <a:pPr algn="l"/>
             <a:r>
-              <a:rPr sz="2100" b="0">
+              <a:rPr sz="2200" b="1">
                 <a:solidFill>
                   <a:srgbClr val="1E2A2F"/>
                 </a:solidFill>
                 <a:latin typeface="Arial"/>
               </a:rPr>
-              <a:t>and diagnose why</a:t>
-            </a:r>
-          </a:p>
+              <a:t>climate-shift diagnosis</a:t>
+            </a:r>
+          </a:p>
+        </p:txBody>
+      </p:sp>
+      <p:sp>
+        <p:nvSpPr>
+          <p:cNvPr id="22" name="TextBox 21"/>
+          <p:cNvSpPr txBox="1"/>
+          <p:nvPr/>
+        </p:nvSpPr>
+        <p:spPr>
+          <a:xfrm>
+            <a:off x="8320831" y="4678680"/>
+            <a:ext cx="2529776" cy="228600"/>
+          </a:xfrm>
+          <a:prstGeom prst="rect">
+            <a:avLst/>
+          </a:prstGeom>
+          <a:noFill/>
+        </p:spPr>
+        <p:txBody>
+          <a:bodyPr wrap="square" lIns="63500" rIns="63500" tIns="63500" bIns="63500" anchor="t">
+            <a:normAutofit/>
+          </a:bodyPr>
+          <a:lstStyle/>
           <a:p>
             <a:pPr algn="l"/>
             <a:r>
-              <a:rPr sz="2100" b="0">
-                <a:solidFill>
-                  <a:srgbClr val="1E2A2F"/>
+              <a:rPr sz="1500" b="0">
+                <a:solidFill>
+                  <a:srgbClr val="5C696D"/>
                 </a:solidFill>
                 <a:latin typeface="Arial"/>
               </a:rPr>
-              <a:t>transfer shifts by</a:t>
-            </a:r>
-          </a:p>
+              <a:t>next analytic priority</a:t>
+            </a:r>
+          </a:p>
+        </p:txBody>
+      </p:sp>
+    </p:spTree>
+  </p:cSld>
+  <p:clrMapOvr>
+    <a:masterClrMapping/>
+  </p:clrMapOvr>
+</p:sld>
+</file>
+
+<file path=ppt/slides/slide7.xml><?xml version="1.0" encoding="utf-8"?>
+<p:sld xmlns:a="http://schemas.openxmlformats.org/drawingml/2006/main" xmlns:p="http://schemas.openxmlformats.org/presentationml/2006/main" xmlns:r="http://schemas.openxmlformats.org/officeDocument/2006/relationships">
+  <p:cSld>
+    <p:bg>
+      <p:bgPr>
+        <a:solidFill>
+          <a:srgbClr val="F6F1E7"/>
+        </a:solidFill>
+        <a:effectLst/>
+      </p:bgPr>
+    </p:bg>
+    <p:spTree>
+      <p:nvGrpSpPr>
+        <p:cNvPr id="1" name=""/>
+        <p:cNvGrpSpPr/>
+        <p:nvPr/>
+      </p:nvGrpSpPr>
+      <p:grpSpPr/>
+      <p:sp>
+        <p:nvSpPr>
+          <p:cNvPr id="2" name="Oval 1"/>
+          <p:cNvSpPr/>
+          <p:nvPr/>
+        </p:nvSpPr>
+        <p:spPr>
+          <a:xfrm>
+            <a:off x="9296167" y="304800"/>
+            <a:ext cx="2438339" cy="2438400"/>
+          </a:xfrm>
+          <a:prstGeom prst="ellipse">
+            <a:avLst/>
+          </a:prstGeom>
+          <a:solidFill>
+            <a:srgbClr val="D26B34"/>
+          </a:solidFill>
+          <a:ln>
+            <a:noFill/>
+          </a:ln>
+        </p:spPr>
+        <p:style>
+          <a:lnRef idx="1">
+            <a:schemeClr val="accent1"/>
+          </a:lnRef>
+          <a:fillRef idx="3">
+            <a:schemeClr val="accent1"/>
+          </a:fillRef>
+          <a:effectRef idx="2">
+            <a:schemeClr val="accent1"/>
+          </a:effectRef>
+          <a:fontRef idx="minor">
+            <a:schemeClr val="lt1"/>
+          </a:fontRef>
+        </p:style>
+        <p:txBody>
+          <a:bodyPr rtlCol="0" anchor="ctr"/>
+          <a:lstStyle/>
+          <a:p>
+            <a:pPr algn="ctr"/>
+          </a:p>
+        </p:txBody>
+      </p:sp>
+      <p:sp>
+        <p:nvSpPr>
+          <p:cNvPr id="3" name="Oval 2"/>
+          <p:cNvSpPr/>
+          <p:nvPr/>
+        </p:nvSpPr>
+        <p:spPr>
+          <a:xfrm>
+            <a:off x="9753356" y="4267200"/>
+            <a:ext cx="1676358" cy="1676400"/>
+          </a:xfrm>
+          <a:prstGeom prst="ellipse">
+            <a:avLst/>
+          </a:prstGeom>
+          <a:solidFill>
+            <a:srgbClr val="3A7182"/>
+          </a:solidFill>
+          <a:ln>
+            <a:noFill/>
+          </a:ln>
+        </p:spPr>
+        <p:style>
+          <a:lnRef idx="1">
+            <a:schemeClr val="accent1"/>
+          </a:lnRef>
+          <a:fillRef idx="3">
+            <a:schemeClr val="accent1"/>
+          </a:fillRef>
+          <a:effectRef idx="2">
+            <a:schemeClr val="accent1"/>
+          </a:effectRef>
+          <a:fontRef idx="minor">
+            <a:schemeClr val="lt1"/>
+          </a:fontRef>
+        </p:style>
+        <p:txBody>
+          <a:bodyPr rtlCol="0" anchor="ctr"/>
+          <a:lstStyle/>
+          <a:p>
+            <a:pPr algn="ctr"/>
+          </a:p>
+        </p:txBody>
+      </p:sp>
+      <p:sp>
+        <p:nvSpPr>
+          <p:cNvPr id="4" name="Rounded Rectangle 3"/>
+          <p:cNvSpPr/>
+          <p:nvPr/>
+        </p:nvSpPr>
+        <p:spPr>
+          <a:xfrm>
+            <a:off x="563865" y="838200"/>
+            <a:ext cx="1752556" cy="380999"/>
+          </a:xfrm>
+          <a:prstGeom prst="roundRect">
+            <a:avLst/>
+          </a:prstGeom>
+          <a:solidFill>
+            <a:srgbClr val="9A402D"/>
+          </a:solidFill>
+          <a:ln>
+            <a:noFill/>
+          </a:ln>
+        </p:spPr>
+        <p:style>
+          <a:lnRef idx="1">
+            <a:schemeClr val="accent1"/>
+          </a:lnRef>
+          <a:fillRef idx="3">
+            <a:schemeClr val="accent1"/>
+          </a:fillRef>
+          <a:effectRef idx="2">
+            <a:schemeClr val="accent1"/>
+          </a:effectRef>
+          <a:fontRef idx="minor">
+            <a:schemeClr val="lt1"/>
+          </a:fontRef>
+        </p:style>
+        <p:txBody>
+          <a:bodyPr rtlCol="0" anchor="ctr"/>
+          <a:lstStyle/>
+          <a:p>
+            <a:pPr algn="ctr"/>
+          </a:p>
+        </p:txBody>
+      </p:sp>
+      <p:sp>
+        <p:nvSpPr>
+          <p:cNvPr id="5" name="TextBox 4"/>
+          <p:cNvSpPr txBox="1"/>
+          <p:nvPr/>
+        </p:nvSpPr>
+        <p:spPr>
+          <a:xfrm>
+            <a:off x="746741" y="899160"/>
+            <a:ext cx="1386805" cy="228600"/>
+          </a:xfrm>
+          <a:prstGeom prst="rect">
+            <a:avLst/>
+          </a:prstGeom>
+          <a:noFill/>
+        </p:spPr>
+        <p:txBody>
+          <a:bodyPr wrap="square" lIns="63500" rIns="63500" tIns="63500" bIns="63500" anchor="t">
+            <a:normAutofit/>
+          </a:bodyPr>
+          <a:lstStyle/>
           <a:p>
             <a:pPr algn="l"/>
             <a:r>
-              <a:rPr sz="2100" b="0">
-                <a:solidFill>
-                  <a:srgbClr val="1E2A2F"/>
+              <a:rPr sz="1700" b="1">
+                <a:solidFill>
+                  <a:srgbClr val="FFFDFA"/>
                 </a:solidFill>
                 <a:latin typeface="Arial"/>
               </a:rPr>
-              <a:t>climate group.</a:t>
-            </a:r>
-          </a:p>
-        </p:txBody>
-      </p:sp>
-      <p:sp>
-        <p:nvSpPr>
-          <p:cNvPr id="18" name="TextBox 17"/>
+              <a:t>Cross-city urban heat</a:t>
+            </a:r>
+          </a:p>
+        </p:txBody>
+      </p:sp>
+      <p:sp>
+        <p:nvSpPr>
+          <p:cNvPr id="6" name="TextBox 5"/>
           <p:cNvSpPr txBox="1"/>
           <p:nvPr/>
         </p:nvSpPr>
         <p:spPr>
           <a:xfrm>
-            <a:off x="9829554" y="6248400"/>
-            <a:ext cx="1676358" cy="259080"/>
+            <a:off x="594345" y="2042159"/>
+            <a:ext cx="3962300" cy="624840"/>
           </a:xfrm>
           <a:prstGeom prst="rect">
             <a:avLst/>
@@ -8167,20 +7117,55 @@
           <a:noFill/>
         </p:spPr>
         <p:txBody>
-          <a:bodyPr wrap="square" lIns="25400" rIns="25400" tIns="25400" bIns="25400" anchor="t">
-            <a:spAutoFit/>
+          <a:bodyPr wrap="square" lIns="63500" rIns="63500" tIns="63500" bIns="63500" anchor="t">
+            <a:normAutofit/>
           </a:bodyPr>
           <a:lstStyle/>
           <a:p>
-            <a:pPr algn="ctr"/>
-            <a:r>
-              <a:rPr sz="2300" b="1">
-                <a:solidFill>
-                  <a:srgbClr val="5C696D"/>
+            <a:pPr algn="l"/>
+            <a:r>
+              <a:rPr sz="3800" b="1">
+                <a:solidFill>
+                  <a:srgbClr val="1E2A2F"/>
                 </a:solidFill>
                 <a:latin typeface="Arial"/>
               </a:rPr>
               <a:t>Questions?</a:t>
+            </a:r>
+          </a:p>
+        </p:txBody>
+      </p:sp>
+      <p:sp>
+        <p:nvSpPr>
+          <p:cNvPr id="7" name="TextBox 6"/>
+          <p:cNvSpPr txBox="1"/>
+          <p:nvPr/>
+        </p:nvSpPr>
+        <p:spPr>
+          <a:xfrm>
+            <a:off x="609584" y="2895600"/>
+            <a:ext cx="4724281" cy="320040"/>
+          </a:xfrm>
+          <a:prstGeom prst="rect">
+            <a:avLst/>
+          </a:prstGeom>
+          <a:noFill/>
+        </p:spPr>
+        <p:txBody>
+          <a:bodyPr wrap="square" lIns="63500" rIns="63500" tIns="63500" bIns="63500" anchor="t">
+            <a:normAutofit/>
+          </a:bodyPr>
+          <a:lstStyle/>
+          <a:p>
+            <a:pPr algn="l"/>
+            <a:r>
+              <a:rPr sz="1800" b="1">
+                <a:solidFill>
+                  <a:srgbClr val="5C696D"/>
+                </a:solidFill>
+                <a:latin typeface="Arial"/>
+              </a:rPr>
+              <a:t>Max Clements | Nicholas Machado</a:t>
             </a:r>
           </a:p>
         </p:txBody>

</xml_diff>

<commit_message>
Align presentation docs and capitalized slide titles
</commit_message>
<xml_diff>
--- a/docs/presentation_2026/urban_heat_transfer_presentation.pptx
+++ b/docs/presentation_2026/urban_heat_transfer_presentation.pptx
@@ -5,15 +5,15 @@
     <p:sldMasterId id="2147483648" r:id="rId1"/>
   </p:sldMasterIdLst>
   <p:sldIdLst>
-    <p:sldId id="256" r:id="rId2"/>
-    <p:sldId id="257" r:id="rId3"/>
-    <p:sldId id="258" r:id="rId4"/>
-    <p:sldId id="259" r:id="rId5"/>
-    <p:sldId id="260" r:id="rId6"/>
-    <p:sldId id="261" r:id="rId7"/>
-    <p:sldId id="262" r:id="rId8"/>
+    <p:sldId id="256" r:id="rId7"/>
+    <p:sldId id="257" r:id="rId8"/>
+    <p:sldId id="258" r:id="rId9"/>
+    <p:sldId id="259" r:id="rId10"/>
+    <p:sldId id="260" r:id="rId11"/>
+    <p:sldId id="261" r:id="rId12"/>
+    <p:sldId id="262" r:id="rId13"/>
   </p:sldIdLst>
-  <p:sldSz cx="12192000" cy="6858000"/>
+  <p:sldSz cx="12191695" cy="6858000" type="screen4x3"/>
   <p:notesSz cx="6858000" cy="9144000"/>
   <p:defaultTextStyle>
     <a:defPPr>
@@ -110,52 +110,7 @@
       </a:defRPr>
     </a:lvl9pPr>
   </p:defaultTextStyle>
-  <p:extLst>
-    <p:ext uri="{EFAFB233-063F-42B5-8137-9DF3F51BA10A}">
-      <p15:sldGuideLst xmlns:p15="http://schemas.microsoft.com/office/powerpoint/2012/main">
-        <p15:guide id="1" orient="horz" pos="2160">
-          <p15:clr>
-            <a:srgbClr val="A4A3A4"/>
-          </p15:clr>
-        </p15:guide>
-        <p15:guide id="2" pos="2880">
-          <p15:clr>
-            <a:srgbClr val="A4A3A4"/>
-          </p15:clr>
-        </p15:guide>
-      </p15:sldGuideLst>
-    </p:ext>
-  </p:extLst>
 </p:presentation>
-</file>
-
-<file path=ppt/changesInfos/changesInfo1.xml><?xml version="1.0" encoding="utf-8"?>
-<pc:chgInfo xmlns:a="http://schemas.openxmlformats.org/drawingml/2006/main" xmlns:r="http://schemas.openxmlformats.org/officeDocument/2006/relationships" xmlns:ac="http://schemas.microsoft.com/office/drawing/2013/main/command" xmlns:pc="http://schemas.microsoft.com/office/powerpoint/2013/main/command">
-  <pc:docChgLst>
-    <pc:chgData name="Clements, Max (ddv5df)" userId="a6dfb0b9-8d77-4366-95a6-8c077a4ff271" providerId="ADAL" clId="{852F48AA-7239-4E52-AC6B-BA0A2EDD0361}"/>
-    <pc:docChg chg="modSld">
-      <pc:chgData name="Clements, Max (ddv5df)" userId="a6dfb0b9-8d77-4366-95a6-8c077a4ff271" providerId="ADAL" clId="{852F48AA-7239-4E52-AC6B-BA0A2EDD0361}" dt="2026-04-19T01:25:50.228" v="0" actId="14100"/>
-      <pc:docMkLst>
-        <pc:docMk/>
-      </pc:docMkLst>
-      <pc:sldChg chg="modSp mod">
-        <pc:chgData name="Clements, Max (ddv5df)" userId="a6dfb0b9-8d77-4366-95a6-8c077a4ff271" providerId="ADAL" clId="{852F48AA-7239-4E52-AC6B-BA0A2EDD0361}" dt="2026-04-19T01:25:50.228" v="0" actId="14100"/>
-        <pc:sldMkLst>
-          <pc:docMk/>
-          <pc:sldMk cId="0" sldId="257"/>
-        </pc:sldMkLst>
-        <pc:picChg chg="mod">
-          <ac:chgData name="Clements, Max (ddv5df)" userId="a6dfb0b9-8d77-4366-95a6-8c077a4ff271" providerId="ADAL" clId="{852F48AA-7239-4E52-AC6B-BA0A2EDD0361}" dt="2026-04-19T01:25:50.228" v="0" actId="14100"/>
-          <ac:picMkLst>
-            <pc:docMk/>
-            <pc:sldMk cId="0" sldId="257"/>
-            <ac:picMk id="4" creationId="{00000000-0000-0000-0000-000000000000}"/>
-          </ac:picMkLst>
-        </pc:picChg>
-      </pc:sldChg>
-    </pc:docChg>
-  </pc:docChgLst>
-</pc:chgInfo>
 </file>
 
 <file path=ppt/slideLayouts/slideLayout1.xml><?xml version="1.0" encoding="utf-8"?>
@@ -196,9 +151,10 @@
           <a:lstStyle/>
           <a:p>
             <a:r>
-              <a:rPr lang="en-US"/>
+              <a:rPr lang="en-US" smtClean="0"/>
               <a:t>Click to edit Master title style</a:t>
             </a:r>
+            <a:endParaRPr lang="en-US"/>
           </a:p>
         </p:txBody>
       </p:sp>
@@ -314,9 +270,10 @@
           </a:lstStyle>
           <a:p>
             <a:r>
-              <a:rPr lang="en-US"/>
+              <a:rPr lang="en-US" smtClean="0"/>
               <a:t>Click to edit Master subtitle style</a:t>
             </a:r>
+            <a:endParaRPr lang="en-US"/>
           </a:p>
         </p:txBody>
       </p:sp>
@@ -337,7 +294,7 @@
           <a:p>
             <a:fld id="{5BCAD085-E8A6-8845-BD4E-CB4CCA059FC4}" type="datetimeFigureOut">
               <a:rPr lang="en-US" smtClean="0"/>
-              <a:t>4/18/2026</a:t>
+              <a:t>1/27/13</a:t>
             </a:fld>
             <a:endParaRPr lang="en-US"/>
           </a:p>
@@ -431,9 +388,10 @@
           <a:lstStyle/>
           <a:p>
             <a:r>
-              <a:rPr lang="en-US"/>
+              <a:rPr lang="en-US" smtClean="0"/>
               <a:t>Click to edit Master title style</a:t>
             </a:r>
+            <a:endParaRPr lang="en-US"/>
           </a:p>
         </p:txBody>
       </p:sp>
@@ -454,37 +412,38 @@
           <a:p>
             <a:pPr lvl="0"/>
             <a:r>
-              <a:rPr lang="en-US"/>
+              <a:rPr lang="en-US" smtClean="0"/>
               <a:t>Click to edit Master text styles</a:t>
             </a:r>
           </a:p>
           <a:p>
             <a:pPr lvl="1"/>
             <a:r>
-              <a:rPr lang="en-US"/>
+              <a:rPr lang="en-US" smtClean="0"/>
               <a:t>Second level</a:t>
             </a:r>
           </a:p>
           <a:p>
             <a:pPr lvl="2"/>
             <a:r>
-              <a:rPr lang="en-US"/>
+              <a:rPr lang="en-US" smtClean="0"/>
               <a:t>Third level</a:t>
             </a:r>
           </a:p>
           <a:p>
             <a:pPr lvl="3"/>
             <a:r>
-              <a:rPr lang="en-US"/>
+              <a:rPr lang="en-US" smtClean="0"/>
               <a:t>Fourth level</a:t>
             </a:r>
           </a:p>
           <a:p>
             <a:pPr lvl="4"/>
             <a:r>
-              <a:rPr lang="en-US"/>
+              <a:rPr lang="en-US" smtClean="0"/>
               <a:t>Fifth level</a:t>
             </a:r>
+            <a:endParaRPr lang="en-US"/>
           </a:p>
         </p:txBody>
       </p:sp>
@@ -505,7 +464,7 @@
           <a:p>
             <a:fld id="{5BCAD085-E8A6-8845-BD4E-CB4CCA059FC4}" type="datetimeFigureOut">
               <a:rPr lang="en-US" smtClean="0"/>
-              <a:t>4/18/2026</a:t>
+              <a:t>1/27/13</a:t>
             </a:fld>
             <a:endParaRPr lang="en-US"/>
           </a:p>
@@ -604,9 +563,10 @@
           <a:lstStyle/>
           <a:p>
             <a:r>
-              <a:rPr lang="en-US"/>
+              <a:rPr lang="en-US" smtClean="0"/>
               <a:t>Click to edit Master title style</a:t>
             </a:r>
+            <a:endParaRPr lang="en-US"/>
           </a:p>
         </p:txBody>
       </p:sp>
@@ -632,37 +592,38 @@
           <a:p>
             <a:pPr lvl="0"/>
             <a:r>
-              <a:rPr lang="en-US"/>
+              <a:rPr lang="en-US" smtClean="0"/>
               <a:t>Click to edit Master text styles</a:t>
             </a:r>
           </a:p>
           <a:p>
             <a:pPr lvl="1"/>
             <a:r>
-              <a:rPr lang="en-US"/>
+              <a:rPr lang="en-US" smtClean="0"/>
               <a:t>Second level</a:t>
             </a:r>
           </a:p>
           <a:p>
             <a:pPr lvl="2"/>
             <a:r>
-              <a:rPr lang="en-US"/>
+              <a:rPr lang="en-US" smtClean="0"/>
               <a:t>Third level</a:t>
             </a:r>
           </a:p>
           <a:p>
             <a:pPr lvl="3"/>
             <a:r>
-              <a:rPr lang="en-US"/>
+              <a:rPr lang="en-US" smtClean="0"/>
               <a:t>Fourth level</a:t>
             </a:r>
           </a:p>
           <a:p>
             <a:pPr lvl="4"/>
             <a:r>
-              <a:rPr lang="en-US"/>
+              <a:rPr lang="en-US" smtClean="0"/>
               <a:t>Fifth level</a:t>
             </a:r>
+            <a:endParaRPr lang="en-US"/>
           </a:p>
         </p:txBody>
       </p:sp>
@@ -683,7 +644,7 @@
           <a:p>
             <a:fld id="{5BCAD085-E8A6-8845-BD4E-CB4CCA059FC4}" type="datetimeFigureOut">
               <a:rPr lang="en-US" smtClean="0"/>
-              <a:t>4/18/2026</a:t>
+              <a:t>1/27/13</a:t>
             </a:fld>
             <a:endParaRPr lang="en-US"/>
           </a:p>
@@ -777,9 +738,10 @@
           <a:lstStyle/>
           <a:p>
             <a:r>
-              <a:rPr lang="en-US"/>
+              <a:rPr lang="en-US" smtClean="0"/>
               <a:t>Click to edit Master title style</a:t>
             </a:r>
+            <a:endParaRPr lang="en-US"/>
           </a:p>
         </p:txBody>
       </p:sp>
@@ -800,37 +762,38 @@
           <a:p>
             <a:pPr lvl="0"/>
             <a:r>
-              <a:rPr lang="en-US"/>
+              <a:rPr lang="en-US" smtClean="0"/>
               <a:t>Click to edit Master text styles</a:t>
             </a:r>
           </a:p>
           <a:p>
             <a:pPr lvl="1"/>
             <a:r>
-              <a:rPr lang="en-US"/>
+              <a:rPr lang="en-US" smtClean="0"/>
               <a:t>Second level</a:t>
             </a:r>
           </a:p>
           <a:p>
             <a:pPr lvl="2"/>
             <a:r>
-              <a:rPr lang="en-US"/>
+              <a:rPr lang="en-US" smtClean="0"/>
               <a:t>Third level</a:t>
             </a:r>
           </a:p>
           <a:p>
             <a:pPr lvl="3"/>
             <a:r>
-              <a:rPr lang="en-US"/>
+              <a:rPr lang="en-US" smtClean="0"/>
               <a:t>Fourth level</a:t>
             </a:r>
           </a:p>
           <a:p>
             <a:pPr lvl="4"/>
             <a:r>
-              <a:rPr lang="en-US"/>
+              <a:rPr lang="en-US" smtClean="0"/>
               <a:t>Fifth level</a:t>
             </a:r>
+            <a:endParaRPr lang="en-US"/>
           </a:p>
         </p:txBody>
       </p:sp>
@@ -851,7 +814,7 @@
           <a:p>
             <a:fld id="{5BCAD085-E8A6-8845-BD4E-CB4CCA059FC4}" type="datetimeFigureOut">
               <a:rPr lang="en-US" smtClean="0"/>
-              <a:t>4/18/2026</a:t>
+              <a:t>1/27/13</a:t>
             </a:fld>
             <a:endParaRPr lang="en-US"/>
           </a:p>
@@ -954,9 +917,10 @@
           </a:lstStyle>
           <a:p>
             <a:r>
-              <a:rPr lang="en-US"/>
+              <a:rPr lang="en-US" smtClean="0"/>
               <a:t>Click to edit Master title style</a:t>
             </a:r>
+            <a:endParaRPr lang="en-US"/>
           </a:p>
         </p:txBody>
       </p:sp>
@@ -1073,7 +1037,7 @@
           <a:p>
             <a:pPr lvl="0"/>
             <a:r>
-              <a:rPr lang="en-US"/>
+              <a:rPr lang="en-US" smtClean="0"/>
               <a:t>Click to edit Master text styles</a:t>
             </a:r>
           </a:p>
@@ -1096,7 +1060,7 @@
           <a:p>
             <a:fld id="{5BCAD085-E8A6-8845-BD4E-CB4CCA059FC4}" type="datetimeFigureOut">
               <a:rPr lang="en-US" smtClean="0"/>
-              <a:t>4/18/2026</a:t>
+              <a:t>1/27/13</a:t>
             </a:fld>
             <a:endParaRPr lang="en-US"/>
           </a:p>
@@ -1190,9 +1154,10 @@
           <a:lstStyle/>
           <a:p>
             <a:r>
-              <a:rPr lang="en-US"/>
+              <a:rPr lang="en-US" smtClean="0"/>
               <a:t>Click to edit Master title style</a:t>
             </a:r>
+            <a:endParaRPr lang="en-US"/>
           </a:p>
         </p:txBody>
       </p:sp>
@@ -1246,37 +1211,38 @@
           <a:p>
             <a:pPr lvl="0"/>
             <a:r>
-              <a:rPr lang="en-US"/>
+              <a:rPr lang="en-US" smtClean="0"/>
               <a:t>Click to edit Master text styles</a:t>
             </a:r>
           </a:p>
           <a:p>
             <a:pPr lvl="1"/>
             <a:r>
-              <a:rPr lang="en-US"/>
+              <a:rPr lang="en-US" smtClean="0"/>
               <a:t>Second level</a:t>
             </a:r>
           </a:p>
           <a:p>
             <a:pPr lvl="2"/>
             <a:r>
-              <a:rPr lang="en-US"/>
+              <a:rPr lang="en-US" smtClean="0"/>
               <a:t>Third level</a:t>
             </a:r>
           </a:p>
           <a:p>
             <a:pPr lvl="3"/>
             <a:r>
-              <a:rPr lang="en-US"/>
+              <a:rPr lang="en-US" smtClean="0"/>
               <a:t>Fourth level</a:t>
             </a:r>
           </a:p>
           <a:p>
             <a:pPr lvl="4"/>
             <a:r>
-              <a:rPr lang="en-US"/>
+              <a:rPr lang="en-US" smtClean="0"/>
               <a:t>Fifth level</a:t>
             </a:r>
+            <a:endParaRPr lang="en-US"/>
           </a:p>
         </p:txBody>
       </p:sp>
@@ -1330,37 +1296,38 @@
           <a:p>
             <a:pPr lvl="0"/>
             <a:r>
-              <a:rPr lang="en-US"/>
+              <a:rPr lang="en-US" smtClean="0"/>
               <a:t>Click to edit Master text styles</a:t>
             </a:r>
           </a:p>
           <a:p>
             <a:pPr lvl="1"/>
             <a:r>
-              <a:rPr lang="en-US"/>
+              <a:rPr lang="en-US" smtClean="0"/>
               <a:t>Second level</a:t>
             </a:r>
           </a:p>
           <a:p>
             <a:pPr lvl="2"/>
             <a:r>
-              <a:rPr lang="en-US"/>
+              <a:rPr lang="en-US" smtClean="0"/>
               <a:t>Third level</a:t>
             </a:r>
           </a:p>
           <a:p>
             <a:pPr lvl="3"/>
             <a:r>
-              <a:rPr lang="en-US"/>
+              <a:rPr lang="en-US" smtClean="0"/>
               <a:t>Fourth level</a:t>
             </a:r>
           </a:p>
           <a:p>
             <a:pPr lvl="4"/>
             <a:r>
-              <a:rPr lang="en-US"/>
+              <a:rPr lang="en-US" smtClean="0"/>
               <a:t>Fifth level</a:t>
             </a:r>
+            <a:endParaRPr lang="en-US"/>
           </a:p>
         </p:txBody>
       </p:sp>
@@ -1381,7 +1348,7 @@
           <a:p>
             <a:fld id="{5BCAD085-E8A6-8845-BD4E-CB4CCA059FC4}" type="datetimeFigureOut">
               <a:rPr lang="en-US" smtClean="0"/>
-              <a:t>4/18/2026</a:t>
+              <a:t>1/27/13</a:t>
             </a:fld>
             <a:endParaRPr lang="en-US"/>
           </a:p>
@@ -1479,9 +1446,10 @@
           </a:lstStyle>
           <a:p>
             <a:r>
-              <a:rPr lang="en-US"/>
+              <a:rPr lang="en-US" smtClean="0"/>
               <a:t>Click to edit Master title style</a:t>
             </a:r>
+            <a:endParaRPr lang="en-US"/>
           </a:p>
         </p:txBody>
       </p:sp>
@@ -1544,7 +1512,7 @@
           <a:p>
             <a:pPr lvl="0"/>
             <a:r>
-              <a:rPr lang="en-US"/>
+              <a:rPr lang="en-US" smtClean="0"/>
               <a:t>Click to edit Master text styles</a:t>
             </a:r>
           </a:p>
@@ -1600,37 +1568,38 @@
           <a:p>
             <a:pPr lvl="0"/>
             <a:r>
-              <a:rPr lang="en-US"/>
+              <a:rPr lang="en-US" smtClean="0"/>
               <a:t>Click to edit Master text styles</a:t>
             </a:r>
           </a:p>
           <a:p>
             <a:pPr lvl="1"/>
             <a:r>
-              <a:rPr lang="en-US"/>
+              <a:rPr lang="en-US" smtClean="0"/>
               <a:t>Second level</a:t>
             </a:r>
           </a:p>
           <a:p>
             <a:pPr lvl="2"/>
             <a:r>
-              <a:rPr lang="en-US"/>
+              <a:rPr lang="en-US" smtClean="0"/>
               <a:t>Third level</a:t>
             </a:r>
           </a:p>
           <a:p>
             <a:pPr lvl="3"/>
             <a:r>
-              <a:rPr lang="en-US"/>
+              <a:rPr lang="en-US" smtClean="0"/>
               <a:t>Fourth level</a:t>
             </a:r>
           </a:p>
           <a:p>
             <a:pPr lvl="4"/>
             <a:r>
-              <a:rPr lang="en-US"/>
+              <a:rPr lang="en-US" smtClean="0"/>
               <a:t>Fifth level</a:t>
             </a:r>
+            <a:endParaRPr lang="en-US"/>
           </a:p>
         </p:txBody>
       </p:sp>
@@ -1693,7 +1662,7 @@
           <a:p>
             <a:pPr lvl="0"/>
             <a:r>
-              <a:rPr lang="en-US"/>
+              <a:rPr lang="en-US" smtClean="0"/>
               <a:t>Click to edit Master text styles</a:t>
             </a:r>
           </a:p>
@@ -1749,37 +1718,38 @@
           <a:p>
             <a:pPr lvl="0"/>
             <a:r>
-              <a:rPr lang="en-US"/>
+              <a:rPr lang="en-US" smtClean="0"/>
               <a:t>Click to edit Master text styles</a:t>
             </a:r>
           </a:p>
           <a:p>
             <a:pPr lvl="1"/>
             <a:r>
-              <a:rPr lang="en-US"/>
+              <a:rPr lang="en-US" smtClean="0"/>
               <a:t>Second level</a:t>
             </a:r>
           </a:p>
           <a:p>
             <a:pPr lvl="2"/>
             <a:r>
-              <a:rPr lang="en-US"/>
+              <a:rPr lang="en-US" smtClean="0"/>
               <a:t>Third level</a:t>
             </a:r>
           </a:p>
           <a:p>
             <a:pPr lvl="3"/>
             <a:r>
-              <a:rPr lang="en-US"/>
+              <a:rPr lang="en-US" smtClean="0"/>
               <a:t>Fourth level</a:t>
             </a:r>
           </a:p>
           <a:p>
             <a:pPr lvl="4"/>
             <a:r>
-              <a:rPr lang="en-US"/>
+              <a:rPr lang="en-US" smtClean="0"/>
               <a:t>Fifth level</a:t>
             </a:r>
+            <a:endParaRPr lang="en-US"/>
           </a:p>
         </p:txBody>
       </p:sp>
@@ -1800,7 +1770,7 @@
           <a:p>
             <a:fld id="{5BCAD085-E8A6-8845-BD4E-CB4CCA059FC4}" type="datetimeFigureOut">
               <a:rPr lang="en-US" smtClean="0"/>
-              <a:t>4/18/2026</a:t>
+              <a:t>1/27/13</a:t>
             </a:fld>
             <a:endParaRPr lang="en-US"/>
           </a:p>
@@ -1894,9 +1864,10 @@
           <a:lstStyle/>
           <a:p>
             <a:r>
-              <a:rPr lang="en-US"/>
+              <a:rPr lang="en-US" smtClean="0"/>
               <a:t>Click to edit Master title style</a:t>
             </a:r>
+            <a:endParaRPr lang="en-US"/>
           </a:p>
         </p:txBody>
       </p:sp>
@@ -1917,7 +1888,7 @@
           <a:p>
             <a:fld id="{5BCAD085-E8A6-8845-BD4E-CB4CCA059FC4}" type="datetimeFigureOut">
               <a:rPr lang="en-US" smtClean="0"/>
-              <a:t>4/18/2026</a:t>
+              <a:t>1/27/13</a:t>
             </a:fld>
             <a:endParaRPr lang="en-US"/>
           </a:p>
@@ -2012,7 +1983,7 @@
           <a:p>
             <a:fld id="{5BCAD085-E8A6-8845-BD4E-CB4CCA059FC4}" type="datetimeFigureOut">
               <a:rPr lang="en-US" smtClean="0"/>
-              <a:t>4/18/2026</a:t>
+              <a:t>1/27/13</a:t>
             </a:fld>
             <a:endParaRPr lang="en-US"/>
           </a:p>
@@ -2115,9 +2086,10 @@
           </a:lstStyle>
           <a:p>
             <a:r>
-              <a:rPr lang="en-US"/>
+              <a:rPr lang="en-US" smtClean="0"/>
               <a:t>Click to edit Master title style</a:t>
             </a:r>
+            <a:endParaRPr lang="en-US"/>
           </a:p>
         </p:txBody>
       </p:sp>
@@ -2171,37 +2143,38 @@
           <a:p>
             <a:pPr lvl="0"/>
             <a:r>
-              <a:rPr lang="en-US"/>
+              <a:rPr lang="en-US" smtClean="0"/>
               <a:t>Click to edit Master text styles</a:t>
             </a:r>
           </a:p>
           <a:p>
             <a:pPr lvl="1"/>
             <a:r>
-              <a:rPr lang="en-US"/>
+              <a:rPr lang="en-US" smtClean="0"/>
               <a:t>Second level</a:t>
             </a:r>
           </a:p>
           <a:p>
             <a:pPr lvl="2"/>
             <a:r>
-              <a:rPr lang="en-US"/>
+              <a:rPr lang="en-US" smtClean="0"/>
               <a:t>Third level</a:t>
             </a:r>
           </a:p>
           <a:p>
             <a:pPr lvl="3"/>
             <a:r>
-              <a:rPr lang="en-US"/>
+              <a:rPr lang="en-US" smtClean="0"/>
               <a:t>Fourth level</a:t>
             </a:r>
           </a:p>
           <a:p>
             <a:pPr lvl="4"/>
             <a:r>
-              <a:rPr lang="en-US"/>
+              <a:rPr lang="en-US" smtClean="0"/>
               <a:t>Fifth level</a:t>
             </a:r>
+            <a:endParaRPr lang="en-US"/>
           </a:p>
         </p:txBody>
       </p:sp>
@@ -2264,7 +2237,7 @@
           <a:p>
             <a:pPr lvl="0"/>
             <a:r>
-              <a:rPr lang="en-US"/>
+              <a:rPr lang="en-US" smtClean="0"/>
               <a:t>Click to edit Master text styles</a:t>
             </a:r>
           </a:p>
@@ -2287,7 +2260,7 @@
           <a:p>
             <a:fld id="{5BCAD085-E8A6-8845-BD4E-CB4CCA059FC4}" type="datetimeFigureOut">
               <a:rPr lang="en-US" smtClean="0"/>
-              <a:t>4/18/2026</a:t>
+              <a:t>1/27/13</a:t>
             </a:fld>
             <a:endParaRPr lang="en-US"/>
           </a:p>
@@ -2390,9 +2363,10 @@
           </a:lstStyle>
           <a:p>
             <a:r>
-              <a:rPr lang="en-US"/>
+              <a:rPr lang="en-US" smtClean="0"/>
               <a:t>Click to edit Master title style</a:t>
             </a:r>
+            <a:endParaRPr lang="en-US"/>
           </a:p>
         </p:txBody>
       </p:sp>
@@ -2516,7 +2490,7 @@
           <a:p>
             <a:pPr lvl="0"/>
             <a:r>
-              <a:rPr lang="en-US"/>
+              <a:rPr lang="en-US" smtClean="0"/>
               <a:t>Click to edit Master text styles</a:t>
             </a:r>
           </a:p>
@@ -2539,7 +2513,7 @@
           <a:p>
             <a:fld id="{5BCAD085-E8A6-8845-BD4E-CB4CCA059FC4}" type="datetimeFigureOut">
               <a:rPr lang="en-US" smtClean="0"/>
-              <a:t>4/18/2026</a:t>
+              <a:t>1/27/13</a:t>
             </a:fld>
             <a:endParaRPr lang="en-US"/>
           </a:p>
@@ -2648,9 +2622,10 @@
           <a:lstStyle/>
           <a:p>
             <a:r>
-              <a:rPr lang="en-US"/>
+              <a:rPr lang="en-US" smtClean="0"/>
               <a:t>Click to edit Master title style</a:t>
             </a:r>
+            <a:endParaRPr lang="en-US"/>
           </a:p>
         </p:txBody>
       </p:sp>
@@ -2681,37 +2656,38 @@
           <a:p>
             <a:pPr lvl="0"/>
             <a:r>
-              <a:rPr lang="en-US"/>
+              <a:rPr lang="en-US" smtClean="0"/>
               <a:t>Click to edit Master text styles</a:t>
             </a:r>
           </a:p>
           <a:p>
             <a:pPr lvl="1"/>
             <a:r>
-              <a:rPr lang="en-US"/>
+              <a:rPr lang="en-US" smtClean="0"/>
               <a:t>Second level</a:t>
             </a:r>
           </a:p>
           <a:p>
             <a:pPr lvl="2"/>
             <a:r>
-              <a:rPr lang="en-US"/>
+              <a:rPr lang="en-US" smtClean="0"/>
               <a:t>Third level</a:t>
             </a:r>
           </a:p>
           <a:p>
             <a:pPr lvl="3"/>
             <a:r>
-              <a:rPr lang="en-US"/>
+              <a:rPr lang="en-US" smtClean="0"/>
               <a:t>Fourth level</a:t>
             </a:r>
           </a:p>
           <a:p>
             <a:pPr lvl="4"/>
             <a:r>
-              <a:rPr lang="en-US"/>
+              <a:rPr lang="en-US" smtClean="0"/>
               <a:t>Fifth level</a:t>
             </a:r>
+            <a:endParaRPr lang="en-US"/>
           </a:p>
         </p:txBody>
       </p:sp>
@@ -2750,7 +2726,7 @@
           <a:p>
             <a:fld id="{5BCAD085-E8A6-8845-BD4E-CB4CCA059FC4}" type="datetimeFigureOut">
               <a:rPr lang="en-US" smtClean="0"/>
-              <a:t>4/18/2026</a:t>
+              <a:t>1/27/13</a:t>
             </a:fld>
             <a:endParaRPr lang="en-US"/>
           </a:p>
@@ -3109,7 +3085,7 @@
 </file>
 
 <file path=ppt/slides/slide1.xml><?xml version="1.0" encoding="utf-8"?>
-<p:sld xmlns:a="http://schemas.openxmlformats.org/drawingml/2006/main" xmlns:r="http://schemas.openxmlformats.org/officeDocument/2006/relationships" xmlns:p="http://schemas.openxmlformats.org/presentationml/2006/main">
+<p:sld xmlns:a="http://schemas.openxmlformats.org/drawingml/2006/main" xmlns:p="http://schemas.openxmlformats.org/presentationml/2006/main" xmlns:r="http://schemas.openxmlformats.org/officeDocument/2006/relationships">
   <p:cSld>
     <p:bg>
       <p:bgPr>
@@ -3125,14 +3101,7 @@
         <p:cNvGrpSpPr/>
         <p:nvPr/>
       </p:nvGrpSpPr>
-      <p:grpSpPr>
-        <a:xfrm>
-          <a:off x="0" y="0"/>
-          <a:ext cx="0" cy="0"/>
-          <a:chOff x="0" y="0"/>
-          <a:chExt cx="0" cy="0"/>
-        </a:xfrm>
-      </p:grpSpPr>
+      <p:grpSpPr/>
       <p:sp>
         <p:nvSpPr>
           <p:cNvPr id="2" name="Oval 1"/>
@@ -3141,8 +3110,8 @@
         </p:nvSpPr>
         <p:spPr>
           <a:xfrm>
-            <a:off x="8991375" y="-457200"/>
-            <a:ext cx="2743131" cy="2743200"/>
+            <a:off x="9052333" y="-533400"/>
+            <a:ext cx="2590735" cy="2590799"/>
           </a:xfrm>
           <a:prstGeom prst="ellipse">
             <a:avLst/>
@@ -3173,7 +3142,6 @@
           <a:lstStyle/>
           <a:p>
             <a:pPr algn="ctr"/>
-            <a:endParaRPr/>
           </a:p>
         </p:txBody>
       </p:sp>
@@ -3185,8 +3153,8 @@
         </p:nvSpPr>
         <p:spPr>
           <a:xfrm>
-            <a:off x="9753356" y="4267200"/>
-            <a:ext cx="1676358" cy="1676400"/>
+            <a:off x="9814314" y="4267200"/>
+            <a:ext cx="1600159" cy="1600200"/>
           </a:xfrm>
           <a:prstGeom prst="ellipse">
             <a:avLst/>
@@ -3217,143 +3185,25 @@
           <a:lstStyle/>
           <a:p>
             <a:pPr algn="ctr"/>
-            <a:endParaRPr/>
-          </a:p>
-        </p:txBody>
-      </p:sp>
-      <p:sp>
-        <p:nvSpPr>
-          <p:cNvPr id="4" name="TextBox 3"/>
-          <p:cNvSpPr txBox="1"/>
-          <p:nvPr/>
-        </p:nvSpPr>
-        <p:spPr>
-          <a:xfrm>
-            <a:off x="640063" y="1371600"/>
-            <a:ext cx="7467413" cy="1905000"/>
-          </a:xfrm>
-          <a:prstGeom prst="rect">
-            <a:avLst/>
-          </a:prstGeom>
-          <a:noFill/>
-        </p:spPr>
-        <p:txBody>
-          <a:bodyPr wrap="square" lIns="50800" tIns="50800" rIns="50800" bIns="50800" anchor="t">
-            <a:normAutofit/>
-          </a:bodyPr>
-          <a:lstStyle/>
-          <a:p>
-            <a:pPr algn="l"/>
-            <a:r>
-              <a:rPr sz="3900" b="1">
-                <a:solidFill>
-                  <a:srgbClr val="1E2A2F"/>
-                </a:solidFill>
-                <a:latin typeface="Arial"/>
-              </a:rPr>
-              <a:t>Cross-City Urban Heat</a:t>
-            </a:r>
-          </a:p>
-          <a:p>
-            <a:pPr algn="l"/>
-            <a:r>
-              <a:rPr sz="3900" b="1">
-                <a:solidFill>
-                  <a:srgbClr val="1E2A2F"/>
-                </a:solidFill>
-                <a:latin typeface="Arial"/>
-              </a:rPr>
-              <a:t>Hotspot Prediction</a:t>
-            </a:r>
-          </a:p>
-        </p:txBody>
-      </p:sp>
-      <p:sp>
-        <p:nvSpPr>
-          <p:cNvPr id="5" name="TextBox 4"/>
-          <p:cNvSpPr txBox="1"/>
-          <p:nvPr/>
-        </p:nvSpPr>
-        <p:spPr>
-          <a:xfrm>
-            <a:off x="670543" y="3398520"/>
-            <a:ext cx="7010224" cy="365760"/>
-          </a:xfrm>
-          <a:prstGeom prst="rect">
-            <a:avLst/>
-          </a:prstGeom>
-          <a:noFill/>
-        </p:spPr>
-        <p:txBody>
-          <a:bodyPr wrap="square" lIns="50800" tIns="50800" rIns="50800" bIns="50800" anchor="t">
-            <a:normAutofit/>
-          </a:bodyPr>
-          <a:lstStyle/>
-          <a:p>
-            <a:pPr algn="l"/>
-            <a:r>
-              <a:rPr sz="2300" b="1">
-                <a:solidFill>
-                  <a:srgbClr val="9A402D"/>
-                </a:solidFill>
-                <a:latin typeface="Arial"/>
-              </a:rPr>
-              <a:t>Two ways to evaluate hotspot prediction</a:t>
-            </a:r>
-          </a:p>
-        </p:txBody>
-      </p:sp>
-      <p:sp>
-        <p:nvSpPr>
-          <p:cNvPr id="6" name="TextBox 5"/>
-          <p:cNvSpPr txBox="1"/>
-          <p:nvPr/>
-        </p:nvSpPr>
-        <p:spPr>
-          <a:xfrm>
-            <a:off x="670543" y="3855720"/>
-            <a:ext cx="5333866" cy="335280"/>
-          </a:xfrm>
-          <a:prstGeom prst="rect">
-            <a:avLst/>
-          </a:prstGeom>
-          <a:noFill/>
-        </p:spPr>
-        <p:txBody>
-          <a:bodyPr wrap="square" lIns="50800" tIns="50800" rIns="50800" bIns="50800" anchor="t">
-            <a:normAutofit/>
-          </a:bodyPr>
-          <a:lstStyle/>
-          <a:p>
-            <a:pPr algn="l"/>
-            <a:r>
-              <a:rPr sz="2300" b="1">
-                <a:solidFill>
-                  <a:srgbClr val="254D5A"/>
-                </a:solidFill>
-                <a:latin typeface="Arial"/>
-              </a:rPr>
-              <a:t>Max Clements | Nicholas Machado</a:t>
-            </a:r>
-          </a:p>
-        </p:txBody>
-      </p:sp>
-      <p:sp>
-        <p:nvSpPr>
-          <p:cNvPr id="7" name="Rounded Rectangle 6"/>
+          </a:p>
+        </p:txBody>
+      </p:sp>
+      <p:sp>
+        <p:nvSpPr>
+          <p:cNvPr id="4" name="Rounded Rectangle 3"/>
           <p:cNvSpPr/>
           <p:nvPr/>
         </p:nvSpPr>
         <p:spPr>
           <a:xfrm>
-            <a:off x="548626" y="6019800"/>
-            <a:ext cx="10362940" cy="457200"/>
+            <a:off x="670543" y="1066800"/>
+            <a:ext cx="3581310" cy="76200"/>
           </a:xfrm>
           <a:prstGeom prst="roundRect">
             <a:avLst/>
           </a:prstGeom>
           <a:solidFill>
-            <a:srgbClr val="EBE0CF"/>
+            <a:srgbClr val="D26B34"/>
           </a:solidFill>
           <a:ln>
             <a:noFill/>
@@ -3378,20 +3228,19 @@
           <a:lstStyle/>
           <a:p>
             <a:pPr algn="ctr"/>
-            <a:endParaRPr/>
-          </a:p>
-        </p:txBody>
-      </p:sp>
-      <p:sp>
-        <p:nvSpPr>
-          <p:cNvPr id="8" name="TextBox 7"/>
+          </a:p>
+        </p:txBody>
+      </p:sp>
+      <p:sp>
+        <p:nvSpPr>
+          <p:cNvPr id="5" name="TextBox 4"/>
           <p:cNvSpPr txBox="1"/>
           <p:nvPr/>
         </p:nvSpPr>
         <p:spPr>
           <a:xfrm>
-            <a:off x="731501" y="6126480"/>
-            <a:ext cx="9981950" cy="213360"/>
+            <a:off x="624824" y="1310640"/>
+            <a:ext cx="7467413" cy="1905000"/>
           </a:xfrm>
           <a:prstGeom prst="rect">
             <a:avLst/>
@@ -3399,7 +3248,167 @@
           <a:noFill/>
         </p:spPr>
         <p:txBody>
-          <a:bodyPr wrap="square" lIns="50800" tIns="50800" rIns="50800" bIns="50800" anchor="t">
+          <a:bodyPr wrap="square" lIns="50800" rIns="50800" tIns="50800" bIns="50800" anchor="t">
+            <a:normAutofit/>
+          </a:bodyPr>
+          <a:lstStyle/>
+          <a:p>
+            <a:pPr algn="l"/>
+            <a:r>
+              <a:rPr sz="4100" b="1">
+                <a:solidFill>
+                  <a:srgbClr val="1E2A2F"/>
+                </a:solidFill>
+                <a:latin typeface="Arial"/>
+              </a:rPr>
+              <a:t>Cross-City Urban Heat</a:t>
+            </a:r>
+          </a:p>
+          <a:p>
+            <a:pPr algn="l"/>
+            <a:r>
+              <a:rPr sz="4100" b="1">
+                <a:solidFill>
+                  <a:srgbClr val="1E2A2F"/>
+                </a:solidFill>
+                <a:latin typeface="Arial"/>
+              </a:rPr>
+              <a:t>Hotspot Prediction</a:t>
+            </a:r>
+          </a:p>
+        </p:txBody>
+      </p:sp>
+      <p:sp>
+        <p:nvSpPr>
+          <p:cNvPr id="6" name="TextBox 5"/>
+          <p:cNvSpPr txBox="1"/>
+          <p:nvPr/>
+        </p:nvSpPr>
+        <p:spPr>
+          <a:xfrm>
+            <a:off x="670543" y="3276600"/>
+            <a:ext cx="7010224" cy="365760"/>
+          </a:xfrm>
+          <a:prstGeom prst="rect">
+            <a:avLst/>
+          </a:prstGeom>
+          <a:noFill/>
+        </p:spPr>
+        <p:txBody>
+          <a:bodyPr wrap="square" lIns="50800" rIns="50800" tIns="50800" bIns="50800" anchor="t">
+            <a:normAutofit/>
+          </a:bodyPr>
+          <a:lstStyle/>
+          <a:p>
+            <a:pPr algn="l"/>
+            <a:r>
+              <a:rPr sz="2200" b="1">
+                <a:solidFill>
+                  <a:srgbClr val="9A402D"/>
+                </a:solidFill>
+                <a:latin typeface="Arial"/>
+              </a:rPr>
+              <a:t>Two ways to evaluate hotspot prediction</a:t>
+            </a:r>
+          </a:p>
+        </p:txBody>
+      </p:sp>
+      <p:sp>
+        <p:nvSpPr>
+          <p:cNvPr id="7" name="TextBox 6"/>
+          <p:cNvSpPr txBox="1"/>
+          <p:nvPr/>
+        </p:nvSpPr>
+        <p:spPr>
+          <a:xfrm>
+            <a:off x="670543" y="3749039"/>
+            <a:ext cx="5333866" cy="335280"/>
+          </a:xfrm>
+          <a:prstGeom prst="rect">
+            <a:avLst/>
+          </a:prstGeom>
+          <a:noFill/>
+        </p:spPr>
+        <p:txBody>
+          <a:bodyPr wrap="square" lIns="50800" rIns="50800" tIns="50800" bIns="50800" anchor="t">
+            <a:normAutofit/>
+          </a:bodyPr>
+          <a:lstStyle/>
+          <a:p>
+            <a:pPr algn="l"/>
+            <a:r>
+              <a:rPr sz="2100" b="1">
+                <a:solidFill>
+                  <a:srgbClr val="254D5A"/>
+                </a:solidFill>
+                <a:latin typeface="Arial"/>
+              </a:rPr>
+              <a:t>Max Clements | Nicholas Machado</a:t>
+            </a:r>
+          </a:p>
+        </p:txBody>
+      </p:sp>
+      <p:sp>
+        <p:nvSpPr>
+          <p:cNvPr id="8" name="Rounded Rectangle 7"/>
+          <p:cNvSpPr/>
+          <p:nvPr/>
+        </p:nvSpPr>
+        <p:spPr>
+          <a:xfrm>
+            <a:off x="548626" y="6019800"/>
+            <a:ext cx="10362940" cy="441960"/>
+          </a:xfrm>
+          <a:prstGeom prst="roundRect">
+            <a:avLst/>
+          </a:prstGeom>
+          <a:solidFill>
+            <a:srgbClr val="EBE0CF"/>
+          </a:solidFill>
+          <a:ln>
+            <a:noFill/>
+          </a:ln>
+        </p:spPr>
+        <p:style>
+          <a:lnRef idx="1">
+            <a:schemeClr val="accent1"/>
+          </a:lnRef>
+          <a:fillRef idx="3">
+            <a:schemeClr val="accent1"/>
+          </a:fillRef>
+          <a:effectRef idx="2">
+            <a:schemeClr val="accent1"/>
+          </a:effectRef>
+          <a:fontRef idx="minor">
+            <a:schemeClr val="lt1"/>
+          </a:fontRef>
+        </p:style>
+        <p:txBody>
+          <a:bodyPr rtlCol="0" anchor="ctr"/>
+          <a:lstStyle/>
+          <a:p>
+            <a:pPr algn="ctr"/>
+          </a:p>
+        </p:txBody>
+      </p:sp>
+      <p:sp>
+        <p:nvSpPr>
+          <p:cNvPr id="9" name="TextBox 8"/>
+          <p:cNvSpPr txBox="1"/>
+          <p:nvPr/>
+        </p:nvSpPr>
+        <p:spPr>
+          <a:xfrm>
+            <a:off x="731501" y="6126480"/>
+            <a:ext cx="9981950" cy="213360"/>
+          </a:xfrm>
+          <a:prstGeom prst="rect">
+            <a:avLst/>
+          </a:prstGeom>
+          <a:noFill/>
+        </p:spPr>
+        <p:txBody>
+          <a:bodyPr wrap="square" lIns="50800" rIns="50800" tIns="50800" bIns="50800" anchor="t">
             <a:normAutofit/>
           </a:bodyPr>
           <a:lstStyle/>
@@ -3426,7 +3435,7 @@
 </file>
 
 <file path=ppt/slides/slide2.xml><?xml version="1.0" encoding="utf-8"?>
-<p:sld xmlns:a="http://schemas.openxmlformats.org/drawingml/2006/main" xmlns:r="http://schemas.openxmlformats.org/officeDocument/2006/relationships" xmlns:p="http://schemas.openxmlformats.org/presentationml/2006/main">
+<p:sld xmlns:a="http://schemas.openxmlformats.org/drawingml/2006/main" xmlns:p="http://schemas.openxmlformats.org/presentationml/2006/main" xmlns:r="http://schemas.openxmlformats.org/officeDocument/2006/relationships">
   <p:cSld>
     <p:bg>
       <p:bgPr>
@@ -3442,14 +3451,7 @@
         <p:cNvGrpSpPr/>
         <p:nvPr/>
       </p:nvGrpSpPr>
-      <p:grpSpPr>
-        <a:xfrm>
-          <a:off x="0" y="0"/>
-          <a:ext cx="0" cy="0"/>
-          <a:chOff x="0" y="0"/>
-          <a:chExt cx="0" cy="0"/>
-        </a:xfrm>
-      </p:grpSpPr>
+      <p:grpSpPr/>
       <p:sp>
         <p:nvSpPr>
           <p:cNvPr id="2" name="TextBox 1"/>
@@ -3458,8 +3460,8 @@
         </p:nvSpPr>
         <p:spPr>
           <a:xfrm>
-            <a:off x="441948" y="320040"/>
-            <a:ext cx="8229394" cy="335280"/>
+            <a:off x="396230" y="274320"/>
+            <a:ext cx="9753356" cy="335280"/>
           </a:xfrm>
           <a:prstGeom prst="rect">
             <a:avLst/>
@@ -3467,7 +3469,7 @@
           <a:noFill/>
         </p:spPr>
         <p:txBody>
-          <a:bodyPr wrap="square" lIns="50800" tIns="50800" rIns="50800" bIns="50800" anchor="t">
+          <a:bodyPr wrap="square" lIns="50800" rIns="50800" tIns="50800" bIns="50800" anchor="t">
             <a:normAutofit/>
           </a:bodyPr>
           <a:lstStyle/>
@@ -3480,7 +3482,7 @@
                 </a:solidFill>
                 <a:latin typeface="Arial"/>
               </a:rPr>
-              <a:t>Research question + predictors</a:t>
+              <a:t>Research Question + Validation Design</a:t>
             </a:r>
           </a:p>
         </p:txBody>
@@ -3493,8 +3495,8 @@
         </p:nvSpPr>
         <p:spPr>
           <a:xfrm>
-            <a:off x="320031" y="853440"/>
-            <a:ext cx="11551631" cy="4175760"/>
+            <a:off x="320031" y="777240"/>
+            <a:ext cx="11551631" cy="5684520"/>
           </a:xfrm>
           <a:prstGeom prst="roundRect">
             <a:avLst/>
@@ -3527,13 +3529,12 @@
           <a:lstStyle/>
           <a:p>
             <a:pPr algn="ctr"/>
-            <a:endParaRPr/>
           </a:p>
         </p:txBody>
       </p:sp>
       <p:pic>
         <p:nvPicPr>
-          <p:cNvPr id="4" name="Picture 3" descr="research_question_predictors.png"/>
+          <p:cNvPr id="4" name="Picture 3" descr="setup_predictors_evaluation_questions.png"/>
           <p:cNvPicPr>
             <a:picLocks noChangeAspect="1"/>
           </p:cNvPicPr>
@@ -3547,95 +3548,14 @@
         </p:blipFill>
         <p:spPr>
           <a:xfrm>
-            <a:off x="487667" y="1005840"/>
-            <a:ext cx="11301210" cy="3840480"/>
+            <a:off x="487667" y="883920"/>
+            <a:ext cx="11216359" cy="5364480"/>
           </a:xfrm>
           <a:prstGeom prst="rect">
             <a:avLst/>
           </a:prstGeom>
         </p:spPr>
       </p:pic>
-      <p:sp>
-        <p:nvSpPr>
-          <p:cNvPr id="5" name="Rounded Rectangle 4"/>
-          <p:cNvSpPr/>
-          <p:nvPr/>
-        </p:nvSpPr>
-        <p:spPr>
-          <a:xfrm>
-            <a:off x="899137" y="5273040"/>
-            <a:ext cx="10362940" cy="487680"/>
-          </a:xfrm>
-          <a:prstGeom prst="roundRect">
-            <a:avLst/>
-          </a:prstGeom>
-          <a:solidFill>
-            <a:srgbClr val="EBE0CF"/>
-          </a:solidFill>
-          <a:ln w="10160">
-            <a:solidFill>
-              <a:srgbClr val="DBC7AA"/>
-            </a:solidFill>
-          </a:ln>
-        </p:spPr>
-        <p:style>
-          <a:lnRef idx="1">
-            <a:schemeClr val="accent1"/>
-          </a:lnRef>
-          <a:fillRef idx="3">
-            <a:schemeClr val="accent1"/>
-          </a:fillRef>
-          <a:effectRef idx="2">
-            <a:schemeClr val="accent1"/>
-          </a:effectRef>
-          <a:fontRef idx="minor">
-            <a:schemeClr val="lt1"/>
-          </a:fontRef>
-        </p:style>
-        <p:txBody>
-          <a:bodyPr rtlCol="0" anchor="ctr"/>
-          <a:lstStyle/>
-          <a:p>
-            <a:pPr algn="ctr"/>
-            <a:endParaRPr/>
-          </a:p>
-        </p:txBody>
-      </p:sp>
-      <p:sp>
-        <p:nvSpPr>
-          <p:cNvPr id="6" name="TextBox 5"/>
-          <p:cNvSpPr txBox="1"/>
-          <p:nvPr/>
-        </p:nvSpPr>
-        <p:spPr>
-          <a:xfrm>
-            <a:off x="1142971" y="5379720"/>
-            <a:ext cx="9829554" cy="259080"/>
-          </a:xfrm>
-          <a:prstGeom prst="rect">
-            <a:avLst/>
-          </a:prstGeom>
-          <a:noFill/>
-        </p:spPr>
-        <p:txBody>
-          <a:bodyPr wrap="square" lIns="50800" tIns="50800" rIns="50800" bIns="50800" anchor="t">
-            <a:normAutofit/>
-          </a:bodyPr>
-          <a:lstStyle/>
-          <a:p>
-            <a:pPr algn="ctr"/>
-            <a:r>
-              <a:rPr sz="1800" b="1">
-                <a:solidFill>
-                  <a:srgbClr val="254D5A"/>
-                </a:solidFill>
-                <a:latin typeface="Arial"/>
-              </a:rPr>
-              <a:t>The target is city-relative: the hottest 10% of 30 m cells within each city.</a:t>
-            </a:r>
-          </a:p>
-        </p:txBody>
-      </p:sp>
     </p:spTree>
   </p:cSld>
   <p:clrMapOvr>
@@ -3645,7 +3565,7 @@
 </file>
 
 <file path=ppt/slides/slide3.xml><?xml version="1.0" encoding="utf-8"?>
-<p:sld xmlns:a="http://schemas.openxmlformats.org/drawingml/2006/main" xmlns:r="http://schemas.openxmlformats.org/officeDocument/2006/relationships" xmlns:p="http://schemas.openxmlformats.org/presentationml/2006/main">
+<p:sld xmlns:a="http://schemas.openxmlformats.org/drawingml/2006/main" xmlns:p="http://schemas.openxmlformats.org/presentationml/2006/main" xmlns:r="http://schemas.openxmlformats.org/officeDocument/2006/relationships">
   <p:cSld>
     <p:bg>
       <p:bgPr>
@@ -3661,14 +3581,7 @@
         <p:cNvGrpSpPr/>
         <p:nvPr/>
       </p:nvGrpSpPr>
-      <p:grpSpPr>
-        <a:xfrm>
-          <a:off x="0" y="0"/>
-          <a:ext cx="0" cy="0"/>
-          <a:chOff x="0" y="0"/>
-          <a:chExt cx="0" cy="0"/>
-        </a:xfrm>
-      </p:grpSpPr>
+      <p:grpSpPr/>
       <p:sp>
         <p:nvSpPr>
           <p:cNvPr id="2" name="TextBox 1"/>
@@ -3677,7 +3590,7 @@
         </p:nvSpPr>
         <p:spPr>
           <a:xfrm>
-            <a:off x="441948" y="320040"/>
+            <a:off x="396230" y="274320"/>
             <a:ext cx="7467413" cy="335280"/>
           </a:xfrm>
           <a:prstGeom prst="rect">
@@ -3686,7 +3599,7 @@
           <a:noFill/>
         </p:spPr>
         <p:txBody>
-          <a:bodyPr wrap="square" lIns="50800" tIns="50800" rIns="50800" bIns="50800" anchor="t">
+          <a:bodyPr wrap="square" lIns="50800" rIns="50800" tIns="50800" bIns="50800" anchor="t">
             <a:normAutofit/>
           </a:bodyPr>
           <a:lstStyle/>
@@ -3699,7 +3612,7 @@
                 </a:solidFill>
                 <a:latin typeface="Arial"/>
               </a:rPr>
-              <a:t>Two evaluation questions</a:t>
+              <a:t>Modeling Section: Logistic vs Random Forest</a:t>
             </a:r>
           </a:p>
         </p:txBody>
@@ -3712,8 +3625,8 @@
         </p:nvSpPr>
         <p:spPr>
           <a:xfrm>
-            <a:off x="320031" y="853440"/>
-            <a:ext cx="11551631" cy="4404360"/>
+            <a:off x="320031" y="777240"/>
+            <a:ext cx="11551631" cy="5684520"/>
           </a:xfrm>
           <a:prstGeom prst="roundRect">
             <a:avLst/>
@@ -3746,13 +3659,12 @@
           <a:lstStyle/>
           <a:p>
             <a:pPr algn="ctr"/>
-            <a:endParaRPr/>
           </a:p>
         </p:txBody>
       </p:sp>
       <p:pic>
         <p:nvPicPr>
-          <p:cNvPr id="4" name="Picture 3" descr="two_evaluation_questions.png"/>
+          <p:cNvPr id="4" name="Picture 3" descr="logistic_rf_model_math.png"/>
           <p:cNvPicPr>
             <a:picLocks noChangeAspect="1"/>
           </p:cNvPicPr>
@@ -3766,49 +3678,14 @@
         </p:blipFill>
         <p:spPr>
           <a:xfrm>
-            <a:off x="487667" y="990599"/>
-            <a:ext cx="11216359" cy="4069080"/>
+            <a:off x="487667" y="883920"/>
+            <a:ext cx="11216359" cy="5364480"/>
           </a:xfrm>
           <a:prstGeom prst="rect">
             <a:avLst/>
           </a:prstGeom>
         </p:spPr>
       </p:pic>
-      <p:sp>
-        <p:nvSpPr>
-          <p:cNvPr id="5" name="TextBox 4"/>
-          <p:cNvSpPr txBox="1"/>
-          <p:nvPr/>
-        </p:nvSpPr>
-        <p:spPr>
-          <a:xfrm>
-            <a:off x="990575" y="5516880"/>
-            <a:ext cx="10210544" cy="274320"/>
-          </a:xfrm>
-          <a:prstGeom prst="rect">
-            <a:avLst/>
-          </a:prstGeom>
-          <a:noFill/>
-        </p:spPr>
-        <p:txBody>
-          <a:bodyPr wrap="square" lIns="50800" tIns="50800" rIns="50800" bIns="50800" anchor="t">
-            <a:normAutofit/>
-          </a:bodyPr>
-          <a:lstStyle/>
-          <a:p>
-            <a:pPr algn="ctr"/>
-            <a:r>
-              <a:rPr sz="1800" b="1">
-                <a:solidFill>
-                  <a:srgbClr val="254D5A"/>
-                </a:solidFill>
-                <a:latin typeface="Arial"/>
-              </a:rPr>
-              <a:t>The split design changes the use case being measured.</a:t>
-            </a:r>
-          </a:p>
-        </p:txBody>
-      </p:sp>
     </p:spTree>
   </p:cSld>
   <p:clrMapOvr>
@@ -3818,7 +3695,7 @@
 </file>
 
 <file path=ppt/slides/slide4.xml><?xml version="1.0" encoding="utf-8"?>
-<p:sld xmlns:a="http://schemas.openxmlformats.org/drawingml/2006/main" xmlns:r="http://schemas.openxmlformats.org/officeDocument/2006/relationships" xmlns:p="http://schemas.openxmlformats.org/presentationml/2006/main">
+<p:sld xmlns:a="http://schemas.openxmlformats.org/drawingml/2006/main" xmlns:p="http://schemas.openxmlformats.org/presentationml/2006/main" xmlns:r="http://schemas.openxmlformats.org/officeDocument/2006/relationships">
   <p:cSld>
     <p:bg>
       <p:bgPr>
@@ -3834,14 +3711,7 @@
         <p:cNvGrpSpPr/>
         <p:nvPr/>
       </p:nvGrpSpPr>
-      <p:grpSpPr>
-        <a:xfrm>
-          <a:off x="0" y="0"/>
-          <a:ext cx="0" cy="0"/>
-          <a:chOff x="0" y="0"/>
-          <a:chExt cx="0" cy="0"/>
-        </a:xfrm>
-      </p:grpSpPr>
+      <p:grpSpPr/>
       <p:sp>
         <p:nvSpPr>
           <p:cNvPr id="2" name="TextBox 1"/>
@@ -3851,7 +3721,7 @@
         <p:spPr>
           <a:xfrm>
             <a:off x="396230" y="274320"/>
-            <a:ext cx="8381790" cy="457200"/>
+            <a:ext cx="10058148" cy="457200"/>
           </a:xfrm>
           <a:prstGeom prst="rect">
             <a:avLst/>
@@ -3859,7 +3729,7 @@
           <a:noFill/>
         </p:spPr>
         <p:txBody>
-          <a:bodyPr wrap="square" lIns="50800" tIns="50800" rIns="50800" bIns="50800" anchor="t">
+          <a:bodyPr wrap="square" lIns="50800" rIns="50800" tIns="50800" bIns="50800" anchor="t">
             <a:normAutofit/>
           </a:bodyPr>
           <a:lstStyle/>
@@ -3872,7 +3742,7 @@
                 </a:solidFill>
                 <a:latin typeface="Arial"/>
               </a:rPr>
-              <a:t>Within-city held-out evaluation</a:t>
+              <a:t>Results Side by Side</a:t>
             </a:r>
           </a:p>
         </p:txBody>
@@ -3885,8 +3755,8 @@
         </p:nvSpPr>
         <p:spPr>
           <a:xfrm>
-            <a:off x="335271" y="853440"/>
-            <a:ext cx="11521151" cy="4114800"/>
+            <a:off x="335271" y="777240"/>
+            <a:ext cx="11521151" cy="5684520"/>
           </a:xfrm>
           <a:prstGeom prst="roundRect">
             <a:avLst/>
@@ -3919,13 +3789,12 @@
           <a:lstStyle/>
           <a:p>
             <a:pPr algn="ctr"/>
-            <a:endParaRPr/>
           </a:p>
         </p:txBody>
       </p:sp>
       <p:pic>
         <p:nvPicPr>
-          <p:cNvPr id="4" name="Picture 3" descr="within_city_hotspot_results.png"/>
+          <p:cNvPr id="4" name="Picture 3" descr="within_city_vs_transfer_results.png"/>
           <p:cNvPicPr>
             <a:picLocks noChangeAspect="1"/>
           </p:cNvPicPr>
@@ -3939,95 +3808,14 @@
         </p:blipFill>
         <p:spPr>
           <a:xfrm>
-            <a:off x="640063" y="1005840"/>
-            <a:ext cx="10911567" cy="3779519"/>
+            <a:off x="533386" y="883920"/>
+            <a:ext cx="11124921" cy="5364480"/>
           </a:xfrm>
           <a:prstGeom prst="rect">
             <a:avLst/>
           </a:prstGeom>
         </p:spPr>
       </p:pic>
-      <p:sp>
-        <p:nvSpPr>
-          <p:cNvPr id="5" name="Rounded Rectangle 4"/>
-          <p:cNvSpPr/>
-          <p:nvPr/>
-        </p:nvSpPr>
-        <p:spPr>
-          <a:xfrm>
-            <a:off x="655303" y="5212080"/>
-            <a:ext cx="10881087" cy="563880"/>
-          </a:xfrm>
-          <a:prstGeom prst="roundRect">
-            <a:avLst/>
-          </a:prstGeom>
-          <a:solidFill>
-            <a:srgbClr val="EBE0CF"/>
-          </a:solidFill>
-          <a:ln w="10160">
-            <a:solidFill>
-              <a:srgbClr val="DBC7AA"/>
-            </a:solidFill>
-          </a:ln>
-        </p:spPr>
-        <p:style>
-          <a:lnRef idx="1">
-            <a:schemeClr val="accent1"/>
-          </a:lnRef>
-          <a:fillRef idx="3">
-            <a:schemeClr val="accent1"/>
-          </a:fillRef>
-          <a:effectRef idx="2">
-            <a:schemeClr val="accent1"/>
-          </a:effectRef>
-          <a:fontRef idx="minor">
-            <a:schemeClr val="lt1"/>
-          </a:fontRef>
-        </p:style>
-        <p:txBody>
-          <a:bodyPr rtlCol="0" anchor="ctr"/>
-          <a:lstStyle/>
-          <a:p>
-            <a:pPr algn="ctr"/>
-            <a:endParaRPr/>
-          </a:p>
-        </p:txBody>
-      </p:sp>
-      <p:sp>
-        <p:nvSpPr>
-          <p:cNvPr id="6" name="TextBox 5"/>
-          <p:cNvSpPr txBox="1"/>
-          <p:nvPr/>
-        </p:nvSpPr>
-        <p:spPr>
-          <a:xfrm>
-            <a:off x="960095" y="5318760"/>
-            <a:ext cx="10271503" cy="289560"/>
-          </a:xfrm>
-          <a:prstGeom prst="rect">
-            <a:avLst/>
-          </a:prstGeom>
-          <a:noFill/>
-        </p:spPr>
-        <p:txBody>
-          <a:bodyPr wrap="square" lIns="50800" tIns="50800" rIns="50800" bIns="50800" anchor="t">
-            <a:normAutofit/>
-          </a:bodyPr>
-          <a:lstStyle/>
-          <a:p>
-            <a:pPr algn="ctr"/>
-            <a:r>
-              <a:rPr sz="1800" b="0">
-                <a:solidFill>
-                  <a:srgbClr val="5C696D"/>
-                </a:solidFill>
-                <a:latin typeface="Arial"/>
-              </a:rPr>
-              <a:t>We treat these results as within-city / row-level evidence because support counts are about 30% of each city's rows.</a:t>
-            </a:r>
-          </a:p>
-        </p:txBody>
-      </p:sp>
     </p:spTree>
   </p:cSld>
   <p:clrMapOvr>
@@ -4037,7 +3825,7 @@
 </file>
 
 <file path=ppt/slides/slide5.xml><?xml version="1.0" encoding="utf-8"?>
-<p:sld xmlns:a="http://schemas.openxmlformats.org/drawingml/2006/main" xmlns:r="http://schemas.openxmlformats.org/officeDocument/2006/relationships" xmlns:p="http://schemas.openxmlformats.org/presentationml/2006/main">
+<p:sld xmlns:a="http://schemas.openxmlformats.org/drawingml/2006/main" xmlns:p="http://schemas.openxmlformats.org/presentationml/2006/main" xmlns:r="http://schemas.openxmlformats.org/officeDocument/2006/relationships">
   <p:cSld>
     <p:bg>
       <p:bgPr>
@@ -4053,14 +3841,7 @@
         <p:cNvGrpSpPr/>
         <p:nvPr/>
       </p:nvGrpSpPr>
-      <p:grpSpPr>
-        <a:xfrm>
-          <a:off x="0" y="0"/>
-          <a:ext cx="0" cy="0"/>
-          <a:chOff x="0" y="0"/>
-          <a:chExt cx="0" cy="0"/>
-        </a:xfrm>
-      </p:grpSpPr>
+      <p:grpSpPr/>
       <p:sp>
         <p:nvSpPr>
           <p:cNvPr id="2" name="TextBox 1"/>
@@ -4078,7 +3859,7 @@
           <a:noFill/>
         </p:spPr>
         <p:txBody>
-          <a:bodyPr wrap="square" lIns="50800" tIns="50800" rIns="50800" bIns="50800" anchor="t">
+          <a:bodyPr wrap="square" lIns="50800" rIns="50800" tIns="50800" bIns="50800" anchor="t">
             <a:normAutofit/>
           </a:bodyPr>
           <a:lstStyle/>
@@ -4091,7 +3872,7 @@
                 </a:solidFill>
                 <a:latin typeface="Arial"/>
               </a:rPr>
-              <a:t>City-held-out transfer evaluation</a:t>
+              <a:t>City-Level Signal Shifts Across Evaluation Designs</a:t>
             </a:r>
           </a:p>
         </p:txBody>
@@ -4104,8 +3885,8 @@
         </p:nvSpPr>
         <p:spPr>
           <a:xfrm>
-            <a:off x="335271" y="853440"/>
-            <a:ext cx="11521151" cy="4114800"/>
+            <a:off x="335271" y="777240"/>
+            <a:ext cx="11521151" cy="5684520"/>
           </a:xfrm>
           <a:prstGeom prst="roundRect">
             <a:avLst/>
@@ -4138,13 +3919,12 @@
           <a:lstStyle/>
           <a:p>
             <a:pPr algn="ctr"/>
-            <a:endParaRPr/>
           </a:p>
         </p:txBody>
       </p:sp>
       <p:pic>
         <p:nvPicPr>
-          <p:cNvPr id="4" name="Picture 3" descr="city_heldout_transfer_results.png"/>
+          <p:cNvPr id="4" name="Picture 3" descr="city_signal_transfer_relationship.png"/>
           <p:cNvPicPr>
             <a:picLocks noChangeAspect="1"/>
           </p:cNvPicPr>
@@ -4158,95 +3938,14 @@
         </p:blipFill>
         <p:spPr>
           <a:xfrm>
-            <a:off x="640063" y="1005840"/>
-            <a:ext cx="10911567" cy="3779519"/>
+            <a:off x="533386" y="883920"/>
+            <a:ext cx="11124921" cy="5364480"/>
           </a:xfrm>
           <a:prstGeom prst="rect">
             <a:avLst/>
           </a:prstGeom>
         </p:spPr>
       </p:pic>
-      <p:sp>
-        <p:nvSpPr>
-          <p:cNvPr id="5" name="Rounded Rectangle 4"/>
-          <p:cNvSpPr/>
-          <p:nvPr/>
-        </p:nvSpPr>
-        <p:spPr>
-          <a:xfrm>
-            <a:off x="655303" y="5212080"/>
-            <a:ext cx="10881087" cy="563880"/>
-          </a:xfrm>
-          <a:prstGeom prst="roundRect">
-            <a:avLst/>
-          </a:prstGeom>
-          <a:solidFill>
-            <a:srgbClr val="EBE0CF"/>
-          </a:solidFill>
-          <a:ln w="10160">
-            <a:solidFill>
-              <a:srgbClr val="DBC7AA"/>
-            </a:solidFill>
-          </a:ln>
-        </p:spPr>
-        <p:style>
-          <a:lnRef idx="1">
-            <a:schemeClr val="accent1"/>
-          </a:lnRef>
-          <a:fillRef idx="3">
-            <a:schemeClr val="accent1"/>
-          </a:fillRef>
-          <a:effectRef idx="2">
-            <a:schemeClr val="accent1"/>
-          </a:effectRef>
-          <a:fontRef idx="minor">
-            <a:schemeClr val="lt1"/>
-          </a:fontRef>
-        </p:style>
-        <p:txBody>
-          <a:bodyPr rtlCol="0" anchor="ctr"/>
-          <a:lstStyle/>
-          <a:p>
-            <a:pPr algn="ctr"/>
-            <a:endParaRPr/>
-          </a:p>
-        </p:txBody>
-      </p:sp>
-      <p:sp>
-        <p:nvSpPr>
-          <p:cNvPr id="6" name="TextBox 5"/>
-          <p:cNvSpPr txBox="1"/>
-          <p:nvPr/>
-        </p:nvSpPr>
-        <p:spPr>
-          <a:xfrm>
-            <a:off x="960095" y="5318760"/>
-            <a:ext cx="10271503" cy="289560"/>
-          </a:xfrm>
-          <a:prstGeom prst="rect">
-            <a:avLst/>
-          </a:prstGeom>
-          <a:noFill/>
-        </p:spPr>
-        <p:txBody>
-          <a:bodyPr wrap="square" lIns="50800" tIns="50800" rIns="50800" bIns="50800" anchor="t">
-            <a:normAutofit/>
-          </a:bodyPr>
-          <a:lstStyle/>
-          <a:p>
-            <a:pPr algn="ctr"/>
-            <a:r>
-              <a:rPr sz="1800" b="0">
-                <a:solidFill>
-                  <a:srgbClr val="5C696D"/>
-                </a:solidFill>
-                <a:latin typeface="Arial"/>
-              </a:rPr>
-              <a:t>To measure transfer to new cities, whole cities are withheld during model fitting and tuning.</a:t>
-            </a:r>
-          </a:p>
-        </p:txBody>
-      </p:sp>
     </p:spTree>
   </p:cSld>
   <p:clrMapOvr>
@@ -4256,7 +3955,7 @@
 </file>
 
 <file path=ppt/slides/slide6.xml><?xml version="1.0" encoding="utf-8"?>
-<p:sld xmlns:a="http://schemas.openxmlformats.org/drawingml/2006/main" xmlns:r="http://schemas.openxmlformats.org/officeDocument/2006/relationships" xmlns:p="http://schemas.openxmlformats.org/presentationml/2006/main">
+<p:sld xmlns:a="http://schemas.openxmlformats.org/drawingml/2006/main" xmlns:p="http://schemas.openxmlformats.org/presentationml/2006/main" xmlns:r="http://schemas.openxmlformats.org/officeDocument/2006/relationships">
   <p:cSld>
     <p:bg>
       <p:bgPr>
@@ -4272,14 +3971,7 @@
         <p:cNvGrpSpPr/>
         <p:nvPr/>
       </p:nvGrpSpPr>
-      <p:grpSpPr>
-        <a:xfrm>
-          <a:off x="0" y="0"/>
-          <a:ext cx="0" cy="0"/>
-          <a:chOff x="0" y="0"/>
-          <a:chExt cx="0" cy="0"/>
-        </a:xfrm>
-      </p:grpSpPr>
+      <p:grpSpPr/>
       <p:sp>
         <p:nvSpPr>
           <p:cNvPr id="2" name="TextBox 1"/>
@@ -4288,8 +3980,8 @@
         </p:nvSpPr>
         <p:spPr>
           <a:xfrm>
-            <a:off x="396230" y="320040"/>
-            <a:ext cx="11124921" cy="548640"/>
+            <a:off x="396230" y="274320"/>
+            <a:ext cx="11124921" cy="457200"/>
           </a:xfrm>
           <a:prstGeom prst="rect">
             <a:avLst/>
@@ -4297,7 +3989,7 @@
           <a:noFill/>
         </p:spPr>
         <p:txBody>
-          <a:bodyPr wrap="square" lIns="50800" tIns="50800" rIns="50800" bIns="50800" anchor="t">
+          <a:bodyPr wrap="square" lIns="50800" rIns="50800" tIns="50800" bIns="50800" anchor="t">
             <a:normAutofit/>
           </a:bodyPr>
           <a:lstStyle/>
@@ -4310,7 +4002,7 @@
                 </a:solidFill>
                 <a:latin typeface="Arial"/>
               </a:rPr>
-              <a:t>What the contrast shows</a:t>
+              <a:t>Held-Out Denver Map Example</a:t>
             </a:r>
           </a:p>
         </p:txBody>
@@ -4323,8 +4015,8 @@
         </p:nvSpPr>
         <p:spPr>
           <a:xfrm>
-            <a:off x="335271" y="944879"/>
-            <a:ext cx="11521151" cy="4297680"/>
+            <a:off x="335271" y="777240"/>
+            <a:ext cx="11521151" cy="5684520"/>
           </a:xfrm>
           <a:prstGeom prst="roundRect">
             <a:avLst/>
@@ -4357,13 +4049,12 @@
           <a:lstStyle/>
           <a:p>
             <a:pPr algn="ctr"/>
-            <a:endParaRPr/>
           </a:p>
         </p:txBody>
       </p:sp>
       <p:pic>
         <p:nvPicPr>
-          <p:cNvPr id="4" name="Picture 3" descr="evaluation_contrast_takeaway.png"/>
+          <p:cNvPr id="4" name="Picture 3" descr="heldout_denver_map_focus.png"/>
           <p:cNvPicPr>
             <a:picLocks noChangeAspect="1"/>
           </p:cNvPicPr>
@@ -4377,49 +4068,14 @@
         </p:blipFill>
         <p:spPr>
           <a:xfrm>
-            <a:off x="518147" y="1097280"/>
-            <a:ext cx="11155401" cy="3947160"/>
+            <a:off x="533386" y="883920"/>
+            <a:ext cx="11124921" cy="5364480"/>
           </a:xfrm>
           <a:prstGeom prst="rect">
             <a:avLst/>
           </a:prstGeom>
         </p:spPr>
       </p:pic>
-      <p:sp>
-        <p:nvSpPr>
-          <p:cNvPr id="5" name="TextBox 4"/>
-          <p:cNvSpPr txBox="1"/>
-          <p:nvPr/>
-        </p:nvSpPr>
-        <p:spPr>
-          <a:xfrm>
-            <a:off x="1142971" y="5516880"/>
-            <a:ext cx="9905752" cy="274320"/>
-          </a:xfrm>
-          <a:prstGeom prst="rect">
-            <a:avLst/>
-          </a:prstGeom>
-          <a:noFill/>
-        </p:spPr>
-        <p:txBody>
-          <a:bodyPr wrap="square" lIns="50800" tIns="50800" rIns="50800" bIns="50800" anchor="t">
-            <a:normAutofit/>
-          </a:bodyPr>
-          <a:lstStyle/>
-          <a:p>
-            <a:pPr algn="ctr"/>
-            <a:r>
-              <a:rPr sz="1900" b="1">
-                <a:solidFill>
-                  <a:srgbClr val="254D5A"/>
-                </a:solidFill>
-                <a:latin typeface="Arial"/>
-              </a:rPr>
-              <a:t>Basic factors contain real hotspot signal, but transfer to unseen cities is the hard part.</a:t>
-            </a:r>
-          </a:p>
-        </p:txBody>
-      </p:sp>
     </p:spTree>
   </p:cSld>
   <p:clrMapOvr>
@@ -4429,7 +4085,7 @@
 </file>
 
 <file path=ppt/slides/slide7.xml><?xml version="1.0" encoding="utf-8"?>
-<p:sld xmlns:a="http://schemas.openxmlformats.org/drawingml/2006/main" xmlns:r="http://schemas.openxmlformats.org/officeDocument/2006/relationships" xmlns:p="http://schemas.openxmlformats.org/presentationml/2006/main">
+<p:sld xmlns:a="http://schemas.openxmlformats.org/drawingml/2006/main" xmlns:p="http://schemas.openxmlformats.org/presentationml/2006/main" xmlns:r="http://schemas.openxmlformats.org/officeDocument/2006/relationships">
   <p:cSld>
     <p:bg>
       <p:bgPr>
@@ -4445,14 +4101,7 @@
         <p:cNvGrpSpPr/>
         <p:nvPr/>
       </p:nvGrpSpPr>
-      <p:grpSpPr>
-        <a:xfrm>
-          <a:off x="0" y="0"/>
-          <a:ext cx="0" cy="0"/>
-          <a:chOff x="0" y="0"/>
-          <a:chExt cx="0" cy="0"/>
-        </a:xfrm>
-      </p:grpSpPr>
+      <p:grpSpPr/>
       <p:sp>
         <p:nvSpPr>
           <p:cNvPr id="2" name="Oval 1"/>
@@ -4493,7 +4142,6 @@
           <a:lstStyle/>
           <a:p>
             <a:pPr algn="ctr"/>
-            <a:endParaRPr/>
           </a:p>
         </p:txBody>
       </p:sp>
@@ -4505,8 +4153,8 @@
         </p:nvSpPr>
         <p:spPr>
           <a:xfrm>
-            <a:off x="9753356" y="4267200"/>
-            <a:ext cx="1676358" cy="1676400"/>
+            <a:off x="9814314" y="4267200"/>
+            <a:ext cx="1600159" cy="1600200"/>
           </a:xfrm>
           <a:prstGeom prst="ellipse">
             <a:avLst/>
@@ -4537,7 +4185,6 @@
           <a:lstStyle/>
           <a:p>
             <a:pPr algn="ctr"/>
-            <a:endParaRPr/>
           </a:p>
         </p:txBody>
       </p:sp>
@@ -4549,8 +4196,8 @@
         </p:nvSpPr>
         <p:spPr>
           <a:xfrm>
-            <a:off x="594345" y="1874519"/>
-            <a:ext cx="4267093" cy="670560"/>
+            <a:off x="640063" y="2164080"/>
+            <a:ext cx="4571885" cy="716280"/>
           </a:xfrm>
           <a:prstGeom prst="rect">
             <a:avLst/>
@@ -4558,7 +4205,7 @@
           <a:noFill/>
         </p:spPr>
         <p:txBody>
-          <a:bodyPr wrap="square" lIns="50800" tIns="50800" rIns="50800" bIns="50800" anchor="t">
+          <a:bodyPr wrap="square" lIns="50800" rIns="50800" tIns="50800" bIns="50800" anchor="t">
             <a:normAutofit/>
           </a:bodyPr>
           <a:lstStyle/>

</xml_diff>

<commit_message>
Create final report planning scaffold
</commit_message>
<xml_diff>
--- a/docs/presentation_2026/urban_heat_transfer_presentation.pptx
+++ b/docs/presentation_2026/urban_heat_transfer_presentation.pptx
@@ -5,15 +5,15 @@
     <p:sldMasterId id="2147483648" r:id="rId1"/>
   </p:sldMasterIdLst>
   <p:sldIdLst>
-    <p:sldId id="256" r:id="rId7"/>
-    <p:sldId id="257" r:id="rId8"/>
-    <p:sldId id="258" r:id="rId9"/>
-    <p:sldId id="259" r:id="rId10"/>
-    <p:sldId id="260" r:id="rId11"/>
-    <p:sldId id="261" r:id="rId12"/>
-    <p:sldId id="262" r:id="rId13"/>
+    <p:sldId id="256" r:id="rId2"/>
+    <p:sldId id="257" r:id="rId3"/>
+    <p:sldId id="258" r:id="rId4"/>
+    <p:sldId id="259" r:id="rId5"/>
+    <p:sldId id="260" r:id="rId6"/>
+    <p:sldId id="261" r:id="rId7"/>
+    <p:sldId id="262" r:id="rId8"/>
   </p:sldIdLst>
-  <p:sldSz cx="12191695" cy="6858000" type="screen4x3"/>
+  <p:sldSz cx="12192000" cy="6858000"/>
   <p:notesSz cx="6858000" cy="9144000"/>
   <p:defaultTextStyle>
     <a:defPPr>
@@ -110,6 +110,22 @@
       </a:defRPr>
     </a:lvl9pPr>
   </p:defaultTextStyle>
+  <p:extLst>
+    <p:ext uri="{EFAFB233-063F-42B5-8137-9DF3F51BA10A}">
+      <p15:sldGuideLst xmlns:p15="http://schemas.microsoft.com/office/powerpoint/2012/main">
+        <p15:guide id="1" orient="horz" pos="2160">
+          <p15:clr>
+            <a:srgbClr val="A4A3A4"/>
+          </p15:clr>
+        </p15:guide>
+        <p15:guide id="2" pos="2880">
+          <p15:clr>
+            <a:srgbClr val="A4A3A4"/>
+          </p15:clr>
+        </p15:guide>
+      </p15:sldGuideLst>
+    </p:ext>
+  </p:extLst>
 </p:presentation>
 </file>
 
@@ -151,10 +167,9 @@
           <a:lstStyle/>
           <a:p>
             <a:r>
-              <a:rPr lang="en-US" smtClean="0"/>
+              <a:rPr lang="en-US"/>
               <a:t>Click to edit Master title style</a:t>
             </a:r>
-            <a:endParaRPr lang="en-US"/>
           </a:p>
         </p:txBody>
       </p:sp>
@@ -270,10 +285,9 @@
           </a:lstStyle>
           <a:p>
             <a:r>
-              <a:rPr lang="en-US" smtClean="0"/>
+              <a:rPr lang="en-US"/>
               <a:t>Click to edit Master subtitle style</a:t>
             </a:r>
-            <a:endParaRPr lang="en-US"/>
           </a:p>
         </p:txBody>
       </p:sp>
@@ -294,7 +308,7 @@
           <a:p>
             <a:fld id="{5BCAD085-E8A6-8845-BD4E-CB4CCA059FC4}" type="datetimeFigureOut">
               <a:rPr lang="en-US" smtClean="0"/>
-              <a:t>1/27/13</a:t>
+              <a:t>4/19/2026</a:t>
             </a:fld>
             <a:endParaRPr lang="en-US"/>
           </a:p>
@@ -388,10 +402,9 @@
           <a:lstStyle/>
           <a:p>
             <a:r>
-              <a:rPr lang="en-US" smtClean="0"/>
+              <a:rPr lang="en-US"/>
               <a:t>Click to edit Master title style</a:t>
             </a:r>
-            <a:endParaRPr lang="en-US"/>
           </a:p>
         </p:txBody>
       </p:sp>
@@ -412,38 +425,37 @@
           <a:p>
             <a:pPr lvl="0"/>
             <a:r>
-              <a:rPr lang="en-US" smtClean="0"/>
+              <a:rPr lang="en-US"/>
               <a:t>Click to edit Master text styles</a:t>
             </a:r>
           </a:p>
           <a:p>
             <a:pPr lvl="1"/>
             <a:r>
-              <a:rPr lang="en-US" smtClean="0"/>
+              <a:rPr lang="en-US"/>
               <a:t>Second level</a:t>
             </a:r>
           </a:p>
           <a:p>
             <a:pPr lvl="2"/>
             <a:r>
-              <a:rPr lang="en-US" smtClean="0"/>
+              <a:rPr lang="en-US"/>
               <a:t>Third level</a:t>
             </a:r>
           </a:p>
           <a:p>
             <a:pPr lvl="3"/>
             <a:r>
-              <a:rPr lang="en-US" smtClean="0"/>
+              <a:rPr lang="en-US"/>
               <a:t>Fourth level</a:t>
             </a:r>
           </a:p>
           <a:p>
             <a:pPr lvl="4"/>
             <a:r>
-              <a:rPr lang="en-US" smtClean="0"/>
+              <a:rPr lang="en-US"/>
               <a:t>Fifth level</a:t>
             </a:r>
-            <a:endParaRPr lang="en-US"/>
           </a:p>
         </p:txBody>
       </p:sp>
@@ -464,7 +476,7 @@
           <a:p>
             <a:fld id="{5BCAD085-E8A6-8845-BD4E-CB4CCA059FC4}" type="datetimeFigureOut">
               <a:rPr lang="en-US" smtClean="0"/>
-              <a:t>1/27/13</a:t>
+              <a:t>4/19/2026</a:t>
             </a:fld>
             <a:endParaRPr lang="en-US"/>
           </a:p>
@@ -563,10 +575,9 @@
           <a:lstStyle/>
           <a:p>
             <a:r>
-              <a:rPr lang="en-US" smtClean="0"/>
+              <a:rPr lang="en-US"/>
               <a:t>Click to edit Master title style</a:t>
             </a:r>
-            <a:endParaRPr lang="en-US"/>
           </a:p>
         </p:txBody>
       </p:sp>
@@ -592,38 +603,37 @@
           <a:p>
             <a:pPr lvl="0"/>
             <a:r>
-              <a:rPr lang="en-US" smtClean="0"/>
+              <a:rPr lang="en-US"/>
               <a:t>Click to edit Master text styles</a:t>
             </a:r>
           </a:p>
           <a:p>
             <a:pPr lvl="1"/>
             <a:r>
-              <a:rPr lang="en-US" smtClean="0"/>
+              <a:rPr lang="en-US"/>
               <a:t>Second level</a:t>
             </a:r>
           </a:p>
           <a:p>
             <a:pPr lvl="2"/>
             <a:r>
-              <a:rPr lang="en-US" smtClean="0"/>
+              <a:rPr lang="en-US"/>
               <a:t>Third level</a:t>
             </a:r>
           </a:p>
           <a:p>
             <a:pPr lvl="3"/>
             <a:r>
-              <a:rPr lang="en-US" smtClean="0"/>
+              <a:rPr lang="en-US"/>
               <a:t>Fourth level</a:t>
             </a:r>
           </a:p>
           <a:p>
             <a:pPr lvl="4"/>
             <a:r>
-              <a:rPr lang="en-US" smtClean="0"/>
+              <a:rPr lang="en-US"/>
               <a:t>Fifth level</a:t>
             </a:r>
-            <a:endParaRPr lang="en-US"/>
           </a:p>
         </p:txBody>
       </p:sp>
@@ -644,7 +654,7 @@
           <a:p>
             <a:fld id="{5BCAD085-E8A6-8845-BD4E-CB4CCA059FC4}" type="datetimeFigureOut">
               <a:rPr lang="en-US" smtClean="0"/>
-              <a:t>1/27/13</a:t>
+              <a:t>4/19/2026</a:t>
             </a:fld>
             <a:endParaRPr lang="en-US"/>
           </a:p>
@@ -738,10 +748,9 @@
           <a:lstStyle/>
           <a:p>
             <a:r>
-              <a:rPr lang="en-US" smtClean="0"/>
+              <a:rPr lang="en-US"/>
               <a:t>Click to edit Master title style</a:t>
             </a:r>
-            <a:endParaRPr lang="en-US"/>
           </a:p>
         </p:txBody>
       </p:sp>
@@ -762,38 +771,37 @@
           <a:p>
             <a:pPr lvl="0"/>
             <a:r>
-              <a:rPr lang="en-US" smtClean="0"/>
+              <a:rPr lang="en-US"/>
               <a:t>Click to edit Master text styles</a:t>
             </a:r>
           </a:p>
           <a:p>
             <a:pPr lvl="1"/>
             <a:r>
-              <a:rPr lang="en-US" smtClean="0"/>
+              <a:rPr lang="en-US"/>
               <a:t>Second level</a:t>
             </a:r>
           </a:p>
           <a:p>
             <a:pPr lvl="2"/>
             <a:r>
-              <a:rPr lang="en-US" smtClean="0"/>
+              <a:rPr lang="en-US"/>
               <a:t>Third level</a:t>
             </a:r>
           </a:p>
           <a:p>
             <a:pPr lvl="3"/>
             <a:r>
-              <a:rPr lang="en-US" smtClean="0"/>
+              <a:rPr lang="en-US"/>
               <a:t>Fourth level</a:t>
             </a:r>
           </a:p>
           <a:p>
             <a:pPr lvl="4"/>
             <a:r>
-              <a:rPr lang="en-US" smtClean="0"/>
+              <a:rPr lang="en-US"/>
               <a:t>Fifth level</a:t>
             </a:r>
-            <a:endParaRPr lang="en-US"/>
           </a:p>
         </p:txBody>
       </p:sp>
@@ -814,7 +822,7 @@
           <a:p>
             <a:fld id="{5BCAD085-E8A6-8845-BD4E-CB4CCA059FC4}" type="datetimeFigureOut">
               <a:rPr lang="en-US" smtClean="0"/>
-              <a:t>1/27/13</a:t>
+              <a:t>4/19/2026</a:t>
             </a:fld>
             <a:endParaRPr lang="en-US"/>
           </a:p>
@@ -917,10 +925,9 @@
           </a:lstStyle>
           <a:p>
             <a:r>
-              <a:rPr lang="en-US" smtClean="0"/>
+              <a:rPr lang="en-US"/>
               <a:t>Click to edit Master title style</a:t>
             </a:r>
-            <a:endParaRPr lang="en-US"/>
           </a:p>
         </p:txBody>
       </p:sp>
@@ -1037,7 +1044,7 @@
           <a:p>
             <a:pPr lvl="0"/>
             <a:r>
-              <a:rPr lang="en-US" smtClean="0"/>
+              <a:rPr lang="en-US"/>
               <a:t>Click to edit Master text styles</a:t>
             </a:r>
           </a:p>
@@ -1060,7 +1067,7 @@
           <a:p>
             <a:fld id="{5BCAD085-E8A6-8845-BD4E-CB4CCA059FC4}" type="datetimeFigureOut">
               <a:rPr lang="en-US" smtClean="0"/>
-              <a:t>1/27/13</a:t>
+              <a:t>4/19/2026</a:t>
             </a:fld>
             <a:endParaRPr lang="en-US"/>
           </a:p>
@@ -1154,10 +1161,9 @@
           <a:lstStyle/>
           <a:p>
             <a:r>
-              <a:rPr lang="en-US" smtClean="0"/>
+              <a:rPr lang="en-US"/>
               <a:t>Click to edit Master title style</a:t>
             </a:r>
-            <a:endParaRPr lang="en-US"/>
           </a:p>
         </p:txBody>
       </p:sp>
@@ -1211,38 +1217,37 @@
           <a:p>
             <a:pPr lvl="0"/>
             <a:r>
-              <a:rPr lang="en-US" smtClean="0"/>
+              <a:rPr lang="en-US"/>
               <a:t>Click to edit Master text styles</a:t>
             </a:r>
           </a:p>
           <a:p>
             <a:pPr lvl="1"/>
             <a:r>
-              <a:rPr lang="en-US" smtClean="0"/>
+              <a:rPr lang="en-US"/>
               <a:t>Second level</a:t>
             </a:r>
           </a:p>
           <a:p>
             <a:pPr lvl="2"/>
             <a:r>
-              <a:rPr lang="en-US" smtClean="0"/>
+              <a:rPr lang="en-US"/>
               <a:t>Third level</a:t>
             </a:r>
           </a:p>
           <a:p>
             <a:pPr lvl="3"/>
             <a:r>
-              <a:rPr lang="en-US" smtClean="0"/>
+              <a:rPr lang="en-US"/>
               <a:t>Fourth level</a:t>
             </a:r>
           </a:p>
           <a:p>
             <a:pPr lvl="4"/>
             <a:r>
-              <a:rPr lang="en-US" smtClean="0"/>
+              <a:rPr lang="en-US"/>
               <a:t>Fifth level</a:t>
             </a:r>
-            <a:endParaRPr lang="en-US"/>
           </a:p>
         </p:txBody>
       </p:sp>
@@ -1296,38 +1301,37 @@
           <a:p>
             <a:pPr lvl="0"/>
             <a:r>
-              <a:rPr lang="en-US" smtClean="0"/>
+              <a:rPr lang="en-US"/>
               <a:t>Click to edit Master text styles</a:t>
             </a:r>
           </a:p>
           <a:p>
             <a:pPr lvl="1"/>
             <a:r>
-              <a:rPr lang="en-US" smtClean="0"/>
+              <a:rPr lang="en-US"/>
               <a:t>Second level</a:t>
             </a:r>
           </a:p>
           <a:p>
             <a:pPr lvl="2"/>
             <a:r>
-              <a:rPr lang="en-US" smtClean="0"/>
+              <a:rPr lang="en-US"/>
               <a:t>Third level</a:t>
             </a:r>
           </a:p>
           <a:p>
             <a:pPr lvl="3"/>
             <a:r>
-              <a:rPr lang="en-US" smtClean="0"/>
+              <a:rPr lang="en-US"/>
               <a:t>Fourth level</a:t>
             </a:r>
           </a:p>
           <a:p>
             <a:pPr lvl="4"/>
             <a:r>
-              <a:rPr lang="en-US" smtClean="0"/>
+              <a:rPr lang="en-US"/>
               <a:t>Fifth level</a:t>
             </a:r>
-            <a:endParaRPr lang="en-US"/>
           </a:p>
         </p:txBody>
       </p:sp>
@@ -1348,7 +1352,7 @@
           <a:p>
             <a:fld id="{5BCAD085-E8A6-8845-BD4E-CB4CCA059FC4}" type="datetimeFigureOut">
               <a:rPr lang="en-US" smtClean="0"/>
-              <a:t>1/27/13</a:t>
+              <a:t>4/19/2026</a:t>
             </a:fld>
             <a:endParaRPr lang="en-US"/>
           </a:p>
@@ -1446,10 +1450,9 @@
           </a:lstStyle>
           <a:p>
             <a:r>
-              <a:rPr lang="en-US" smtClean="0"/>
+              <a:rPr lang="en-US"/>
               <a:t>Click to edit Master title style</a:t>
             </a:r>
-            <a:endParaRPr lang="en-US"/>
           </a:p>
         </p:txBody>
       </p:sp>
@@ -1512,7 +1515,7 @@
           <a:p>
             <a:pPr lvl="0"/>
             <a:r>
-              <a:rPr lang="en-US" smtClean="0"/>
+              <a:rPr lang="en-US"/>
               <a:t>Click to edit Master text styles</a:t>
             </a:r>
           </a:p>
@@ -1568,38 +1571,37 @@
           <a:p>
             <a:pPr lvl="0"/>
             <a:r>
-              <a:rPr lang="en-US" smtClean="0"/>
+              <a:rPr lang="en-US"/>
               <a:t>Click to edit Master text styles</a:t>
             </a:r>
           </a:p>
           <a:p>
             <a:pPr lvl="1"/>
             <a:r>
-              <a:rPr lang="en-US" smtClean="0"/>
+              <a:rPr lang="en-US"/>
               <a:t>Second level</a:t>
             </a:r>
           </a:p>
           <a:p>
             <a:pPr lvl="2"/>
             <a:r>
-              <a:rPr lang="en-US" smtClean="0"/>
+              <a:rPr lang="en-US"/>
               <a:t>Third level</a:t>
             </a:r>
           </a:p>
           <a:p>
             <a:pPr lvl="3"/>
             <a:r>
-              <a:rPr lang="en-US" smtClean="0"/>
+              <a:rPr lang="en-US"/>
               <a:t>Fourth level</a:t>
             </a:r>
           </a:p>
           <a:p>
             <a:pPr lvl="4"/>
             <a:r>
-              <a:rPr lang="en-US" smtClean="0"/>
+              <a:rPr lang="en-US"/>
               <a:t>Fifth level</a:t>
             </a:r>
-            <a:endParaRPr lang="en-US"/>
           </a:p>
         </p:txBody>
       </p:sp>
@@ -1662,7 +1664,7 @@
           <a:p>
             <a:pPr lvl="0"/>
             <a:r>
-              <a:rPr lang="en-US" smtClean="0"/>
+              <a:rPr lang="en-US"/>
               <a:t>Click to edit Master text styles</a:t>
             </a:r>
           </a:p>
@@ -1718,38 +1720,37 @@
           <a:p>
             <a:pPr lvl="0"/>
             <a:r>
-              <a:rPr lang="en-US" smtClean="0"/>
+              <a:rPr lang="en-US"/>
               <a:t>Click to edit Master text styles</a:t>
             </a:r>
           </a:p>
           <a:p>
             <a:pPr lvl="1"/>
             <a:r>
-              <a:rPr lang="en-US" smtClean="0"/>
+              <a:rPr lang="en-US"/>
               <a:t>Second level</a:t>
             </a:r>
           </a:p>
           <a:p>
             <a:pPr lvl="2"/>
             <a:r>
-              <a:rPr lang="en-US" smtClean="0"/>
+              <a:rPr lang="en-US"/>
               <a:t>Third level</a:t>
             </a:r>
           </a:p>
           <a:p>
             <a:pPr lvl="3"/>
             <a:r>
-              <a:rPr lang="en-US" smtClean="0"/>
+              <a:rPr lang="en-US"/>
               <a:t>Fourth level</a:t>
             </a:r>
           </a:p>
           <a:p>
             <a:pPr lvl="4"/>
             <a:r>
-              <a:rPr lang="en-US" smtClean="0"/>
+              <a:rPr lang="en-US"/>
               <a:t>Fifth level</a:t>
             </a:r>
-            <a:endParaRPr lang="en-US"/>
           </a:p>
         </p:txBody>
       </p:sp>
@@ -1770,7 +1771,7 @@
           <a:p>
             <a:fld id="{5BCAD085-E8A6-8845-BD4E-CB4CCA059FC4}" type="datetimeFigureOut">
               <a:rPr lang="en-US" smtClean="0"/>
-              <a:t>1/27/13</a:t>
+              <a:t>4/19/2026</a:t>
             </a:fld>
             <a:endParaRPr lang="en-US"/>
           </a:p>
@@ -1864,10 +1865,9 @@
           <a:lstStyle/>
           <a:p>
             <a:r>
-              <a:rPr lang="en-US" smtClean="0"/>
+              <a:rPr lang="en-US"/>
               <a:t>Click to edit Master title style</a:t>
             </a:r>
-            <a:endParaRPr lang="en-US"/>
           </a:p>
         </p:txBody>
       </p:sp>
@@ -1888,7 +1888,7 @@
           <a:p>
             <a:fld id="{5BCAD085-E8A6-8845-BD4E-CB4CCA059FC4}" type="datetimeFigureOut">
               <a:rPr lang="en-US" smtClean="0"/>
-              <a:t>1/27/13</a:t>
+              <a:t>4/19/2026</a:t>
             </a:fld>
             <a:endParaRPr lang="en-US"/>
           </a:p>
@@ -1983,7 +1983,7 @@
           <a:p>
             <a:fld id="{5BCAD085-E8A6-8845-BD4E-CB4CCA059FC4}" type="datetimeFigureOut">
               <a:rPr lang="en-US" smtClean="0"/>
-              <a:t>1/27/13</a:t>
+              <a:t>4/19/2026</a:t>
             </a:fld>
             <a:endParaRPr lang="en-US"/>
           </a:p>
@@ -2086,10 +2086,9 @@
           </a:lstStyle>
           <a:p>
             <a:r>
-              <a:rPr lang="en-US" smtClean="0"/>
+              <a:rPr lang="en-US"/>
               <a:t>Click to edit Master title style</a:t>
             </a:r>
-            <a:endParaRPr lang="en-US"/>
           </a:p>
         </p:txBody>
       </p:sp>
@@ -2143,38 +2142,37 @@
           <a:p>
             <a:pPr lvl="0"/>
             <a:r>
-              <a:rPr lang="en-US" smtClean="0"/>
+              <a:rPr lang="en-US"/>
               <a:t>Click to edit Master text styles</a:t>
             </a:r>
           </a:p>
           <a:p>
             <a:pPr lvl="1"/>
             <a:r>
-              <a:rPr lang="en-US" smtClean="0"/>
+              <a:rPr lang="en-US"/>
               <a:t>Second level</a:t>
             </a:r>
           </a:p>
           <a:p>
             <a:pPr lvl="2"/>
             <a:r>
-              <a:rPr lang="en-US" smtClean="0"/>
+              <a:rPr lang="en-US"/>
               <a:t>Third level</a:t>
             </a:r>
           </a:p>
           <a:p>
             <a:pPr lvl="3"/>
             <a:r>
-              <a:rPr lang="en-US" smtClean="0"/>
+              <a:rPr lang="en-US"/>
               <a:t>Fourth level</a:t>
             </a:r>
           </a:p>
           <a:p>
             <a:pPr lvl="4"/>
             <a:r>
-              <a:rPr lang="en-US" smtClean="0"/>
+              <a:rPr lang="en-US"/>
               <a:t>Fifth level</a:t>
             </a:r>
-            <a:endParaRPr lang="en-US"/>
           </a:p>
         </p:txBody>
       </p:sp>
@@ -2237,7 +2235,7 @@
           <a:p>
             <a:pPr lvl="0"/>
             <a:r>
-              <a:rPr lang="en-US" smtClean="0"/>
+              <a:rPr lang="en-US"/>
               <a:t>Click to edit Master text styles</a:t>
             </a:r>
           </a:p>
@@ -2260,7 +2258,7 @@
           <a:p>
             <a:fld id="{5BCAD085-E8A6-8845-BD4E-CB4CCA059FC4}" type="datetimeFigureOut">
               <a:rPr lang="en-US" smtClean="0"/>
-              <a:t>1/27/13</a:t>
+              <a:t>4/19/2026</a:t>
             </a:fld>
             <a:endParaRPr lang="en-US"/>
           </a:p>
@@ -2363,10 +2361,9 @@
           </a:lstStyle>
           <a:p>
             <a:r>
-              <a:rPr lang="en-US" smtClean="0"/>
+              <a:rPr lang="en-US"/>
               <a:t>Click to edit Master title style</a:t>
             </a:r>
-            <a:endParaRPr lang="en-US"/>
           </a:p>
         </p:txBody>
       </p:sp>
@@ -2490,7 +2487,7 @@
           <a:p>
             <a:pPr lvl="0"/>
             <a:r>
-              <a:rPr lang="en-US" smtClean="0"/>
+              <a:rPr lang="en-US"/>
               <a:t>Click to edit Master text styles</a:t>
             </a:r>
           </a:p>
@@ -2513,7 +2510,7 @@
           <a:p>
             <a:fld id="{5BCAD085-E8A6-8845-BD4E-CB4CCA059FC4}" type="datetimeFigureOut">
               <a:rPr lang="en-US" smtClean="0"/>
-              <a:t>1/27/13</a:t>
+              <a:t>4/19/2026</a:t>
             </a:fld>
             <a:endParaRPr lang="en-US"/>
           </a:p>
@@ -2622,10 +2619,9 @@
           <a:lstStyle/>
           <a:p>
             <a:r>
-              <a:rPr lang="en-US" smtClean="0"/>
+              <a:rPr lang="en-US"/>
               <a:t>Click to edit Master title style</a:t>
             </a:r>
-            <a:endParaRPr lang="en-US"/>
           </a:p>
         </p:txBody>
       </p:sp>
@@ -2656,38 +2652,37 @@
           <a:p>
             <a:pPr lvl="0"/>
             <a:r>
-              <a:rPr lang="en-US" smtClean="0"/>
+              <a:rPr lang="en-US"/>
               <a:t>Click to edit Master text styles</a:t>
             </a:r>
           </a:p>
           <a:p>
             <a:pPr lvl="1"/>
             <a:r>
-              <a:rPr lang="en-US" smtClean="0"/>
+              <a:rPr lang="en-US"/>
               <a:t>Second level</a:t>
             </a:r>
           </a:p>
           <a:p>
             <a:pPr lvl="2"/>
             <a:r>
-              <a:rPr lang="en-US" smtClean="0"/>
+              <a:rPr lang="en-US"/>
               <a:t>Third level</a:t>
             </a:r>
           </a:p>
           <a:p>
             <a:pPr lvl="3"/>
             <a:r>
-              <a:rPr lang="en-US" smtClean="0"/>
+              <a:rPr lang="en-US"/>
               <a:t>Fourth level</a:t>
             </a:r>
           </a:p>
           <a:p>
             <a:pPr lvl="4"/>
             <a:r>
-              <a:rPr lang="en-US" smtClean="0"/>
+              <a:rPr lang="en-US"/>
               <a:t>Fifth level</a:t>
             </a:r>
-            <a:endParaRPr lang="en-US"/>
           </a:p>
         </p:txBody>
       </p:sp>
@@ -2726,7 +2721,7 @@
           <a:p>
             <a:fld id="{5BCAD085-E8A6-8845-BD4E-CB4CCA059FC4}" type="datetimeFigureOut">
               <a:rPr lang="en-US" smtClean="0"/>
-              <a:t>1/27/13</a:t>
+              <a:t>4/19/2026</a:t>
             </a:fld>
             <a:endParaRPr lang="en-US"/>
           </a:p>
@@ -3085,7 +3080,7 @@
 </file>
 
 <file path=ppt/slides/slide1.xml><?xml version="1.0" encoding="utf-8"?>
-<p:sld xmlns:a="http://schemas.openxmlformats.org/drawingml/2006/main" xmlns:p="http://schemas.openxmlformats.org/presentationml/2006/main" xmlns:r="http://schemas.openxmlformats.org/officeDocument/2006/relationships">
+<p:sld xmlns:a="http://schemas.openxmlformats.org/drawingml/2006/main" xmlns:r="http://schemas.openxmlformats.org/officeDocument/2006/relationships" xmlns:p="http://schemas.openxmlformats.org/presentationml/2006/main">
   <p:cSld>
     <p:bg>
       <p:bgPr>
@@ -3101,7 +3096,14 @@
         <p:cNvGrpSpPr/>
         <p:nvPr/>
       </p:nvGrpSpPr>
-      <p:grpSpPr/>
+      <p:grpSpPr>
+        <a:xfrm>
+          <a:off x="0" y="0"/>
+          <a:ext cx="0" cy="0"/>
+          <a:chOff x="0" y="0"/>
+          <a:chExt cx="0" cy="0"/>
+        </a:xfrm>
+      </p:grpSpPr>
       <p:sp>
         <p:nvSpPr>
           <p:cNvPr id="2" name="Oval 1"/>
@@ -3142,6 +3144,7 @@
           <a:lstStyle/>
           <a:p>
             <a:pPr algn="ctr"/>
+            <a:endParaRPr/>
           </a:p>
         </p:txBody>
       </p:sp>
@@ -3185,6 +3188,7 @@
           <a:lstStyle/>
           <a:p>
             <a:pPr algn="ctr"/>
+            <a:endParaRPr/>
           </a:p>
         </p:txBody>
       </p:sp>
@@ -3228,6 +3232,7 @@
           <a:lstStyle/>
           <a:p>
             <a:pPr algn="ctr"/>
+            <a:endParaRPr/>
           </a:p>
         </p:txBody>
       </p:sp>
@@ -3248,7 +3253,7 @@
           <a:noFill/>
         </p:spPr>
         <p:txBody>
-          <a:bodyPr wrap="square" lIns="50800" rIns="50800" tIns="50800" bIns="50800" anchor="t">
+          <a:bodyPr wrap="square" lIns="50800" tIns="50800" rIns="50800" bIns="50800" anchor="t">
             <a:normAutofit/>
           </a:bodyPr>
           <a:lstStyle/>
@@ -3295,8 +3300,8 @@
           <a:noFill/>
         </p:spPr>
         <p:txBody>
-          <a:bodyPr wrap="square" lIns="50800" rIns="50800" tIns="50800" bIns="50800" anchor="t">
-            <a:normAutofit/>
+          <a:bodyPr wrap="square" lIns="50800" tIns="50800" rIns="50800" bIns="50800" anchor="t">
+            <a:normAutofit fontScale="92500" lnSpcReduction="20000"/>
           </a:bodyPr>
           <a:lstStyle/>
           <a:p>
@@ -3330,8 +3335,8 @@
           <a:noFill/>
         </p:spPr>
         <p:txBody>
-          <a:bodyPr wrap="square" lIns="50800" rIns="50800" tIns="50800" bIns="50800" anchor="t">
-            <a:normAutofit/>
+          <a:bodyPr wrap="square" lIns="50800" tIns="50800" rIns="50800" bIns="50800" anchor="t">
+            <a:normAutofit fontScale="92500" lnSpcReduction="20000"/>
           </a:bodyPr>
           <a:lstStyle/>
           <a:p>
@@ -3388,6 +3393,7 @@
           <a:lstStyle/>
           <a:p>
             <a:pPr algn="ctr"/>
+            <a:endParaRPr/>
           </a:p>
         </p:txBody>
       </p:sp>
@@ -3408,8 +3414,8 @@
           <a:noFill/>
         </p:spPr>
         <p:txBody>
-          <a:bodyPr wrap="square" lIns="50800" rIns="50800" tIns="50800" bIns="50800" anchor="t">
-            <a:normAutofit/>
+          <a:bodyPr wrap="square" lIns="50800" tIns="50800" rIns="50800" bIns="50800" anchor="t">
+            <a:normAutofit fontScale="47500" lnSpcReduction="20000"/>
           </a:bodyPr>
           <a:lstStyle/>
           <a:p>
@@ -3435,7 +3441,7 @@
 </file>
 
 <file path=ppt/slides/slide2.xml><?xml version="1.0" encoding="utf-8"?>
-<p:sld xmlns:a="http://schemas.openxmlformats.org/drawingml/2006/main" xmlns:p="http://schemas.openxmlformats.org/presentationml/2006/main" xmlns:r="http://schemas.openxmlformats.org/officeDocument/2006/relationships">
+<p:sld xmlns:a="http://schemas.openxmlformats.org/drawingml/2006/main" xmlns:r="http://schemas.openxmlformats.org/officeDocument/2006/relationships" xmlns:p="http://schemas.openxmlformats.org/presentationml/2006/main">
   <p:cSld>
     <p:bg>
       <p:bgPr>
@@ -3451,7 +3457,14 @@
         <p:cNvGrpSpPr/>
         <p:nvPr/>
       </p:nvGrpSpPr>
-      <p:grpSpPr/>
+      <p:grpSpPr>
+        <a:xfrm>
+          <a:off x="0" y="0"/>
+          <a:ext cx="0" cy="0"/>
+          <a:chOff x="0" y="0"/>
+          <a:chExt cx="0" cy="0"/>
+        </a:xfrm>
+      </p:grpSpPr>
       <p:sp>
         <p:nvSpPr>
           <p:cNvPr id="2" name="TextBox 1"/>
@@ -3469,8 +3482,8 @@
           <a:noFill/>
         </p:spPr>
         <p:txBody>
-          <a:bodyPr wrap="square" lIns="50800" rIns="50800" tIns="50800" bIns="50800" anchor="t">
-            <a:normAutofit/>
+          <a:bodyPr wrap="square" lIns="50800" tIns="50800" rIns="50800" bIns="50800" anchor="t">
+            <a:normAutofit fontScale="77500" lnSpcReduction="20000"/>
           </a:bodyPr>
           <a:lstStyle/>
           <a:p>
@@ -3529,6 +3542,7 @@
           <a:lstStyle/>
           <a:p>
             <a:pPr algn="ctr"/>
+            <a:endParaRPr/>
           </a:p>
         </p:txBody>
       </p:sp>
@@ -3565,7 +3579,7 @@
 </file>
 
 <file path=ppt/slides/slide3.xml><?xml version="1.0" encoding="utf-8"?>
-<p:sld xmlns:a="http://schemas.openxmlformats.org/drawingml/2006/main" xmlns:p="http://schemas.openxmlformats.org/presentationml/2006/main" xmlns:r="http://schemas.openxmlformats.org/officeDocument/2006/relationships">
+<p:sld xmlns:a="http://schemas.openxmlformats.org/drawingml/2006/main" xmlns:r="http://schemas.openxmlformats.org/officeDocument/2006/relationships" xmlns:p="http://schemas.openxmlformats.org/presentationml/2006/main">
   <p:cSld>
     <p:bg>
       <p:bgPr>
@@ -3581,7 +3595,14 @@
         <p:cNvGrpSpPr/>
         <p:nvPr/>
       </p:nvGrpSpPr>
-      <p:grpSpPr/>
+      <p:grpSpPr>
+        <a:xfrm>
+          <a:off x="0" y="0"/>
+          <a:ext cx="0" cy="0"/>
+          <a:chOff x="0" y="0"/>
+          <a:chExt cx="0" cy="0"/>
+        </a:xfrm>
+      </p:grpSpPr>
       <p:sp>
         <p:nvSpPr>
           <p:cNvPr id="2" name="TextBox 1"/>
@@ -3599,8 +3620,8 @@
           <a:noFill/>
         </p:spPr>
         <p:txBody>
-          <a:bodyPr wrap="square" lIns="50800" rIns="50800" tIns="50800" bIns="50800" anchor="t">
-            <a:normAutofit/>
+          <a:bodyPr wrap="square" lIns="50800" tIns="50800" rIns="50800" bIns="50800" anchor="t">
+            <a:normAutofit fontScale="77500" lnSpcReduction="20000"/>
           </a:bodyPr>
           <a:lstStyle/>
           <a:p>
@@ -3617,75 +3638,97 @@
           </a:p>
         </p:txBody>
       </p:sp>
-      <p:sp>
-        <p:nvSpPr>
-          <p:cNvPr id="3" name="Rounded Rectangle 2"/>
-          <p:cNvSpPr/>
+      <p:grpSp>
+        <p:nvGrpSpPr>
+          <p:cNvPr id="5" name="Group 4">
+            <a:extLst>
+              <a:ext uri="{FF2B5EF4-FFF2-40B4-BE49-F238E27FC236}">
+                <a16:creationId xmlns:a16="http://schemas.microsoft.com/office/drawing/2014/main" id="{D6F0732B-C08B-2A3A-8175-8F676DBB1D39}"/>
+              </a:ext>
+            </a:extLst>
+          </p:cNvPr>
+          <p:cNvGrpSpPr/>
           <p:nvPr/>
-        </p:nvSpPr>
-        <p:spPr>
+        </p:nvGrpSpPr>
+        <p:grpSpPr>
           <a:xfrm>
             <a:off x="320031" y="777240"/>
             <a:ext cx="11551631" cy="5684520"/>
+            <a:chOff x="320031" y="777240"/>
+            <a:chExt cx="11551631" cy="5684520"/>
           </a:xfrm>
-          <a:prstGeom prst="roundRect">
-            <a:avLst/>
-          </a:prstGeom>
-          <a:solidFill>
-            <a:srgbClr val="FFFDFA"/>
-          </a:solidFill>
-          <a:ln w="15240">
+        </p:grpSpPr>
+        <p:sp>
+          <p:nvSpPr>
+            <p:cNvPr id="3" name="Rounded Rectangle 2"/>
+            <p:cNvSpPr/>
+            <p:nvPr/>
+          </p:nvSpPr>
+          <p:spPr>
+            <a:xfrm>
+              <a:off x="320031" y="777240"/>
+              <a:ext cx="11551631" cy="5684520"/>
+            </a:xfrm>
+            <a:prstGeom prst="roundRect">
+              <a:avLst/>
+            </a:prstGeom>
             <a:solidFill>
-              <a:srgbClr val="DBC7AA"/>
+              <a:srgbClr val="FFFDFA"/>
             </a:solidFill>
-          </a:ln>
-        </p:spPr>
-        <p:style>
-          <a:lnRef idx="1">
-            <a:schemeClr val="accent1"/>
-          </a:lnRef>
-          <a:fillRef idx="3">
-            <a:schemeClr val="accent1"/>
-          </a:fillRef>
-          <a:effectRef idx="2">
-            <a:schemeClr val="accent1"/>
-          </a:effectRef>
-          <a:fontRef idx="minor">
-            <a:schemeClr val="lt1"/>
-          </a:fontRef>
-        </p:style>
-        <p:txBody>
-          <a:bodyPr rtlCol="0" anchor="ctr"/>
-          <a:lstStyle/>
-          <a:p>
-            <a:pPr algn="ctr"/>
-          </a:p>
-        </p:txBody>
-      </p:sp>
-      <p:pic>
-        <p:nvPicPr>
-          <p:cNvPr id="4" name="Picture 3" descr="logistic_rf_model_math.png"/>
-          <p:cNvPicPr>
-            <a:picLocks noChangeAspect="1"/>
-          </p:cNvPicPr>
-          <p:nvPr/>
-        </p:nvPicPr>
-        <p:blipFill>
-          <a:blip r:embed="rId2"/>
-          <a:stretch>
-            <a:fillRect/>
-          </a:stretch>
-        </p:blipFill>
-        <p:spPr>
-          <a:xfrm>
-            <a:off x="487667" y="883920"/>
-            <a:ext cx="11216359" cy="5364480"/>
-          </a:xfrm>
-          <a:prstGeom prst="rect">
-            <a:avLst/>
-          </a:prstGeom>
-        </p:spPr>
-      </p:pic>
+            <a:ln w="15240">
+              <a:solidFill>
+                <a:srgbClr val="DBC7AA"/>
+              </a:solidFill>
+            </a:ln>
+          </p:spPr>
+          <p:style>
+            <a:lnRef idx="1">
+              <a:schemeClr val="accent1"/>
+            </a:lnRef>
+            <a:fillRef idx="3">
+              <a:schemeClr val="accent1"/>
+            </a:fillRef>
+            <a:effectRef idx="2">
+              <a:schemeClr val="accent1"/>
+            </a:effectRef>
+            <a:fontRef idx="minor">
+              <a:schemeClr val="lt1"/>
+            </a:fontRef>
+          </p:style>
+          <p:txBody>
+            <a:bodyPr rtlCol="0" anchor="ctr"/>
+            <a:lstStyle/>
+            <a:p>
+              <a:pPr algn="ctr"/>
+              <a:endParaRPr/>
+            </a:p>
+          </p:txBody>
+        </p:sp>
+        <p:pic>
+          <p:nvPicPr>
+            <p:cNvPr id="4" name="Picture 3" descr="logistic_rf_model_math.png"/>
+            <p:cNvPicPr>
+              <a:picLocks noChangeAspect="1"/>
+            </p:cNvPicPr>
+            <p:nvPr/>
+          </p:nvPicPr>
+          <p:blipFill>
+            <a:blip r:embed="rId2"/>
+            <a:stretch>
+              <a:fillRect/>
+            </a:stretch>
+          </p:blipFill>
+          <p:spPr>
+            <a:xfrm>
+              <a:off x="487667" y="883920"/>
+              <a:ext cx="11216359" cy="5364480"/>
+            </a:xfrm>
+            <a:prstGeom prst="rect">
+              <a:avLst/>
+            </a:prstGeom>
+          </p:spPr>
+        </p:pic>
+      </p:grpSp>
     </p:spTree>
   </p:cSld>
   <p:clrMapOvr>
@@ -3695,7 +3738,7 @@
 </file>
 
 <file path=ppt/slides/slide4.xml><?xml version="1.0" encoding="utf-8"?>
-<p:sld xmlns:a="http://schemas.openxmlformats.org/drawingml/2006/main" xmlns:p="http://schemas.openxmlformats.org/presentationml/2006/main" xmlns:r="http://schemas.openxmlformats.org/officeDocument/2006/relationships">
+<p:sld xmlns:a="http://schemas.openxmlformats.org/drawingml/2006/main" xmlns:r="http://schemas.openxmlformats.org/officeDocument/2006/relationships" xmlns:p="http://schemas.openxmlformats.org/presentationml/2006/main">
   <p:cSld>
     <p:bg>
       <p:bgPr>
@@ -3711,7 +3754,14 @@
         <p:cNvGrpSpPr/>
         <p:nvPr/>
       </p:nvGrpSpPr>
-      <p:grpSpPr/>
+      <p:grpSpPr>
+        <a:xfrm>
+          <a:off x="0" y="0"/>
+          <a:ext cx="0" cy="0"/>
+          <a:chOff x="0" y="0"/>
+          <a:chExt cx="0" cy="0"/>
+        </a:xfrm>
+      </p:grpSpPr>
       <p:sp>
         <p:nvSpPr>
           <p:cNvPr id="2" name="TextBox 1"/>
@@ -3729,8 +3779,8 @@
           <a:noFill/>
         </p:spPr>
         <p:txBody>
-          <a:bodyPr wrap="square" lIns="50800" rIns="50800" tIns="50800" bIns="50800" anchor="t">
-            <a:normAutofit/>
+          <a:bodyPr wrap="square" lIns="50800" tIns="50800" rIns="50800" bIns="50800" anchor="t">
+            <a:normAutofit lnSpcReduction="10000"/>
           </a:bodyPr>
           <a:lstStyle/>
           <a:p>
@@ -3747,75 +3797,97 @@
           </a:p>
         </p:txBody>
       </p:sp>
-      <p:sp>
-        <p:nvSpPr>
-          <p:cNvPr id="3" name="Rounded Rectangle 2"/>
-          <p:cNvSpPr/>
+      <p:grpSp>
+        <p:nvGrpSpPr>
+          <p:cNvPr id="5" name="Group 4">
+            <a:extLst>
+              <a:ext uri="{FF2B5EF4-FFF2-40B4-BE49-F238E27FC236}">
+                <a16:creationId xmlns:a16="http://schemas.microsoft.com/office/drawing/2014/main" id="{48453628-4F9E-4810-633E-DAC1E90C40B7}"/>
+              </a:ext>
+            </a:extLst>
+          </p:cNvPr>
+          <p:cNvGrpSpPr/>
           <p:nvPr/>
-        </p:nvSpPr>
-        <p:spPr>
+        </p:nvGrpSpPr>
+        <p:grpSpPr>
           <a:xfrm>
             <a:off x="335271" y="777240"/>
             <a:ext cx="11521151" cy="5684520"/>
+            <a:chOff x="335271" y="777240"/>
+            <a:chExt cx="11521151" cy="5684520"/>
           </a:xfrm>
-          <a:prstGeom prst="roundRect">
-            <a:avLst/>
-          </a:prstGeom>
-          <a:solidFill>
-            <a:srgbClr val="FFFDFA"/>
-          </a:solidFill>
-          <a:ln w="15240">
+        </p:grpSpPr>
+        <p:sp>
+          <p:nvSpPr>
+            <p:cNvPr id="3" name="Rounded Rectangle 2"/>
+            <p:cNvSpPr/>
+            <p:nvPr/>
+          </p:nvSpPr>
+          <p:spPr>
+            <a:xfrm>
+              <a:off x="335271" y="777240"/>
+              <a:ext cx="11521151" cy="5684520"/>
+            </a:xfrm>
+            <a:prstGeom prst="roundRect">
+              <a:avLst/>
+            </a:prstGeom>
             <a:solidFill>
-              <a:srgbClr val="DBC7AA"/>
+              <a:srgbClr val="FFFDFA"/>
             </a:solidFill>
-          </a:ln>
-        </p:spPr>
-        <p:style>
-          <a:lnRef idx="1">
-            <a:schemeClr val="accent1"/>
-          </a:lnRef>
-          <a:fillRef idx="3">
-            <a:schemeClr val="accent1"/>
-          </a:fillRef>
-          <a:effectRef idx="2">
-            <a:schemeClr val="accent1"/>
-          </a:effectRef>
-          <a:fontRef idx="minor">
-            <a:schemeClr val="lt1"/>
-          </a:fontRef>
-        </p:style>
-        <p:txBody>
-          <a:bodyPr rtlCol="0" anchor="ctr"/>
-          <a:lstStyle/>
-          <a:p>
-            <a:pPr algn="ctr"/>
-          </a:p>
-        </p:txBody>
-      </p:sp>
-      <p:pic>
-        <p:nvPicPr>
-          <p:cNvPr id="4" name="Picture 3" descr="within_city_vs_transfer_results.png"/>
-          <p:cNvPicPr>
-            <a:picLocks noChangeAspect="1"/>
-          </p:cNvPicPr>
-          <p:nvPr/>
-        </p:nvPicPr>
-        <p:blipFill>
-          <a:blip r:embed="rId2"/>
-          <a:stretch>
-            <a:fillRect/>
-          </a:stretch>
-        </p:blipFill>
-        <p:spPr>
-          <a:xfrm>
-            <a:off x="533386" y="883920"/>
-            <a:ext cx="11124921" cy="5364480"/>
-          </a:xfrm>
-          <a:prstGeom prst="rect">
-            <a:avLst/>
-          </a:prstGeom>
-        </p:spPr>
-      </p:pic>
+            <a:ln w="15240">
+              <a:solidFill>
+                <a:srgbClr val="DBC7AA"/>
+              </a:solidFill>
+            </a:ln>
+          </p:spPr>
+          <p:style>
+            <a:lnRef idx="1">
+              <a:schemeClr val="accent1"/>
+            </a:lnRef>
+            <a:fillRef idx="3">
+              <a:schemeClr val="accent1"/>
+            </a:fillRef>
+            <a:effectRef idx="2">
+              <a:schemeClr val="accent1"/>
+            </a:effectRef>
+            <a:fontRef idx="minor">
+              <a:schemeClr val="lt1"/>
+            </a:fontRef>
+          </p:style>
+          <p:txBody>
+            <a:bodyPr rtlCol="0" anchor="ctr"/>
+            <a:lstStyle/>
+            <a:p>
+              <a:pPr algn="ctr"/>
+              <a:endParaRPr/>
+            </a:p>
+          </p:txBody>
+        </p:sp>
+        <p:pic>
+          <p:nvPicPr>
+            <p:cNvPr id="4" name="Picture 3" descr="within_city_vs_transfer_results.png"/>
+            <p:cNvPicPr>
+              <a:picLocks noChangeAspect="1"/>
+            </p:cNvPicPr>
+            <p:nvPr/>
+          </p:nvPicPr>
+          <p:blipFill>
+            <a:blip r:embed="rId2"/>
+            <a:stretch>
+              <a:fillRect/>
+            </a:stretch>
+          </p:blipFill>
+          <p:spPr>
+            <a:xfrm>
+              <a:off x="533386" y="883920"/>
+              <a:ext cx="11124921" cy="5364480"/>
+            </a:xfrm>
+            <a:prstGeom prst="rect">
+              <a:avLst/>
+            </a:prstGeom>
+          </p:spPr>
+        </p:pic>
+      </p:grpSp>
     </p:spTree>
   </p:cSld>
   <p:clrMapOvr>
@@ -3825,7 +3897,7 @@
 </file>
 
 <file path=ppt/slides/slide5.xml><?xml version="1.0" encoding="utf-8"?>
-<p:sld xmlns:a="http://schemas.openxmlformats.org/drawingml/2006/main" xmlns:p="http://schemas.openxmlformats.org/presentationml/2006/main" xmlns:r="http://schemas.openxmlformats.org/officeDocument/2006/relationships">
+<p:sld xmlns:a="http://schemas.openxmlformats.org/drawingml/2006/main" xmlns:r="http://schemas.openxmlformats.org/officeDocument/2006/relationships" xmlns:p="http://schemas.openxmlformats.org/presentationml/2006/main">
   <p:cSld>
     <p:bg>
       <p:bgPr>
@@ -3841,7 +3913,14 @@
         <p:cNvGrpSpPr/>
         <p:nvPr/>
       </p:nvGrpSpPr>
-      <p:grpSpPr/>
+      <p:grpSpPr>
+        <a:xfrm>
+          <a:off x="0" y="0"/>
+          <a:ext cx="0" cy="0"/>
+          <a:chOff x="0" y="0"/>
+          <a:chExt cx="0" cy="0"/>
+        </a:xfrm>
+      </p:grpSpPr>
       <p:sp>
         <p:nvSpPr>
           <p:cNvPr id="2" name="TextBox 1"/>
@@ -3859,8 +3938,8 @@
           <a:noFill/>
         </p:spPr>
         <p:txBody>
-          <a:bodyPr wrap="square" lIns="50800" rIns="50800" tIns="50800" bIns="50800" anchor="t">
-            <a:normAutofit/>
+          <a:bodyPr wrap="square" lIns="50800" tIns="50800" rIns="50800" bIns="50800" anchor="t">
+            <a:normAutofit fontScale="77500" lnSpcReduction="20000"/>
           </a:bodyPr>
           <a:lstStyle/>
           <a:p>
@@ -3877,75 +3956,97 @@
           </a:p>
         </p:txBody>
       </p:sp>
-      <p:sp>
-        <p:nvSpPr>
-          <p:cNvPr id="3" name="Rounded Rectangle 2"/>
-          <p:cNvSpPr/>
+      <p:grpSp>
+        <p:nvGrpSpPr>
+          <p:cNvPr id="5" name="Group 4">
+            <a:extLst>
+              <a:ext uri="{FF2B5EF4-FFF2-40B4-BE49-F238E27FC236}">
+                <a16:creationId xmlns:a16="http://schemas.microsoft.com/office/drawing/2014/main" id="{2F427037-72B8-53BB-FD6B-1B8E107DC218}"/>
+              </a:ext>
+            </a:extLst>
+          </p:cNvPr>
+          <p:cNvGrpSpPr/>
           <p:nvPr/>
-        </p:nvSpPr>
-        <p:spPr>
+        </p:nvGrpSpPr>
+        <p:grpSpPr>
           <a:xfrm>
             <a:off x="335271" y="777240"/>
             <a:ext cx="11521151" cy="5684520"/>
+            <a:chOff x="335271" y="777240"/>
+            <a:chExt cx="11521151" cy="5684520"/>
           </a:xfrm>
-          <a:prstGeom prst="roundRect">
-            <a:avLst/>
-          </a:prstGeom>
-          <a:solidFill>
-            <a:srgbClr val="FFFDFA"/>
-          </a:solidFill>
-          <a:ln w="15240">
+        </p:grpSpPr>
+        <p:sp>
+          <p:nvSpPr>
+            <p:cNvPr id="3" name="Rounded Rectangle 2"/>
+            <p:cNvSpPr/>
+            <p:nvPr/>
+          </p:nvSpPr>
+          <p:spPr>
+            <a:xfrm>
+              <a:off x="335271" y="777240"/>
+              <a:ext cx="11521151" cy="5684520"/>
+            </a:xfrm>
+            <a:prstGeom prst="roundRect">
+              <a:avLst/>
+            </a:prstGeom>
             <a:solidFill>
-              <a:srgbClr val="DBC7AA"/>
+              <a:srgbClr val="FFFDFA"/>
             </a:solidFill>
-          </a:ln>
-        </p:spPr>
-        <p:style>
-          <a:lnRef idx="1">
-            <a:schemeClr val="accent1"/>
-          </a:lnRef>
-          <a:fillRef idx="3">
-            <a:schemeClr val="accent1"/>
-          </a:fillRef>
-          <a:effectRef idx="2">
-            <a:schemeClr val="accent1"/>
-          </a:effectRef>
-          <a:fontRef idx="minor">
-            <a:schemeClr val="lt1"/>
-          </a:fontRef>
-        </p:style>
-        <p:txBody>
-          <a:bodyPr rtlCol="0" anchor="ctr"/>
-          <a:lstStyle/>
-          <a:p>
-            <a:pPr algn="ctr"/>
-          </a:p>
-        </p:txBody>
-      </p:sp>
-      <p:pic>
-        <p:nvPicPr>
-          <p:cNvPr id="4" name="Picture 3" descr="city_signal_transfer_relationship.png"/>
-          <p:cNvPicPr>
-            <a:picLocks noChangeAspect="1"/>
-          </p:cNvPicPr>
-          <p:nvPr/>
-        </p:nvPicPr>
-        <p:blipFill>
-          <a:blip r:embed="rId2"/>
-          <a:stretch>
-            <a:fillRect/>
-          </a:stretch>
-        </p:blipFill>
-        <p:spPr>
-          <a:xfrm>
-            <a:off x="533386" y="883920"/>
-            <a:ext cx="11124921" cy="5364480"/>
-          </a:xfrm>
-          <a:prstGeom prst="rect">
-            <a:avLst/>
-          </a:prstGeom>
-        </p:spPr>
-      </p:pic>
+            <a:ln w="15240">
+              <a:solidFill>
+                <a:srgbClr val="DBC7AA"/>
+              </a:solidFill>
+            </a:ln>
+          </p:spPr>
+          <p:style>
+            <a:lnRef idx="1">
+              <a:schemeClr val="accent1"/>
+            </a:lnRef>
+            <a:fillRef idx="3">
+              <a:schemeClr val="accent1"/>
+            </a:fillRef>
+            <a:effectRef idx="2">
+              <a:schemeClr val="accent1"/>
+            </a:effectRef>
+            <a:fontRef idx="minor">
+              <a:schemeClr val="lt1"/>
+            </a:fontRef>
+          </p:style>
+          <p:txBody>
+            <a:bodyPr rtlCol="0" anchor="ctr"/>
+            <a:lstStyle/>
+            <a:p>
+              <a:pPr algn="ctr"/>
+              <a:endParaRPr/>
+            </a:p>
+          </p:txBody>
+        </p:sp>
+        <p:pic>
+          <p:nvPicPr>
+            <p:cNvPr id="4" name="Picture 3" descr="city_signal_transfer_relationship.png"/>
+            <p:cNvPicPr>
+              <a:picLocks noChangeAspect="1"/>
+            </p:cNvPicPr>
+            <p:nvPr/>
+          </p:nvPicPr>
+          <p:blipFill>
+            <a:blip r:embed="rId2"/>
+            <a:stretch>
+              <a:fillRect/>
+            </a:stretch>
+          </p:blipFill>
+          <p:spPr>
+            <a:xfrm>
+              <a:off x="533386" y="883920"/>
+              <a:ext cx="11124921" cy="5364480"/>
+            </a:xfrm>
+            <a:prstGeom prst="rect">
+              <a:avLst/>
+            </a:prstGeom>
+          </p:spPr>
+        </p:pic>
+      </p:grpSp>
     </p:spTree>
   </p:cSld>
   <p:clrMapOvr>
@@ -3955,7 +4056,7 @@
 </file>
 
 <file path=ppt/slides/slide6.xml><?xml version="1.0" encoding="utf-8"?>
-<p:sld xmlns:a="http://schemas.openxmlformats.org/drawingml/2006/main" xmlns:p="http://schemas.openxmlformats.org/presentationml/2006/main" xmlns:r="http://schemas.openxmlformats.org/officeDocument/2006/relationships">
+<p:sld xmlns:a="http://schemas.openxmlformats.org/drawingml/2006/main" xmlns:r="http://schemas.openxmlformats.org/officeDocument/2006/relationships" xmlns:p="http://schemas.openxmlformats.org/presentationml/2006/main">
   <p:cSld>
     <p:bg>
       <p:bgPr>
@@ -3971,7 +4072,14 @@
         <p:cNvGrpSpPr/>
         <p:nvPr/>
       </p:nvGrpSpPr>
-      <p:grpSpPr/>
+      <p:grpSpPr>
+        <a:xfrm>
+          <a:off x="0" y="0"/>
+          <a:ext cx="0" cy="0"/>
+          <a:chOff x="0" y="0"/>
+          <a:chExt cx="0" cy="0"/>
+        </a:xfrm>
+      </p:grpSpPr>
       <p:sp>
         <p:nvSpPr>
           <p:cNvPr id="2" name="TextBox 1"/>
@@ -3989,8 +4097,8 @@
           <a:noFill/>
         </p:spPr>
         <p:txBody>
-          <a:bodyPr wrap="square" lIns="50800" rIns="50800" tIns="50800" bIns="50800" anchor="t">
-            <a:normAutofit/>
+          <a:bodyPr wrap="square" lIns="50800" tIns="50800" rIns="50800" bIns="50800" anchor="t">
+            <a:normAutofit lnSpcReduction="10000"/>
           </a:bodyPr>
           <a:lstStyle/>
           <a:p>
@@ -4007,75 +4115,97 @@
           </a:p>
         </p:txBody>
       </p:sp>
-      <p:sp>
-        <p:nvSpPr>
-          <p:cNvPr id="3" name="Rounded Rectangle 2"/>
-          <p:cNvSpPr/>
+      <p:grpSp>
+        <p:nvGrpSpPr>
+          <p:cNvPr id="5" name="Group 4">
+            <a:extLst>
+              <a:ext uri="{FF2B5EF4-FFF2-40B4-BE49-F238E27FC236}">
+                <a16:creationId xmlns:a16="http://schemas.microsoft.com/office/drawing/2014/main" id="{AE441E9D-1956-9C7B-E499-12D5A8397672}"/>
+              </a:ext>
+            </a:extLst>
+          </p:cNvPr>
+          <p:cNvGrpSpPr/>
           <p:nvPr/>
-        </p:nvSpPr>
-        <p:spPr>
+        </p:nvGrpSpPr>
+        <p:grpSpPr>
           <a:xfrm>
             <a:off x="335271" y="777240"/>
             <a:ext cx="11521151" cy="5684520"/>
+            <a:chOff x="335271" y="777240"/>
+            <a:chExt cx="11521151" cy="5684520"/>
           </a:xfrm>
-          <a:prstGeom prst="roundRect">
-            <a:avLst/>
-          </a:prstGeom>
-          <a:solidFill>
-            <a:srgbClr val="FFFDFA"/>
-          </a:solidFill>
-          <a:ln w="15240">
+        </p:grpSpPr>
+        <p:sp>
+          <p:nvSpPr>
+            <p:cNvPr id="3" name="Rounded Rectangle 2"/>
+            <p:cNvSpPr/>
+            <p:nvPr/>
+          </p:nvSpPr>
+          <p:spPr>
+            <a:xfrm>
+              <a:off x="335271" y="777240"/>
+              <a:ext cx="11521151" cy="5684520"/>
+            </a:xfrm>
+            <a:prstGeom prst="roundRect">
+              <a:avLst/>
+            </a:prstGeom>
             <a:solidFill>
-              <a:srgbClr val="DBC7AA"/>
+              <a:srgbClr val="FFFDFA"/>
             </a:solidFill>
-          </a:ln>
-        </p:spPr>
-        <p:style>
-          <a:lnRef idx="1">
-            <a:schemeClr val="accent1"/>
-          </a:lnRef>
-          <a:fillRef idx="3">
-            <a:schemeClr val="accent1"/>
-          </a:fillRef>
-          <a:effectRef idx="2">
-            <a:schemeClr val="accent1"/>
-          </a:effectRef>
-          <a:fontRef idx="minor">
-            <a:schemeClr val="lt1"/>
-          </a:fontRef>
-        </p:style>
-        <p:txBody>
-          <a:bodyPr rtlCol="0" anchor="ctr"/>
-          <a:lstStyle/>
-          <a:p>
-            <a:pPr algn="ctr"/>
-          </a:p>
-        </p:txBody>
-      </p:sp>
-      <p:pic>
-        <p:nvPicPr>
-          <p:cNvPr id="4" name="Picture 3" descr="heldout_denver_map_focus.png"/>
-          <p:cNvPicPr>
-            <a:picLocks noChangeAspect="1"/>
-          </p:cNvPicPr>
-          <p:nvPr/>
-        </p:nvPicPr>
-        <p:blipFill>
-          <a:blip r:embed="rId2"/>
-          <a:stretch>
-            <a:fillRect/>
-          </a:stretch>
-        </p:blipFill>
-        <p:spPr>
-          <a:xfrm>
-            <a:off x="533386" y="883920"/>
-            <a:ext cx="11124921" cy="5364480"/>
-          </a:xfrm>
-          <a:prstGeom prst="rect">
-            <a:avLst/>
-          </a:prstGeom>
-        </p:spPr>
-      </p:pic>
+            <a:ln w="15240">
+              <a:solidFill>
+                <a:srgbClr val="DBC7AA"/>
+              </a:solidFill>
+            </a:ln>
+          </p:spPr>
+          <p:style>
+            <a:lnRef idx="1">
+              <a:schemeClr val="accent1"/>
+            </a:lnRef>
+            <a:fillRef idx="3">
+              <a:schemeClr val="accent1"/>
+            </a:fillRef>
+            <a:effectRef idx="2">
+              <a:schemeClr val="accent1"/>
+            </a:effectRef>
+            <a:fontRef idx="minor">
+              <a:schemeClr val="lt1"/>
+            </a:fontRef>
+          </p:style>
+          <p:txBody>
+            <a:bodyPr rtlCol="0" anchor="ctr"/>
+            <a:lstStyle/>
+            <a:p>
+              <a:pPr algn="ctr"/>
+              <a:endParaRPr/>
+            </a:p>
+          </p:txBody>
+        </p:sp>
+        <p:pic>
+          <p:nvPicPr>
+            <p:cNvPr id="4" name="Picture 3" descr="heldout_denver_map_focus.png"/>
+            <p:cNvPicPr>
+              <a:picLocks noChangeAspect="1"/>
+            </p:cNvPicPr>
+            <p:nvPr/>
+          </p:nvPicPr>
+          <p:blipFill>
+            <a:blip r:embed="rId2"/>
+            <a:stretch>
+              <a:fillRect/>
+            </a:stretch>
+          </p:blipFill>
+          <p:spPr>
+            <a:xfrm>
+              <a:off x="533386" y="883920"/>
+              <a:ext cx="11124921" cy="5364480"/>
+            </a:xfrm>
+            <a:prstGeom prst="rect">
+              <a:avLst/>
+            </a:prstGeom>
+          </p:spPr>
+        </p:pic>
+      </p:grpSp>
     </p:spTree>
   </p:cSld>
   <p:clrMapOvr>
@@ -4085,7 +4215,7 @@
 </file>
 
 <file path=ppt/slides/slide7.xml><?xml version="1.0" encoding="utf-8"?>
-<p:sld xmlns:a="http://schemas.openxmlformats.org/drawingml/2006/main" xmlns:p="http://schemas.openxmlformats.org/presentationml/2006/main" xmlns:r="http://schemas.openxmlformats.org/officeDocument/2006/relationships">
+<p:sld xmlns:a="http://schemas.openxmlformats.org/drawingml/2006/main" xmlns:r="http://schemas.openxmlformats.org/officeDocument/2006/relationships" xmlns:p="http://schemas.openxmlformats.org/presentationml/2006/main">
   <p:cSld>
     <p:bg>
       <p:bgPr>
@@ -4101,7 +4231,14 @@
         <p:cNvGrpSpPr/>
         <p:nvPr/>
       </p:nvGrpSpPr>
-      <p:grpSpPr/>
+      <p:grpSpPr>
+        <a:xfrm>
+          <a:off x="0" y="0"/>
+          <a:ext cx="0" cy="0"/>
+          <a:chOff x="0" y="0"/>
+          <a:chExt cx="0" cy="0"/>
+        </a:xfrm>
+      </p:grpSpPr>
       <p:sp>
         <p:nvSpPr>
           <p:cNvPr id="2" name="Oval 1"/>
@@ -4142,6 +4279,7 @@
           <a:lstStyle/>
           <a:p>
             <a:pPr algn="ctr"/>
+            <a:endParaRPr/>
           </a:p>
         </p:txBody>
       </p:sp>
@@ -4185,6 +4323,7 @@
           <a:lstStyle/>
           <a:p>
             <a:pPr algn="ctr"/>
+            <a:endParaRPr/>
           </a:p>
         </p:txBody>
       </p:sp>
@@ -4205,8 +4344,8 @@
           <a:noFill/>
         </p:spPr>
         <p:txBody>
-          <a:bodyPr wrap="square" lIns="50800" rIns="50800" tIns="50800" bIns="50800" anchor="t">
-            <a:normAutofit/>
+          <a:bodyPr wrap="square" lIns="50800" tIns="50800" rIns="50800" bIns="50800" anchor="t">
+            <a:normAutofit lnSpcReduction="10000"/>
           </a:bodyPr>
           <a:lstStyle/>
           <a:p>

</xml_diff>